<commit_message>
Commit from thinkpad on 25/05/2026, 22:08:31
</commit_message>
<xml_diff>
--- a/Entregas PhD/machine-unlearning.pptx
+++ b/Entregas PhD/machine-unlearning.pptx
@@ -11,6 +11,10 @@
     <p:sldId id="263" r:id="rId5"/>
     <p:sldId id="265" r:id="rId6"/>
     <p:sldId id="267" r:id="rId7"/>
+    <p:sldId id="269" r:id="rId8"/>
+    <p:sldId id="273" r:id="rId9"/>
+    <p:sldId id="271" r:id="rId10"/>
+    <p:sldId id="274" r:id="rId11"/>
   </p:sldIdLst>
   <p:sldSz cx="12192000" cy="6858000"/>
   <p:notesSz cx="6858000" cy="9144000"/>
@@ -3678,6 +3682,83 @@
 </p:sld>
 </file>
 
+<file path=ppt/slides/slide10.xml><?xml version="1.0" encoding="utf-8"?>
+<p:sld xmlns:a="http://schemas.openxmlformats.org/drawingml/2006/main" xmlns:r="http://schemas.openxmlformats.org/officeDocument/2006/relationships" xmlns:p="http://schemas.openxmlformats.org/presentationml/2006/main">
+  <p:cSld>
+    <p:spTree>
+      <p:nvGrpSpPr>
+        <p:cNvPr id="1" name=""/>
+        <p:cNvGrpSpPr/>
+        <p:nvPr/>
+      </p:nvGrpSpPr>
+      <p:grpSpPr>
+        <a:xfrm>
+          <a:off x="0" y="0"/>
+          <a:ext cx="0" cy="0"/>
+          <a:chOff x="0" y="0"/>
+          <a:chExt cx="0" cy="0"/>
+        </a:xfrm>
+      </p:grpSpPr>
+      <p:sp>
+        <p:nvSpPr>
+          <p:cNvPr id="2" name="Título 1">
+            <a:extLst>
+              <a:ext uri="{FF2B5EF4-FFF2-40B4-BE49-F238E27FC236}">
+                <a16:creationId xmlns:a16="http://schemas.microsoft.com/office/drawing/2014/main" id="{B20112FC-735B-DE07-E10D-52F9E62047B0}"/>
+              </a:ext>
+            </a:extLst>
+          </p:cNvPr>
+          <p:cNvSpPr>
+            <a:spLocks noGrp="1"/>
+          </p:cNvSpPr>
+          <p:nvPr>
+            <p:ph type="title"/>
+          </p:nvPr>
+        </p:nvSpPr>
+        <p:spPr>
+          <a:xfrm>
+            <a:off x="4760118" y="2766218"/>
+            <a:ext cx="2671763" cy="1325563"/>
+          </a:xfrm>
+        </p:spPr>
+        <p:txBody>
+          <a:bodyPr>
+            <a:normAutofit fontScale="90000"/>
+          </a:bodyPr>
+          <a:lstStyle/>
+          <a:p>
+            <a:pPr algn="ctr"/>
+            <a:r>
+              <a:rPr lang="pt-PT" b="1" dirty="0"/>
+              <a:t>Obrigado</a:t>
+            </a:r>
+            <a:br>
+              <a:rPr lang="pt-PT" b="1" dirty="0"/>
+            </a:br>
+            <a:br>
+              <a:rPr lang="pt-PT" b="1" dirty="0"/>
+            </a:br>
+            <a:r>
+              <a:rPr lang="pt-PT" sz="3600" dirty="0"/>
+              <a:t>Questões?</a:t>
+            </a:r>
+            <a:endParaRPr lang="pt-PT" dirty="0"/>
+          </a:p>
+        </p:txBody>
+      </p:sp>
+    </p:spTree>
+    <p:extLst>
+      <p:ext uri="{BB962C8B-B14F-4D97-AF65-F5344CB8AC3E}">
+        <p14:creationId xmlns:p14="http://schemas.microsoft.com/office/powerpoint/2010/main" val="1888870987"/>
+      </p:ext>
+    </p:extLst>
+  </p:cSld>
+  <p:clrMapOvr>
+    <a:masterClrMapping/>
+  </p:clrMapOvr>
+</p:sld>
+</file>
+
 <file path=ppt/slides/slide2.xml><?xml version="1.0" encoding="utf-8"?>
 <p:sld xmlns:a="http://schemas.openxmlformats.org/drawingml/2006/main" xmlns:r="http://schemas.openxmlformats.org/officeDocument/2006/relationships" xmlns:p="http://schemas.openxmlformats.org/presentationml/2006/main">
   <p:cSld>
@@ -4743,7 +4824,7 @@
             <a:avLst/>
           </a:prstGeom>
           <a:solidFill>
-            <a:srgbClr val="E97132"/>
+            <a:srgbClr val="B5511A"/>
           </a:solidFill>
           <a:ln w="19050" cap="flat" cmpd="sng" algn="ctr">
             <a:noFill/>
@@ -5400,7 +5481,7 @@
             <a:avLst/>
           </a:prstGeom>
           <a:solidFill>
-            <a:srgbClr val="E97132"/>
+            <a:srgbClr val="B5511A"/>
           </a:solidFill>
           <a:ln w="19050" cap="flat" cmpd="sng" algn="ctr">
             <a:noFill/>
@@ -5655,7 +5736,7 @@
           <a:p>
             <a:pPr algn="l"/>
             <a:r>
-              <a:rPr lang="pt-PT" sz="1400" b="1">
+              <a:rPr lang="pt-PT" sz="1400" b="1" dirty="0">
                 <a:solidFill>
                   <a:srgbClr val="196B24"/>
                 </a:solidFill>
@@ -6181,7 +6262,7 @@
             <a:avLst/>
           </a:prstGeom>
           <a:solidFill>
-            <a:srgbClr val="E97132"/>
+            <a:srgbClr val="B5511A"/>
           </a:solidFill>
           <a:ln w="19050" cap="flat" cmpd="sng" algn="ctr">
             <a:noFill/>
@@ -6991,7 +7072,7 @@
             <a:avLst/>
           </a:prstGeom>
           <a:solidFill>
-            <a:srgbClr val="E97132"/>
+            <a:srgbClr val="B5511A"/>
           </a:solidFill>
           <a:ln w="19050" cap="flat" cmpd="sng" algn="ctr">
             <a:noFill/>
@@ -7644,6 +7725,3067 @@
     <p:extLst>
       <p:ext uri="{BB962C8B-B14F-4D97-AF65-F5344CB8AC3E}">
         <p14:creationId xmlns:p14="http://schemas.microsoft.com/office/powerpoint/2010/main" val="2479857546"/>
+      </p:ext>
+    </p:extLst>
+  </p:cSld>
+  <p:clrMapOvr>
+    <a:masterClrMapping/>
+  </p:clrMapOvr>
+</p:sld>
+</file>
+
+<file path=ppt/slides/slide7.xml><?xml version="1.0" encoding="utf-8"?>
+<p:sld xmlns:a="http://schemas.openxmlformats.org/drawingml/2006/main" xmlns:r="http://schemas.openxmlformats.org/officeDocument/2006/relationships" xmlns:p="http://schemas.openxmlformats.org/presentationml/2006/main">
+  <p:cSld>
+    <p:spTree>
+      <p:nvGrpSpPr>
+        <p:cNvPr id="1" name=""/>
+        <p:cNvGrpSpPr/>
+        <p:nvPr/>
+      </p:nvGrpSpPr>
+      <p:grpSpPr>
+        <a:xfrm>
+          <a:off x="0" y="0"/>
+          <a:ext cx="0" cy="0"/>
+          <a:chOff x="0" y="0"/>
+          <a:chExt cx="0" cy="0"/>
+        </a:xfrm>
+      </p:grpSpPr>
+      <p:sp>
+        <p:nvSpPr>
+          <p:cNvPr id="2" name="Título 1">
+            <a:extLst>
+              <a:ext uri="{FF2B5EF4-FFF2-40B4-BE49-F238E27FC236}">
+                <a16:creationId xmlns:a16="http://schemas.microsoft.com/office/drawing/2014/main" id="{41511A50-9B6A-8B3B-CFC3-4B8D702C174E}"/>
+              </a:ext>
+            </a:extLst>
+          </p:cNvPr>
+          <p:cNvSpPr>
+            <a:spLocks noGrp="1"/>
+          </p:cNvSpPr>
+          <p:nvPr>
+            <p:ph type="title"/>
+          </p:nvPr>
+        </p:nvSpPr>
+        <p:spPr/>
+        <p:txBody>
+          <a:bodyPr/>
+          <a:lstStyle/>
+          <a:p>
+            <a:pPr algn="l">
+              <a:buNone/>
+            </a:pPr>
+            <a:r>
+              <a:rPr lang="pt-PT" sz="3200" b="1" dirty="0">
+                <a:solidFill>
+                  <a:srgbClr val="1A2332"/>
+                </a:solidFill>
+                <a:latin typeface="Georgia"/>
+              </a:rPr>
+              <a:t>Lacuna Central</a:t>
+            </a:r>
+          </a:p>
+        </p:txBody>
+      </p:sp>
+      <p:sp>
+        <p:nvSpPr>
+          <p:cNvPr id="4" name="CaixaDeTexto 3">
+            <a:extLst>
+              <a:ext uri="{FF2B5EF4-FFF2-40B4-BE49-F238E27FC236}">
+                <a16:creationId xmlns:a16="http://schemas.microsoft.com/office/drawing/2014/main" id="{73F63C08-D268-7F42-93DA-9815B2560F61}"/>
+              </a:ext>
+            </a:extLst>
+          </p:cNvPr>
+          <p:cNvSpPr txBox="1"/>
+          <p:nvPr/>
+        </p:nvSpPr>
+        <p:spPr>
+          <a:xfrm>
+            <a:off x="711200" y="1981200"/>
+            <a:ext cx="10769600" cy="711200"/>
+          </a:xfrm>
+          <a:prstGeom prst="rect">
+            <a:avLst/>
+          </a:prstGeom>
+          <a:noFill/>
+        </p:spPr>
+        <p:txBody>
+          <a:bodyPr rot="0" spcFirstLastPara="0" vertOverflow="overflow" horzOverflow="overflow" vert="horz" wrap="square" lIns="91440" tIns="45720" rIns="91440" bIns="45720" numCol="1" spcCol="0" rtlCol="0" fromWordArt="0" anchor="t" anchorCtr="0" forceAA="0" compatLnSpc="1">
+            <a:prstTxWarp prst="textNoShape">
+              <a:avLst/>
+            </a:prstTxWarp>
+            <a:spAutoFit/>
+          </a:bodyPr>
+          <a:lstStyle>
+            <a:defPPr>
+              <a:defRPr lang="pt-PT"/>
+            </a:defPPr>
+            <a:lvl1pPr>
+              <a:defRPr sz="1900" b="1">
+                <a:solidFill>
+                  <a:srgbClr val="1A2332"/>
+                </a:solidFill>
+                <a:latin typeface="Georgia"/>
+              </a:defRPr>
+            </a:lvl1pPr>
+          </a:lstStyle>
+          <a:p>
+            <a:r>
+              <a:rPr lang="pt-PT" dirty="0"/>
+              <a:t>Nenhum método atual satisfaz o envelope completo de restrições</a:t>
+            </a:r>
+          </a:p>
+        </p:txBody>
+      </p:sp>
+      <p:sp>
+        <p:nvSpPr>
+          <p:cNvPr id="5" name="Retângulo Arredondado 4">
+            <a:extLst>
+              <a:ext uri="{FF2B5EF4-FFF2-40B4-BE49-F238E27FC236}">
+                <a16:creationId xmlns:a16="http://schemas.microsoft.com/office/drawing/2014/main" id="{813B3A02-336F-E04A-A3F6-FA32BCFFA336}"/>
+              </a:ext>
+            </a:extLst>
+          </p:cNvPr>
+          <p:cNvSpPr/>
+          <p:nvPr/>
+        </p:nvSpPr>
+        <p:spPr>
+          <a:xfrm>
+            <a:off x="457200" y="3098800"/>
+            <a:ext cx="3556000" cy="2159000"/>
+          </a:xfrm>
+          <a:prstGeom prst="roundRect">
+            <a:avLst/>
+          </a:prstGeom>
+          <a:solidFill>
+            <a:srgbClr val="F0EBE3"/>
+          </a:solidFill>
+          <a:ln w="19050" cap="flat" cmpd="sng" algn="ctr">
+            <a:noFill/>
+            <a:prstDash val="solid"/>
+            <a:miter lim="800000"/>
+          </a:ln>
+        </p:spPr>
+        <p:style>
+          <a:lnRef idx="2">
+            <a:schemeClr val="accent1">
+              <a:shade val="15000"/>
+            </a:schemeClr>
+          </a:lnRef>
+          <a:fillRef idx="1">
+            <a:schemeClr val="accent1"/>
+          </a:fillRef>
+          <a:effectRef idx="0">
+            <a:schemeClr val="accent1"/>
+          </a:effectRef>
+          <a:fontRef idx="minor">
+            <a:schemeClr val="lt1"/>
+          </a:fontRef>
+        </p:style>
+        <p:txBody>
+          <a:bodyPr vertOverflow="clip" horzOverflow="clip" rtlCol="0" anchor="t"/>
+          <a:lstStyle/>
+          <a:p>
+            <a:pPr algn="l"/>
+            <a:endParaRPr lang="pt-PT"/>
+          </a:p>
+        </p:txBody>
+      </p:sp>
+      <p:sp>
+        <p:nvSpPr>
+          <p:cNvPr id="6" name="Retângulo 5">
+            <a:extLst>
+              <a:ext uri="{FF2B5EF4-FFF2-40B4-BE49-F238E27FC236}">
+                <a16:creationId xmlns:a16="http://schemas.microsoft.com/office/drawing/2014/main" id="{285AEF21-182B-744C-8AA0-4B2137A9F7B7}"/>
+              </a:ext>
+            </a:extLst>
+          </p:cNvPr>
+          <p:cNvSpPr/>
+          <p:nvPr/>
+        </p:nvSpPr>
+        <p:spPr>
+          <a:xfrm>
+            <a:off x="457200" y="3098800"/>
+            <a:ext cx="3556000" cy="50800"/>
+          </a:xfrm>
+          <a:prstGeom prst="rect">
+            <a:avLst/>
+          </a:prstGeom>
+          <a:solidFill>
+            <a:srgbClr val="156082"/>
+          </a:solidFill>
+          <a:ln w="19050" cap="flat" cmpd="sng" algn="ctr">
+            <a:noFill/>
+            <a:prstDash val="solid"/>
+            <a:miter lim="800000"/>
+          </a:ln>
+        </p:spPr>
+        <p:style>
+          <a:lnRef idx="2">
+            <a:schemeClr val="accent1">
+              <a:shade val="15000"/>
+            </a:schemeClr>
+          </a:lnRef>
+          <a:fillRef idx="1">
+            <a:schemeClr val="accent1"/>
+          </a:fillRef>
+          <a:effectRef idx="0">
+            <a:schemeClr val="accent1"/>
+          </a:effectRef>
+          <a:fontRef idx="minor">
+            <a:schemeClr val="lt1"/>
+          </a:fontRef>
+        </p:style>
+        <p:txBody>
+          <a:bodyPr vertOverflow="clip" horzOverflow="clip" rtlCol="0" anchor="t"/>
+          <a:lstStyle/>
+          <a:p>
+            <a:pPr algn="l"/>
+            <a:endParaRPr lang="pt-PT"/>
+          </a:p>
+        </p:txBody>
+      </p:sp>
+      <p:sp>
+        <p:nvSpPr>
+          <p:cNvPr id="7" name="CaixaDeTexto 6">
+            <a:extLst>
+              <a:ext uri="{FF2B5EF4-FFF2-40B4-BE49-F238E27FC236}">
+                <a16:creationId xmlns:a16="http://schemas.microsoft.com/office/drawing/2014/main" id="{34ED811E-44F9-BB4B-BEC5-3F8A63DE9E54}"/>
+              </a:ext>
+            </a:extLst>
+          </p:cNvPr>
+          <p:cNvSpPr txBox="1"/>
+          <p:nvPr/>
+        </p:nvSpPr>
+        <p:spPr>
+          <a:xfrm>
+            <a:off x="609600" y="3276600"/>
+            <a:ext cx="3251200" cy="279400"/>
+          </a:xfrm>
+          <a:prstGeom prst="rect">
+            <a:avLst/>
+          </a:prstGeom>
+          <a:noFill/>
+        </p:spPr>
+        <p:txBody>
+          <a:bodyPr vertOverflow="overflow" vert="horz" wrap="square" rtlCol="0" anchor="t">
+            <a:spAutoFit/>
+          </a:bodyPr>
+          <a:lstStyle/>
+          <a:p>
+            <a:pPr algn="l"/>
+            <a:r>
+              <a:rPr lang="pt-PT" sz="1300" b="1">
+                <a:solidFill>
+                  <a:srgbClr val="156082"/>
+                </a:solidFill>
+                <a:latin typeface="Calibri"/>
+                <a:cs typeface="Calibri"/>
+              </a:rPr>
+              <a:t>CLOUD-SIDE</a:t>
+            </a:r>
+          </a:p>
+        </p:txBody>
+      </p:sp>
+      <p:sp>
+        <p:nvSpPr>
+          <p:cNvPr id="8" name="CaixaDeTexto 7">
+            <a:extLst>
+              <a:ext uri="{FF2B5EF4-FFF2-40B4-BE49-F238E27FC236}">
+                <a16:creationId xmlns:a16="http://schemas.microsoft.com/office/drawing/2014/main" id="{CDB8897C-17F3-1C4D-8A08-F81EE2D24CD6}"/>
+              </a:ext>
+            </a:extLst>
+          </p:cNvPr>
+          <p:cNvSpPr txBox="1"/>
+          <p:nvPr/>
+        </p:nvSpPr>
+        <p:spPr>
+          <a:xfrm>
+            <a:off x="609600" y="3632200"/>
+            <a:ext cx="3251200" cy="609600"/>
+          </a:xfrm>
+          <a:prstGeom prst="rect">
+            <a:avLst/>
+          </a:prstGeom>
+          <a:noFill/>
+        </p:spPr>
+        <p:txBody>
+          <a:bodyPr vertOverflow="overflow" vert="horz" wrap="square" rtlCol="0" anchor="t">
+            <a:spAutoFit/>
+          </a:bodyPr>
+          <a:lstStyle/>
+          <a:p>
+            <a:pPr algn="l"/>
+            <a:r>
+              <a:rPr lang="pt-PT" sz="1300" dirty="0">
+                <a:solidFill>
+                  <a:srgbClr val="2E3B4E"/>
+                </a:solidFill>
+                <a:latin typeface="Calibri"/>
+                <a:cs typeface="Calibri"/>
+              </a:rPr>
+              <a:t>Aborda: SISA, correções de gradiente, destilação</a:t>
+            </a:r>
+          </a:p>
+        </p:txBody>
+      </p:sp>
+      <p:sp>
+        <p:nvSpPr>
+          <p:cNvPr id="9" name="CaixaDeTexto 8">
+            <a:extLst>
+              <a:ext uri="{FF2B5EF4-FFF2-40B4-BE49-F238E27FC236}">
+                <a16:creationId xmlns:a16="http://schemas.microsoft.com/office/drawing/2014/main" id="{0DFB537D-B5CD-FC46-A115-09FC7C22B619}"/>
+              </a:ext>
+            </a:extLst>
+          </p:cNvPr>
+          <p:cNvSpPr txBox="1"/>
+          <p:nvPr/>
+        </p:nvSpPr>
+        <p:spPr>
+          <a:xfrm>
+            <a:off x="609600" y="4368800"/>
+            <a:ext cx="3251200" cy="711200"/>
+          </a:xfrm>
+          <a:prstGeom prst="rect">
+            <a:avLst/>
+          </a:prstGeom>
+          <a:noFill/>
+        </p:spPr>
+        <p:txBody>
+          <a:bodyPr vertOverflow="overflow" vert="horz" wrap="square" rtlCol="0" anchor="t">
+            <a:spAutoFit/>
+          </a:bodyPr>
+          <a:lstStyle/>
+          <a:p>
+            <a:pPr algn="l"/>
+            <a:r>
+              <a:rPr lang="pt-PT" sz="1300">
+                <a:solidFill>
+                  <a:srgbClr val="8B1A1A"/>
+                </a:solidFill>
+                <a:latin typeface="Calibri"/>
+                <a:cs typeface="Calibri"/>
+              </a:rPr>
+              <a:t>Ignora: Limites de recursos edge, federação, replicação multi-camada</a:t>
+            </a:r>
+          </a:p>
+        </p:txBody>
+      </p:sp>
+      <p:sp>
+        <p:nvSpPr>
+          <p:cNvPr id="10" name="Retângulo Arredondado 9">
+            <a:extLst>
+              <a:ext uri="{FF2B5EF4-FFF2-40B4-BE49-F238E27FC236}">
+                <a16:creationId xmlns:a16="http://schemas.microsoft.com/office/drawing/2014/main" id="{D35E0D7F-D128-F042-BDB4-AF746B64CA1E}"/>
+              </a:ext>
+            </a:extLst>
+          </p:cNvPr>
+          <p:cNvSpPr/>
+          <p:nvPr/>
+        </p:nvSpPr>
+        <p:spPr>
+          <a:xfrm>
+            <a:off x="4318000" y="3098800"/>
+            <a:ext cx="3556000" cy="2159000"/>
+          </a:xfrm>
+          <a:prstGeom prst="roundRect">
+            <a:avLst/>
+          </a:prstGeom>
+          <a:solidFill>
+            <a:srgbClr val="F0EBE3"/>
+          </a:solidFill>
+          <a:ln w="19050" cap="flat" cmpd="sng" algn="ctr">
+            <a:noFill/>
+            <a:prstDash val="solid"/>
+            <a:miter lim="800000"/>
+          </a:ln>
+        </p:spPr>
+        <p:style>
+          <a:lnRef idx="2">
+            <a:schemeClr val="accent1">
+              <a:shade val="15000"/>
+            </a:schemeClr>
+          </a:lnRef>
+          <a:fillRef idx="1">
+            <a:schemeClr val="accent1"/>
+          </a:fillRef>
+          <a:effectRef idx="0">
+            <a:schemeClr val="accent1"/>
+          </a:effectRef>
+          <a:fontRef idx="minor">
+            <a:schemeClr val="lt1"/>
+          </a:fontRef>
+        </p:style>
+        <p:txBody>
+          <a:bodyPr vertOverflow="clip" horzOverflow="clip" rtlCol="0" anchor="t"/>
+          <a:lstStyle/>
+          <a:p>
+            <a:pPr algn="l"/>
+            <a:endParaRPr lang="pt-PT"/>
+          </a:p>
+        </p:txBody>
+      </p:sp>
+      <p:sp>
+        <p:nvSpPr>
+          <p:cNvPr id="11" name="Retângulo 10">
+            <a:extLst>
+              <a:ext uri="{FF2B5EF4-FFF2-40B4-BE49-F238E27FC236}">
+                <a16:creationId xmlns:a16="http://schemas.microsoft.com/office/drawing/2014/main" id="{81CC8072-9731-7A40-B478-17497E9FD07E}"/>
+              </a:ext>
+            </a:extLst>
+          </p:cNvPr>
+          <p:cNvSpPr/>
+          <p:nvPr/>
+        </p:nvSpPr>
+        <p:spPr>
+          <a:xfrm>
+            <a:off x="4318000" y="3098800"/>
+            <a:ext cx="3556000" cy="50800"/>
+          </a:xfrm>
+          <a:prstGeom prst="rect">
+            <a:avLst/>
+          </a:prstGeom>
+          <a:solidFill>
+            <a:srgbClr val="B5511A"/>
+          </a:solidFill>
+          <a:ln w="19050" cap="flat" cmpd="sng" algn="ctr">
+            <a:noFill/>
+            <a:prstDash val="solid"/>
+            <a:miter lim="800000"/>
+          </a:ln>
+        </p:spPr>
+        <p:style>
+          <a:lnRef idx="2">
+            <a:schemeClr val="accent1">
+              <a:shade val="15000"/>
+            </a:schemeClr>
+          </a:lnRef>
+          <a:fillRef idx="1">
+            <a:schemeClr val="accent1"/>
+          </a:fillRef>
+          <a:effectRef idx="0">
+            <a:schemeClr val="accent1"/>
+          </a:effectRef>
+          <a:fontRef idx="minor">
+            <a:schemeClr val="lt1"/>
+          </a:fontRef>
+        </p:style>
+        <p:txBody>
+          <a:bodyPr vertOverflow="clip" horzOverflow="clip" rtlCol="0" anchor="t"/>
+          <a:lstStyle/>
+          <a:p>
+            <a:pPr algn="l"/>
+            <a:endParaRPr lang="pt-PT"/>
+          </a:p>
+        </p:txBody>
+      </p:sp>
+      <p:sp>
+        <p:nvSpPr>
+          <p:cNvPr id="12" name="CaixaDeTexto 11">
+            <a:extLst>
+              <a:ext uri="{FF2B5EF4-FFF2-40B4-BE49-F238E27FC236}">
+                <a16:creationId xmlns:a16="http://schemas.microsoft.com/office/drawing/2014/main" id="{C6DBE496-3740-FB48-8B07-B288BA369590}"/>
+              </a:ext>
+            </a:extLst>
+          </p:cNvPr>
+          <p:cNvSpPr txBox="1"/>
+          <p:nvPr/>
+        </p:nvSpPr>
+        <p:spPr>
+          <a:xfrm>
+            <a:off x="4470400" y="3276600"/>
+            <a:ext cx="3251200" cy="279400"/>
+          </a:xfrm>
+          <a:prstGeom prst="rect">
+            <a:avLst/>
+          </a:prstGeom>
+          <a:noFill/>
+        </p:spPr>
+        <p:txBody>
+          <a:bodyPr vertOverflow="overflow" vert="horz" wrap="square" rtlCol="0" anchor="t">
+            <a:spAutoFit/>
+          </a:bodyPr>
+          <a:lstStyle/>
+          <a:p>
+            <a:pPr algn="l"/>
+            <a:r>
+              <a:rPr lang="pt-PT" sz="1300" b="1">
+                <a:solidFill>
+                  <a:srgbClr val="E97132"/>
+                </a:solidFill>
+                <a:latin typeface="Calibri"/>
+                <a:cs typeface="Calibri"/>
+              </a:rPr>
+              <a:t>EDGE-SIDE</a:t>
+            </a:r>
+          </a:p>
+        </p:txBody>
+      </p:sp>
+      <p:sp>
+        <p:nvSpPr>
+          <p:cNvPr id="13" name="CaixaDeTexto 12">
+            <a:extLst>
+              <a:ext uri="{FF2B5EF4-FFF2-40B4-BE49-F238E27FC236}">
+                <a16:creationId xmlns:a16="http://schemas.microsoft.com/office/drawing/2014/main" id="{88AA3A50-3542-6740-8E62-D628AD9B3E78}"/>
+              </a:ext>
+            </a:extLst>
+          </p:cNvPr>
+          <p:cNvSpPr txBox="1"/>
+          <p:nvPr/>
+        </p:nvSpPr>
+        <p:spPr>
+          <a:xfrm>
+            <a:off x="4470400" y="3632200"/>
+            <a:ext cx="3251200" cy="609600"/>
+          </a:xfrm>
+          <a:prstGeom prst="rect">
+            <a:avLst/>
+          </a:prstGeom>
+          <a:noFill/>
+        </p:spPr>
+        <p:txBody>
+          <a:bodyPr vertOverflow="overflow" vert="horz" wrap="square" rtlCol="0" anchor="t">
+            <a:spAutoFit/>
+          </a:bodyPr>
+          <a:lstStyle/>
+          <a:p>
+            <a:pPr algn="l"/>
+            <a:r>
+              <a:rPr lang="pt-PT" sz="1300">
+                <a:solidFill>
+                  <a:srgbClr val="2E3B4E"/>
+                </a:solidFill>
+                <a:latin typeface="Calibri"/>
+                <a:cs typeface="Calibri"/>
+              </a:rPr>
+              <a:t>Aborda: Gradient ascent, pruning, fine-tuning local</a:t>
+            </a:r>
+          </a:p>
+        </p:txBody>
+      </p:sp>
+      <p:sp>
+        <p:nvSpPr>
+          <p:cNvPr id="14" name="CaixaDeTexto 13">
+            <a:extLst>
+              <a:ext uri="{FF2B5EF4-FFF2-40B4-BE49-F238E27FC236}">
+                <a16:creationId xmlns:a16="http://schemas.microsoft.com/office/drawing/2014/main" id="{AEC05898-F06C-864A-954B-BDDCDABE7CCC}"/>
+              </a:ext>
+            </a:extLst>
+          </p:cNvPr>
+          <p:cNvSpPr txBox="1"/>
+          <p:nvPr/>
+        </p:nvSpPr>
+        <p:spPr>
+          <a:xfrm>
+            <a:off x="4470400" y="4368800"/>
+            <a:ext cx="3251200" cy="711200"/>
+          </a:xfrm>
+          <a:prstGeom prst="rect">
+            <a:avLst/>
+          </a:prstGeom>
+          <a:noFill/>
+        </p:spPr>
+        <p:txBody>
+          <a:bodyPr vertOverflow="overflow" vert="horz" wrap="square" rtlCol="0" anchor="t">
+            <a:spAutoFit/>
+          </a:bodyPr>
+          <a:lstStyle/>
+          <a:p>
+            <a:pPr algn="l"/>
+            <a:r>
+              <a:rPr lang="pt-PT" sz="1300">
+                <a:solidFill>
+                  <a:srgbClr val="8B1A1A"/>
+                </a:solidFill>
+                <a:latin typeface="Calibri"/>
+                <a:cs typeface="Calibri"/>
+              </a:rPr>
+              <a:t>Ignora: Multi-tenancy, coordenação entre camadas, modelos partilhados</a:t>
+            </a:r>
+          </a:p>
+        </p:txBody>
+      </p:sp>
+      <p:sp>
+        <p:nvSpPr>
+          <p:cNvPr id="15" name="Retângulo Arredondado 14">
+            <a:extLst>
+              <a:ext uri="{FF2B5EF4-FFF2-40B4-BE49-F238E27FC236}">
+                <a16:creationId xmlns:a16="http://schemas.microsoft.com/office/drawing/2014/main" id="{1DA7E1C0-BB64-A040-A6AE-A8371F92BA2A}"/>
+              </a:ext>
+            </a:extLst>
+          </p:cNvPr>
+          <p:cNvSpPr/>
+          <p:nvPr/>
+        </p:nvSpPr>
+        <p:spPr>
+          <a:xfrm>
+            <a:off x="8178800" y="3098800"/>
+            <a:ext cx="3556000" cy="2159000"/>
+          </a:xfrm>
+          <a:prstGeom prst="roundRect">
+            <a:avLst/>
+          </a:prstGeom>
+          <a:solidFill>
+            <a:srgbClr val="F0EBE3"/>
+          </a:solidFill>
+          <a:ln w="19050" cap="flat" cmpd="sng" algn="ctr">
+            <a:noFill/>
+            <a:prstDash val="solid"/>
+            <a:miter lim="800000"/>
+          </a:ln>
+        </p:spPr>
+        <p:style>
+          <a:lnRef idx="2">
+            <a:schemeClr val="accent1">
+              <a:shade val="15000"/>
+            </a:schemeClr>
+          </a:lnRef>
+          <a:fillRef idx="1">
+            <a:schemeClr val="accent1"/>
+          </a:fillRef>
+          <a:effectRef idx="0">
+            <a:schemeClr val="accent1"/>
+          </a:effectRef>
+          <a:fontRef idx="minor">
+            <a:schemeClr val="lt1"/>
+          </a:fontRef>
+        </p:style>
+        <p:txBody>
+          <a:bodyPr vertOverflow="clip" horzOverflow="clip" rtlCol="0" anchor="t"/>
+          <a:lstStyle/>
+          <a:p>
+            <a:pPr algn="l"/>
+            <a:endParaRPr lang="pt-PT"/>
+          </a:p>
+        </p:txBody>
+      </p:sp>
+      <p:sp>
+        <p:nvSpPr>
+          <p:cNvPr id="16" name="Retângulo 15">
+            <a:extLst>
+              <a:ext uri="{FF2B5EF4-FFF2-40B4-BE49-F238E27FC236}">
+                <a16:creationId xmlns:a16="http://schemas.microsoft.com/office/drawing/2014/main" id="{EC4D5D16-511B-9C49-995F-64F0E0D37797}"/>
+              </a:ext>
+            </a:extLst>
+          </p:cNvPr>
+          <p:cNvSpPr/>
+          <p:nvPr/>
+        </p:nvSpPr>
+        <p:spPr>
+          <a:xfrm>
+            <a:off x="8178800" y="3098800"/>
+            <a:ext cx="3556000" cy="50800"/>
+          </a:xfrm>
+          <a:prstGeom prst="rect">
+            <a:avLst/>
+          </a:prstGeom>
+          <a:solidFill>
+            <a:srgbClr val="196B24"/>
+          </a:solidFill>
+          <a:ln w="19050" cap="flat" cmpd="sng" algn="ctr">
+            <a:noFill/>
+            <a:prstDash val="solid"/>
+            <a:miter lim="800000"/>
+          </a:ln>
+        </p:spPr>
+        <p:style>
+          <a:lnRef idx="2">
+            <a:schemeClr val="accent1">
+              <a:shade val="15000"/>
+            </a:schemeClr>
+          </a:lnRef>
+          <a:fillRef idx="1">
+            <a:schemeClr val="accent1"/>
+          </a:fillRef>
+          <a:effectRef idx="0">
+            <a:schemeClr val="accent1"/>
+          </a:effectRef>
+          <a:fontRef idx="minor">
+            <a:schemeClr val="lt1"/>
+          </a:fontRef>
+        </p:style>
+        <p:txBody>
+          <a:bodyPr vertOverflow="clip" horzOverflow="clip" rtlCol="0" anchor="t"/>
+          <a:lstStyle/>
+          <a:p>
+            <a:pPr algn="l"/>
+            <a:endParaRPr lang="pt-PT"/>
+          </a:p>
+        </p:txBody>
+      </p:sp>
+      <p:sp>
+        <p:nvSpPr>
+          <p:cNvPr id="17" name="CaixaDeTexto 16">
+            <a:extLst>
+              <a:ext uri="{FF2B5EF4-FFF2-40B4-BE49-F238E27FC236}">
+                <a16:creationId xmlns:a16="http://schemas.microsoft.com/office/drawing/2014/main" id="{6A5C0CE0-B3D4-F944-A628-FE8DF1F21C28}"/>
+              </a:ext>
+            </a:extLst>
+          </p:cNvPr>
+          <p:cNvSpPr txBox="1"/>
+          <p:nvPr/>
+        </p:nvSpPr>
+        <p:spPr>
+          <a:xfrm>
+            <a:off x="8331200" y="3276600"/>
+            <a:ext cx="3251200" cy="279400"/>
+          </a:xfrm>
+          <a:prstGeom prst="rect">
+            <a:avLst/>
+          </a:prstGeom>
+          <a:noFill/>
+        </p:spPr>
+        <p:txBody>
+          <a:bodyPr vertOverflow="overflow" vert="horz" wrap="square" rtlCol="0" anchor="t">
+            <a:spAutoFit/>
+          </a:bodyPr>
+          <a:lstStyle/>
+          <a:p>
+            <a:pPr algn="l"/>
+            <a:r>
+              <a:rPr lang="pt-PT" sz="1300" b="1">
+                <a:solidFill>
+                  <a:srgbClr val="196B24"/>
+                </a:solidFill>
+                <a:latin typeface="Calibri"/>
+                <a:cs typeface="Calibri"/>
+              </a:rPr>
+              <a:t>FEDERADO</a:t>
+            </a:r>
+          </a:p>
+        </p:txBody>
+      </p:sp>
+      <p:sp>
+        <p:nvSpPr>
+          <p:cNvPr id="18" name="CaixaDeTexto 17">
+            <a:extLst>
+              <a:ext uri="{FF2B5EF4-FFF2-40B4-BE49-F238E27FC236}">
+                <a16:creationId xmlns:a16="http://schemas.microsoft.com/office/drawing/2014/main" id="{23314D25-9FEF-4449-9E76-45C173BD16E8}"/>
+              </a:ext>
+            </a:extLst>
+          </p:cNvPr>
+          <p:cNvSpPr txBox="1"/>
+          <p:nvPr/>
+        </p:nvSpPr>
+        <p:spPr>
+          <a:xfrm>
+            <a:off x="8331200" y="3632200"/>
+            <a:ext cx="3251200" cy="609600"/>
+          </a:xfrm>
+          <a:prstGeom prst="rect">
+            <a:avLst/>
+          </a:prstGeom>
+          <a:noFill/>
+        </p:spPr>
+        <p:txBody>
+          <a:bodyPr vertOverflow="overflow" vert="horz" wrap="square" rtlCol="0" anchor="t">
+            <a:spAutoFit/>
+          </a:bodyPr>
+          <a:lstStyle/>
+          <a:p>
+            <a:pPr algn="l"/>
+            <a:r>
+              <a:rPr lang="pt-PT" sz="1300">
+                <a:solidFill>
+                  <a:srgbClr val="2E3B4E"/>
+                </a:solidFill>
+                <a:latin typeface="Calibri"/>
+                <a:cs typeface="Calibri"/>
+              </a:rPr>
+              <a:t>Aborda: FedEraser, rollback de gradientes, SISA federado</a:t>
+            </a:r>
+          </a:p>
+        </p:txBody>
+      </p:sp>
+      <p:sp>
+        <p:nvSpPr>
+          <p:cNvPr id="19" name="CaixaDeTexto 18">
+            <a:extLst>
+              <a:ext uri="{FF2B5EF4-FFF2-40B4-BE49-F238E27FC236}">
+                <a16:creationId xmlns:a16="http://schemas.microsoft.com/office/drawing/2014/main" id="{3EB8A28B-530F-4B4C-A326-8660C6E9052C}"/>
+              </a:ext>
+            </a:extLst>
+          </p:cNvPr>
+          <p:cNvSpPr txBox="1"/>
+          <p:nvPr/>
+        </p:nvSpPr>
+        <p:spPr>
+          <a:xfrm>
+            <a:off x="8331200" y="4368800"/>
+            <a:ext cx="3251200" cy="711200"/>
+          </a:xfrm>
+          <a:prstGeom prst="rect">
+            <a:avLst/>
+          </a:prstGeom>
+          <a:noFill/>
+        </p:spPr>
+        <p:txBody>
+          <a:bodyPr vertOverflow="overflow" vert="horz" wrap="square" rtlCol="0" anchor="t">
+            <a:spAutoFit/>
+          </a:bodyPr>
+          <a:lstStyle/>
+          <a:p>
+            <a:pPr algn="l"/>
+            <a:r>
+              <a:rPr lang="pt-PT" sz="1300">
+                <a:solidFill>
+                  <a:srgbClr val="8B1A1A"/>
+                </a:solidFill>
+                <a:latin typeface="Calibri"/>
+                <a:cs typeface="Calibri"/>
+              </a:rPr>
+              <a:t>Ignora: Garantia de erasure enfraquecida, clientes offline, sem certificação</a:t>
+            </a:r>
+          </a:p>
+        </p:txBody>
+      </p:sp>
+      <p:sp>
+        <p:nvSpPr>
+          <p:cNvPr id="20" name="CaixaDeTexto 19">
+            <a:extLst>
+              <a:ext uri="{FF2B5EF4-FFF2-40B4-BE49-F238E27FC236}">
+                <a16:creationId xmlns:a16="http://schemas.microsoft.com/office/drawing/2014/main" id="{35ADD662-1CC8-7045-8564-D8ACBBBE3DA6}"/>
+              </a:ext>
+            </a:extLst>
+          </p:cNvPr>
+          <p:cNvSpPr txBox="1"/>
+          <p:nvPr/>
+        </p:nvSpPr>
+        <p:spPr>
+          <a:xfrm>
+            <a:off x="711200" y="2365921"/>
+            <a:ext cx="5384800" cy="523220"/>
+          </a:xfrm>
+          <a:prstGeom prst="rect">
+            <a:avLst/>
+          </a:prstGeom>
+          <a:noFill/>
+        </p:spPr>
+        <p:txBody>
+          <a:bodyPr rot="0" spcFirstLastPara="0" vertOverflow="overflow" horzOverflow="overflow" vert="horz" wrap="square" lIns="91440" tIns="45720" rIns="91440" bIns="45720" numCol="1" spcCol="0" rtlCol="0" fromWordArt="0" anchor="t" anchorCtr="0" forceAA="0" compatLnSpc="1">
+            <a:prstTxWarp prst="textNoShape">
+              <a:avLst/>
+            </a:prstTxWarp>
+            <a:spAutoFit/>
+          </a:bodyPr>
+          <a:lstStyle>
+            <a:defPPr>
+              <a:defRPr lang="pt-PT"/>
+            </a:defPPr>
+            <a:lvl1pPr>
+              <a:defRPr sz="1400">
+                <a:solidFill>
+                  <a:srgbClr val="1A2332"/>
+                </a:solidFill>
+                <a:latin typeface="Calibri"/>
+                <a:cs typeface="Calibri"/>
+              </a:defRPr>
+            </a:lvl1pPr>
+          </a:lstStyle>
+          <a:p>
+            <a:r>
+              <a:rPr lang="pt-PT" dirty="0"/>
+              <a:t>não existe </a:t>
+            </a:r>
+            <a:r>
+              <a:rPr lang="pt-PT" dirty="0" err="1"/>
+              <a:t>benchmark</a:t>
+            </a:r>
+            <a:r>
+              <a:rPr lang="pt-PT" dirty="0"/>
+              <a:t> standard — cada estudo usa métricas, </a:t>
+            </a:r>
+            <a:r>
+              <a:rPr lang="pt-PT" dirty="0" err="1"/>
+              <a:t>datasets</a:t>
+            </a:r>
+            <a:r>
+              <a:rPr lang="pt-PT" dirty="0"/>
+              <a:t> e modelos de ameaça distintos.</a:t>
+            </a:r>
+          </a:p>
+        </p:txBody>
+      </p:sp>
+    </p:spTree>
+    <p:extLst>
+      <p:ext uri="{BB962C8B-B14F-4D97-AF65-F5344CB8AC3E}">
+        <p14:creationId xmlns:p14="http://schemas.microsoft.com/office/powerpoint/2010/main" val="2608838854"/>
+      </p:ext>
+    </p:extLst>
+  </p:cSld>
+  <p:clrMapOvr>
+    <a:masterClrMapping/>
+  </p:clrMapOvr>
+</p:sld>
+</file>
+
+<file path=ppt/slides/slide8.xml><?xml version="1.0" encoding="utf-8"?>
+<p:sld xmlns:a="http://schemas.openxmlformats.org/drawingml/2006/main" xmlns:r="http://schemas.openxmlformats.org/officeDocument/2006/relationships" xmlns:p="http://schemas.openxmlformats.org/presentationml/2006/main">
+  <p:cSld>
+    <p:spTree>
+      <p:nvGrpSpPr>
+        <p:cNvPr id="1" name=""/>
+        <p:cNvGrpSpPr/>
+        <p:nvPr/>
+      </p:nvGrpSpPr>
+      <p:grpSpPr>
+        <a:xfrm>
+          <a:off x="0" y="0"/>
+          <a:ext cx="0" cy="0"/>
+          <a:chOff x="0" y="0"/>
+          <a:chExt cx="0" cy="0"/>
+        </a:xfrm>
+      </p:grpSpPr>
+      <p:sp>
+        <p:nvSpPr>
+          <p:cNvPr id="2" name="Título 1">
+            <a:extLst>
+              <a:ext uri="{FF2B5EF4-FFF2-40B4-BE49-F238E27FC236}">
+                <a16:creationId xmlns:a16="http://schemas.microsoft.com/office/drawing/2014/main" id="{92012911-82BC-6872-3E14-EDE88C23BA90}"/>
+              </a:ext>
+            </a:extLst>
+          </p:cNvPr>
+          <p:cNvSpPr>
+            <a:spLocks noGrp="1"/>
+          </p:cNvSpPr>
+          <p:nvPr>
+            <p:ph type="title"/>
+          </p:nvPr>
+        </p:nvSpPr>
+        <p:spPr/>
+        <p:txBody>
+          <a:bodyPr/>
+          <a:lstStyle/>
+          <a:p>
+            <a:pPr algn="l">
+              <a:buNone/>
+            </a:pPr>
+            <a:r>
+              <a:rPr lang="pt-PT" sz="3200" b="1" dirty="0">
+                <a:solidFill>
+                  <a:srgbClr val="1A2332"/>
+                </a:solidFill>
+                <a:latin typeface="Georgia"/>
+              </a:rPr>
+              <a:t>Direções de Investigação</a:t>
+            </a:r>
+          </a:p>
+        </p:txBody>
+      </p:sp>
+      <p:sp>
+        <p:nvSpPr>
+          <p:cNvPr id="3" name="Retângulo Arredondado 2">
+            <a:extLst>
+              <a:ext uri="{FF2B5EF4-FFF2-40B4-BE49-F238E27FC236}">
+                <a16:creationId xmlns:a16="http://schemas.microsoft.com/office/drawing/2014/main" id="{7D1CE6D4-71C4-9C42-BDFC-0EA3A6E33AED}"/>
+              </a:ext>
+            </a:extLst>
+          </p:cNvPr>
+          <p:cNvSpPr/>
+          <p:nvPr/>
+        </p:nvSpPr>
+        <p:spPr>
+          <a:xfrm>
+            <a:off x="457200" y="1905000"/>
+            <a:ext cx="5334000" cy="457200"/>
+          </a:xfrm>
+          <a:prstGeom prst="roundRect">
+            <a:avLst/>
+          </a:prstGeom>
+          <a:solidFill>
+            <a:srgbClr val="156082"/>
+          </a:solidFill>
+          <a:ln w="19050" cap="flat" cmpd="sng" algn="ctr">
+            <a:noFill/>
+            <a:prstDash val="solid"/>
+            <a:miter lim="800000"/>
+          </a:ln>
+        </p:spPr>
+        <p:style>
+          <a:lnRef idx="2">
+            <a:schemeClr val="accent1">
+              <a:shade val="15000"/>
+            </a:schemeClr>
+          </a:lnRef>
+          <a:fillRef idx="1">
+            <a:schemeClr val="accent1"/>
+          </a:fillRef>
+          <a:effectRef idx="0">
+            <a:schemeClr val="accent1"/>
+          </a:effectRef>
+          <a:fontRef idx="minor">
+            <a:schemeClr val="lt1"/>
+          </a:fontRef>
+        </p:style>
+        <p:txBody>
+          <a:bodyPr vertOverflow="clip" horzOverflow="clip" wrap="none" rtlCol="0" anchor="ctr" anchorCtr="0">
+            <a:noAutofit/>
+          </a:bodyPr>
+          <a:lstStyle/>
+          <a:p>
+            <a:pPr algn="l"/>
+            <a:r>
+              <a:rPr lang="pt-PT" sz="1400" b="1">
+                <a:solidFill>
+                  <a:srgbClr val="FFFFFF"/>
+                </a:solidFill>
+                <a:latin typeface="Calibri"/>
+                <a:cs typeface="Calibri"/>
+              </a:rPr>
+              <a:t>ESCALABILIDADE NO EDGE</a:t>
+            </a:r>
+          </a:p>
+        </p:txBody>
+      </p:sp>
+      <p:sp>
+        <p:nvSpPr>
+          <p:cNvPr id="4" name="Oval 3">
+            <a:extLst>
+              <a:ext uri="{FF2B5EF4-FFF2-40B4-BE49-F238E27FC236}">
+                <a16:creationId xmlns:a16="http://schemas.microsoft.com/office/drawing/2014/main" id="{3F90BDEB-842A-7447-9EC7-BD08DF512EBF}"/>
+              </a:ext>
+            </a:extLst>
+          </p:cNvPr>
+          <p:cNvSpPr/>
+          <p:nvPr/>
+        </p:nvSpPr>
+        <p:spPr>
+          <a:xfrm>
+            <a:off x="508000" y="2565400"/>
+            <a:ext cx="101600" cy="101600"/>
+          </a:xfrm>
+          <a:prstGeom prst="ellipse">
+            <a:avLst/>
+          </a:prstGeom>
+          <a:solidFill>
+            <a:srgbClr val="156082"/>
+          </a:solidFill>
+          <a:ln w="19050" cap="flat" cmpd="sng" algn="ctr">
+            <a:noFill/>
+            <a:prstDash val="solid"/>
+            <a:miter lim="800000"/>
+          </a:ln>
+        </p:spPr>
+        <p:style>
+          <a:lnRef idx="2">
+            <a:schemeClr val="accent1">
+              <a:shade val="15000"/>
+            </a:schemeClr>
+          </a:lnRef>
+          <a:fillRef idx="1">
+            <a:schemeClr val="accent1"/>
+          </a:fillRef>
+          <a:effectRef idx="0">
+            <a:schemeClr val="accent1"/>
+          </a:effectRef>
+          <a:fontRef idx="minor">
+            <a:schemeClr val="lt1"/>
+          </a:fontRef>
+        </p:style>
+        <p:txBody>
+          <a:bodyPr vertOverflow="clip" horzOverflow="clip" rtlCol="0" anchor="t"/>
+          <a:lstStyle/>
+          <a:p>
+            <a:pPr algn="l"/>
+            <a:endParaRPr lang="pt-PT"/>
+          </a:p>
+        </p:txBody>
+      </p:sp>
+      <p:sp>
+        <p:nvSpPr>
+          <p:cNvPr id="5" name="CaixaDeTexto 4">
+            <a:extLst>
+              <a:ext uri="{FF2B5EF4-FFF2-40B4-BE49-F238E27FC236}">
+                <a16:creationId xmlns:a16="http://schemas.microsoft.com/office/drawing/2014/main" id="{C5F96323-26F3-154E-8893-F751AAC2F7E1}"/>
+              </a:ext>
+            </a:extLst>
+          </p:cNvPr>
+          <p:cNvSpPr txBox="1"/>
+          <p:nvPr/>
+        </p:nvSpPr>
+        <p:spPr>
+          <a:xfrm>
+            <a:off x="711200" y="2489200"/>
+            <a:ext cx="5029200" cy="254000"/>
+          </a:xfrm>
+          <a:prstGeom prst="rect">
+            <a:avLst/>
+          </a:prstGeom>
+          <a:noFill/>
+        </p:spPr>
+        <p:txBody>
+          <a:bodyPr vertOverflow="overflow" vert="horz" wrap="square" rtlCol="0" anchor="t">
+            <a:spAutoFit/>
+          </a:bodyPr>
+          <a:lstStyle/>
+          <a:p>
+            <a:pPr algn="l"/>
+            <a:r>
+              <a:rPr lang="pt-PT" sz="1400" b="1">
+                <a:solidFill>
+                  <a:srgbClr val="1A2332"/>
+                </a:solidFill>
+                <a:latin typeface="Calibri"/>
+                <a:cs typeface="Calibri"/>
+              </a:rPr>
+              <a:t>Atualizações esparsas</a:t>
+            </a:r>
+          </a:p>
+        </p:txBody>
+      </p:sp>
+      <p:sp>
+        <p:nvSpPr>
+          <p:cNvPr id="6" name="CaixaDeTexto 5">
+            <a:extLst>
+              <a:ext uri="{FF2B5EF4-FFF2-40B4-BE49-F238E27FC236}">
+                <a16:creationId xmlns:a16="http://schemas.microsoft.com/office/drawing/2014/main" id="{28C9D78B-35FC-A74A-B525-F1735188B3EC}"/>
+              </a:ext>
+            </a:extLst>
+          </p:cNvPr>
+          <p:cNvSpPr txBox="1"/>
+          <p:nvPr/>
+        </p:nvSpPr>
+        <p:spPr>
+          <a:xfrm>
+            <a:off x="711200" y="2768600"/>
+            <a:ext cx="5029200" cy="406400"/>
+          </a:xfrm>
+          <a:prstGeom prst="rect">
+            <a:avLst/>
+          </a:prstGeom>
+          <a:noFill/>
+        </p:spPr>
+        <p:txBody>
+          <a:bodyPr vertOverflow="overflow" vert="horz" wrap="square" rtlCol="0" anchor="t">
+            <a:spAutoFit/>
+          </a:bodyPr>
+          <a:lstStyle/>
+          <a:p>
+            <a:pPr algn="l"/>
+            <a:r>
+              <a:rPr lang="pt-PT" sz="1300">
+                <a:solidFill>
+                  <a:srgbClr val="2E3B4E"/>
+                </a:solidFill>
+                <a:latin typeface="Calibri"/>
+                <a:cs typeface="Calibri"/>
+              </a:rPr>
+              <a:t>Primitivas LoRA-style que restringem unlearning a fração mínima de parâmetros</a:t>
+            </a:r>
+          </a:p>
+        </p:txBody>
+      </p:sp>
+      <p:sp>
+        <p:nvSpPr>
+          <p:cNvPr id="7" name="Oval 6">
+            <a:extLst>
+              <a:ext uri="{FF2B5EF4-FFF2-40B4-BE49-F238E27FC236}">
+                <a16:creationId xmlns:a16="http://schemas.microsoft.com/office/drawing/2014/main" id="{F30FC41A-626A-2344-A1C4-68330BFA68CB}"/>
+              </a:ext>
+            </a:extLst>
+          </p:cNvPr>
+          <p:cNvSpPr/>
+          <p:nvPr/>
+        </p:nvSpPr>
+        <p:spPr>
+          <a:xfrm>
+            <a:off x="508000" y="3403600"/>
+            <a:ext cx="101600" cy="101600"/>
+          </a:xfrm>
+          <a:prstGeom prst="ellipse">
+            <a:avLst/>
+          </a:prstGeom>
+          <a:solidFill>
+            <a:srgbClr val="156082"/>
+          </a:solidFill>
+          <a:ln w="19050" cap="flat" cmpd="sng" algn="ctr">
+            <a:noFill/>
+            <a:prstDash val="solid"/>
+            <a:miter lim="800000"/>
+          </a:ln>
+        </p:spPr>
+        <p:style>
+          <a:lnRef idx="2">
+            <a:schemeClr val="accent1">
+              <a:shade val="15000"/>
+            </a:schemeClr>
+          </a:lnRef>
+          <a:fillRef idx="1">
+            <a:schemeClr val="accent1"/>
+          </a:fillRef>
+          <a:effectRef idx="0">
+            <a:schemeClr val="accent1"/>
+          </a:effectRef>
+          <a:fontRef idx="minor">
+            <a:schemeClr val="lt1"/>
+          </a:fontRef>
+        </p:style>
+        <p:txBody>
+          <a:bodyPr vertOverflow="clip" horzOverflow="clip" rtlCol="0" anchor="t"/>
+          <a:lstStyle/>
+          <a:p>
+            <a:pPr algn="l"/>
+            <a:endParaRPr lang="pt-PT"/>
+          </a:p>
+        </p:txBody>
+      </p:sp>
+      <p:sp>
+        <p:nvSpPr>
+          <p:cNvPr id="8" name="CaixaDeTexto 7">
+            <a:extLst>
+              <a:ext uri="{FF2B5EF4-FFF2-40B4-BE49-F238E27FC236}">
+                <a16:creationId xmlns:a16="http://schemas.microsoft.com/office/drawing/2014/main" id="{D69C9886-0420-0C4B-B968-6E06FABAED99}"/>
+              </a:ext>
+            </a:extLst>
+          </p:cNvPr>
+          <p:cNvSpPr txBox="1"/>
+          <p:nvPr/>
+        </p:nvSpPr>
+        <p:spPr>
+          <a:xfrm>
+            <a:off x="711200" y="3327400"/>
+            <a:ext cx="5029200" cy="254000"/>
+          </a:xfrm>
+          <a:prstGeom prst="rect">
+            <a:avLst/>
+          </a:prstGeom>
+          <a:noFill/>
+        </p:spPr>
+        <p:txBody>
+          <a:bodyPr vertOverflow="overflow" vert="horz" wrap="square" rtlCol="0" anchor="t">
+            <a:spAutoFit/>
+          </a:bodyPr>
+          <a:lstStyle/>
+          <a:p>
+            <a:pPr algn="l"/>
+            <a:r>
+              <a:rPr lang="pt-PT" sz="1400" b="1">
+                <a:solidFill>
+                  <a:srgbClr val="1A2332"/>
+                </a:solidFill>
+                <a:latin typeface="Calibri"/>
+                <a:cs typeface="Calibri"/>
+              </a:rPr>
+              <a:t>Kernels TinyML</a:t>
+            </a:r>
+          </a:p>
+        </p:txBody>
+      </p:sp>
+      <p:sp>
+        <p:nvSpPr>
+          <p:cNvPr id="9" name="CaixaDeTexto 8">
+            <a:extLst>
+              <a:ext uri="{FF2B5EF4-FFF2-40B4-BE49-F238E27FC236}">
+                <a16:creationId xmlns:a16="http://schemas.microsoft.com/office/drawing/2014/main" id="{10BEBC2F-0F7B-6D46-A944-63692DB51C7B}"/>
+              </a:ext>
+            </a:extLst>
+          </p:cNvPr>
+          <p:cNvSpPr txBox="1"/>
+          <p:nvPr/>
+        </p:nvSpPr>
+        <p:spPr>
+          <a:xfrm>
+            <a:off x="711200" y="3606800"/>
+            <a:ext cx="5029200" cy="406400"/>
+          </a:xfrm>
+          <a:prstGeom prst="rect">
+            <a:avLst/>
+          </a:prstGeom>
+          <a:noFill/>
+        </p:spPr>
+        <p:txBody>
+          <a:bodyPr vertOverflow="overflow" vert="horz" wrap="square" rtlCol="0" anchor="t">
+            <a:spAutoFit/>
+          </a:bodyPr>
+          <a:lstStyle/>
+          <a:p>
+            <a:pPr algn="l"/>
+            <a:r>
+              <a:rPr lang="pt-PT" sz="1300">
+                <a:solidFill>
+                  <a:srgbClr val="2E3B4E"/>
+                </a:solidFill>
+                <a:latin typeface="Calibri"/>
+                <a:cs typeface="Calibri"/>
+              </a:rPr>
+              <a:t>Compilar operações de erasure para MCU (TF Lite Micro, microTVM)</a:t>
+            </a:r>
+          </a:p>
+        </p:txBody>
+      </p:sp>
+      <p:sp>
+        <p:nvSpPr>
+          <p:cNvPr id="10" name="Oval 9">
+            <a:extLst>
+              <a:ext uri="{FF2B5EF4-FFF2-40B4-BE49-F238E27FC236}">
+                <a16:creationId xmlns:a16="http://schemas.microsoft.com/office/drawing/2014/main" id="{2194CC9C-176A-0F47-ACE1-5066FA21ABD3}"/>
+              </a:ext>
+            </a:extLst>
+          </p:cNvPr>
+          <p:cNvSpPr/>
+          <p:nvPr/>
+        </p:nvSpPr>
+        <p:spPr>
+          <a:xfrm>
+            <a:off x="508000" y="4114800"/>
+            <a:ext cx="101600" cy="101600"/>
+          </a:xfrm>
+          <a:prstGeom prst="ellipse">
+            <a:avLst/>
+          </a:prstGeom>
+          <a:solidFill>
+            <a:srgbClr val="156082"/>
+          </a:solidFill>
+          <a:ln w="19050" cap="flat" cmpd="sng" algn="ctr">
+            <a:noFill/>
+            <a:prstDash val="solid"/>
+            <a:miter lim="800000"/>
+          </a:ln>
+        </p:spPr>
+        <p:style>
+          <a:lnRef idx="2">
+            <a:schemeClr val="accent1">
+              <a:shade val="15000"/>
+            </a:schemeClr>
+          </a:lnRef>
+          <a:fillRef idx="1">
+            <a:schemeClr val="accent1"/>
+          </a:fillRef>
+          <a:effectRef idx="0">
+            <a:schemeClr val="accent1"/>
+          </a:effectRef>
+          <a:fontRef idx="minor">
+            <a:schemeClr val="lt1"/>
+          </a:fontRef>
+        </p:style>
+        <p:txBody>
+          <a:bodyPr vertOverflow="clip" horzOverflow="clip" rtlCol="0" anchor="t"/>
+          <a:lstStyle/>
+          <a:p>
+            <a:pPr algn="l"/>
+            <a:endParaRPr lang="pt-PT"/>
+          </a:p>
+        </p:txBody>
+      </p:sp>
+      <p:sp>
+        <p:nvSpPr>
+          <p:cNvPr id="11" name="CaixaDeTexto 10">
+            <a:extLst>
+              <a:ext uri="{FF2B5EF4-FFF2-40B4-BE49-F238E27FC236}">
+                <a16:creationId xmlns:a16="http://schemas.microsoft.com/office/drawing/2014/main" id="{B1BA7C17-2C74-A14C-8178-C5434B60B050}"/>
+              </a:ext>
+            </a:extLst>
+          </p:cNvPr>
+          <p:cNvSpPr txBox="1"/>
+          <p:nvPr/>
+        </p:nvSpPr>
+        <p:spPr>
+          <a:xfrm>
+            <a:off x="711200" y="4038600"/>
+            <a:ext cx="5029200" cy="254000"/>
+          </a:xfrm>
+          <a:prstGeom prst="rect">
+            <a:avLst/>
+          </a:prstGeom>
+          <a:noFill/>
+        </p:spPr>
+        <p:txBody>
+          <a:bodyPr vertOverflow="overflow" vert="horz" wrap="square" rtlCol="0" anchor="t">
+            <a:spAutoFit/>
+          </a:bodyPr>
+          <a:lstStyle/>
+          <a:p>
+            <a:pPr algn="l"/>
+            <a:r>
+              <a:rPr lang="pt-PT" sz="1400" b="1">
+                <a:solidFill>
+                  <a:srgbClr val="1A2332"/>
+                </a:solidFill>
+                <a:latin typeface="Calibri"/>
+                <a:cs typeface="Calibri"/>
+              </a:rPr>
+              <a:t>Aceleração NPU/DSP</a:t>
+            </a:r>
+          </a:p>
+        </p:txBody>
+      </p:sp>
+      <p:sp>
+        <p:nvSpPr>
+          <p:cNvPr id="12" name="CaixaDeTexto 11">
+            <a:extLst>
+              <a:ext uri="{FF2B5EF4-FFF2-40B4-BE49-F238E27FC236}">
+                <a16:creationId xmlns:a16="http://schemas.microsoft.com/office/drawing/2014/main" id="{1A75184F-0B43-C24F-A1BB-A7F042B0AB41}"/>
+              </a:ext>
+            </a:extLst>
+          </p:cNvPr>
+          <p:cNvSpPr txBox="1"/>
+          <p:nvPr/>
+        </p:nvSpPr>
+        <p:spPr>
+          <a:xfrm>
+            <a:off x="711200" y="4318000"/>
+            <a:ext cx="5029200" cy="406400"/>
+          </a:xfrm>
+          <a:prstGeom prst="rect">
+            <a:avLst/>
+          </a:prstGeom>
+          <a:noFill/>
+        </p:spPr>
+        <p:txBody>
+          <a:bodyPr vertOverflow="overflow" vert="horz" wrap="square" rtlCol="0" anchor="t">
+            <a:spAutoFit/>
+          </a:bodyPr>
+          <a:lstStyle/>
+          <a:p>
+            <a:pPr algn="l"/>
+            <a:r>
+              <a:rPr lang="pt-PT" sz="1300">
+                <a:solidFill>
+                  <a:srgbClr val="2E3B4E"/>
+                </a:solidFill>
+                <a:latin typeface="Calibri"/>
+                <a:cs typeface="Calibri"/>
+              </a:rPr>
+              <a:t>Explorar unidades de processamento neural disponíveis no edge</a:t>
+            </a:r>
+          </a:p>
+        </p:txBody>
+      </p:sp>
+      <p:sp>
+        <p:nvSpPr>
+          <p:cNvPr id="13" name="Oval 12">
+            <a:extLst>
+              <a:ext uri="{FF2B5EF4-FFF2-40B4-BE49-F238E27FC236}">
+                <a16:creationId xmlns:a16="http://schemas.microsoft.com/office/drawing/2014/main" id="{12D3475D-927E-DD49-8C65-A2D20442782D}"/>
+              </a:ext>
+            </a:extLst>
+          </p:cNvPr>
+          <p:cNvSpPr/>
+          <p:nvPr/>
+        </p:nvSpPr>
+        <p:spPr>
+          <a:xfrm>
+            <a:off x="508000" y="4826000"/>
+            <a:ext cx="101600" cy="101600"/>
+          </a:xfrm>
+          <a:prstGeom prst="ellipse">
+            <a:avLst/>
+          </a:prstGeom>
+          <a:solidFill>
+            <a:srgbClr val="156082"/>
+          </a:solidFill>
+          <a:ln w="19050" cap="flat" cmpd="sng" algn="ctr">
+            <a:noFill/>
+            <a:prstDash val="solid"/>
+            <a:miter lim="800000"/>
+          </a:ln>
+        </p:spPr>
+        <p:style>
+          <a:lnRef idx="2">
+            <a:schemeClr val="accent1">
+              <a:shade val="15000"/>
+            </a:schemeClr>
+          </a:lnRef>
+          <a:fillRef idx="1">
+            <a:schemeClr val="accent1"/>
+          </a:fillRef>
+          <a:effectRef idx="0">
+            <a:schemeClr val="accent1"/>
+          </a:effectRef>
+          <a:fontRef idx="minor">
+            <a:schemeClr val="lt1"/>
+          </a:fontRef>
+        </p:style>
+        <p:txBody>
+          <a:bodyPr vertOverflow="clip" horzOverflow="clip" rtlCol="0" anchor="t"/>
+          <a:lstStyle/>
+          <a:p>
+            <a:pPr algn="l"/>
+            <a:endParaRPr lang="pt-PT"/>
+          </a:p>
+        </p:txBody>
+      </p:sp>
+      <p:sp>
+        <p:nvSpPr>
+          <p:cNvPr id="14" name="CaixaDeTexto 13">
+            <a:extLst>
+              <a:ext uri="{FF2B5EF4-FFF2-40B4-BE49-F238E27FC236}">
+                <a16:creationId xmlns:a16="http://schemas.microsoft.com/office/drawing/2014/main" id="{567C310F-F11F-B545-AD9E-9E44A55CA2BE}"/>
+              </a:ext>
+            </a:extLst>
+          </p:cNvPr>
+          <p:cNvSpPr txBox="1"/>
+          <p:nvPr/>
+        </p:nvSpPr>
+        <p:spPr>
+          <a:xfrm>
+            <a:off x="711200" y="4749800"/>
+            <a:ext cx="5029200" cy="254000"/>
+          </a:xfrm>
+          <a:prstGeom prst="rect">
+            <a:avLst/>
+          </a:prstGeom>
+          <a:noFill/>
+        </p:spPr>
+        <p:txBody>
+          <a:bodyPr vertOverflow="overflow" vert="horz" wrap="square" rtlCol="0" anchor="t">
+            <a:spAutoFit/>
+          </a:bodyPr>
+          <a:lstStyle/>
+          <a:p>
+            <a:pPr algn="l"/>
+            <a:r>
+              <a:rPr lang="pt-PT" sz="1400" b="1">
+                <a:solidFill>
+                  <a:srgbClr val="1A2332"/>
+                </a:solidFill>
+                <a:latin typeface="Calibri"/>
+                <a:cs typeface="Calibri"/>
+              </a:rPr>
+              <a:t>Patch cloud→edge</a:t>
+            </a:r>
+          </a:p>
+        </p:txBody>
+      </p:sp>
+      <p:sp>
+        <p:nvSpPr>
+          <p:cNvPr id="15" name="CaixaDeTexto 14">
+            <a:extLst>
+              <a:ext uri="{FF2B5EF4-FFF2-40B4-BE49-F238E27FC236}">
+                <a16:creationId xmlns:a16="http://schemas.microsoft.com/office/drawing/2014/main" id="{DAF1A083-6C0D-3343-A247-98FC91AF480A}"/>
+              </a:ext>
+            </a:extLst>
+          </p:cNvPr>
+          <p:cNvSpPr txBox="1"/>
+          <p:nvPr/>
+        </p:nvSpPr>
+        <p:spPr>
+          <a:xfrm>
+            <a:off x="711200" y="5029200"/>
+            <a:ext cx="5029200" cy="406400"/>
+          </a:xfrm>
+          <a:prstGeom prst="rect">
+            <a:avLst/>
+          </a:prstGeom>
+          <a:noFill/>
+        </p:spPr>
+        <p:txBody>
+          <a:bodyPr vertOverflow="overflow" vert="horz" wrap="square" rtlCol="0" anchor="t">
+            <a:spAutoFit/>
+          </a:bodyPr>
+          <a:lstStyle/>
+          <a:p>
+            <a:pPr algn="l"/>
+            <a:r>
+              <a:rPr lang="pt-PT" sz="1300">
+                <a:solidFill>
+                  <a:srgbClr val="2E3B4E"/>
+                </a:solidFill>
+                <a:latin typeface="Calibri"/>
+                <a:cs typeface="Calibri"/>
+              </a:rPr>
+              <a:t>Cloud faz retrain pesado e envia patch residual leve ao edge</a:t>
+            </a:r>
+          </a:p>
+        </p:txBody>
+      </p:sp>
+      <p:sp>
+        <p:nvSpPr>
+          <p:cNvPr id="16" name="Retângulo Arredondado 15">
+            <a:extLst>
+              <a:ext uri="{FF2B5EF4-FFF2-40B4-BE49-F238E27FC236}">
+                <a16:creationId xmlns:a16="http://schemas.microsoft.com/office/drawing/2014/main" id="{6B874A69-8707-494F-96CD-B4A7BC8D1714}"/>
+              </a:ext>
+            </a:extLst>
+          </p:cNvPr>
+          <p:cNvSpPr/>
+          <p:nvPr/>
+        </p:nvSpPr>
+        <p:spPr>
+          <a:xfrm>
+            <a:off x="6096000" y="1905000"/>
+            <a:ext cx="5334000" cy="457200"/>
+          </a:xfrm>
+          <a:prstGeom prst="roundRect">
+            <a:avLst/>
+          </a:prstGeom>
+          <a:solidFill>
+            <a:srgbClr val="B5511A"/>
+          </a:solidFill>
+          <a:ln w="19050" cap="flat" cmpd="sng" algn="ctr">
+            <a:noFill/>
+            <a:prstDash val="solid"/>
+            <a:miter lim="800000"/>
+          </a:ln>
+        </p:spPr>
+        <p:style>
+          <a:lnRef idx="2">
+            <a:schemeClr val="accent1">
+              <a:shade val="15000"/>
+            </a:schemeClr>
+          </a:lnRef>
+          <a:fillRef idx="1">
+            <a:schemeClr val="accent1"/>
+          </a:fillRef>
+          <a:effectRef idx="0">
+            <a:schemeClr val="accent1"/>
+          </a:effectRef>
+          <a:fontRef idx="minor">
+            <a:schemeClr val="lt1"/>
+          </a:fontRef>
+        </p:style>
+        <p:txBody>
+          <a:bodyPr vertOverflow="clip" horzOverflow="clip" wrap="none" rtlCol="0" anchor="ctr" anchorCtr="0">
+            <a:noAutofit/>
+          </a:bodyPr>
+          <a:lstStyle/>
+          <a:p>
+            <a:pPr algn="l"/>
+            <a:r>
+              <a:rPr lang="pt-PT" sz="1400" b="1">
+                <a:solidFill>
+                  <a:srgbClr val="FFFFFF"/>
+                </a:solidFill>
+                <a:latin typeface="Calibri"/>
+                <a:cs typeface="Calibri"/>
+              </a:rPr>
+              <a:t>VERIFICAÇÃO E GARANTIAS</a:t>
+            </a:r>
+          </a:p>
+        </p:txBody>
+      </p:sp>
+      <p:sp>
+        <p:nvSpPr>
+          <p:cNvPr id="17" name="Oval 16">
+            <a:extLst>
+              <a:ext uri="{FF2B5EF4-FFF2-40B4-BE49-F238E27FC236}">
+                <a16:creationId xmlns:a16="http://schemas.microsoft.com/office/drawing/2014/main" id="{D660A62C-0446-2944-B6BC-2130A92C8C9E}"/>
+              </a:ext>
+            </a:extLst>
+          </p:cNvPr>
+          <p:cNvSpPr/>
+          <p:nvPr/>
+        </p:nvSpPr>
+        <p:spPr>
+          <a:xfrm>
+            <a:off x="6146800" y="2565400"/>
+            <a:ext cx="101600" cy="101600"/>
+          </a:xfrm>
+          <a:prstGeom prst="ellipse">
+            <a:avLst/>
+          </a:prstGeom>
+          <a:solidFill>
+            <a:srgbClr val="B5511A"/>
+          </a:solidFill>
+          <a:ln w="19050" cap="flat" cmpd="sng" algn="ctr">
+            <a:noFill/>
+            <a:prstDash val="solid"/>
+            <a:miter lim="800000"/>
+          </a:ln>
+        </p:spPr>
+        <p:style>
+          <a:lnRef idx="2">
+            <a:schemeClr val="accent1">
+              <a:shade val="15000"/>
+            </a:schemeClr>
+          </a:lnRef>
+          <a:fillRef idx="1">
+            <a:schemeClr val="accent1"/>
+          </a:fillRef>
+          <a:effectRef idx="0">
+            <a:schemeClr val="accent1"/>
+          </a:effectRef>
+          <a:fontRef idx="minor">
+            <a:schemeClr val="lt1"/>
+          </a:fontRef>
+        </p:style>
+        <p:txBody>
+          <a:bodyPr vertOverflow="clip" horzOverflow="clip" rtlCol="0" anchor="t"/>
+          <a:lstStyle/>
+          <a:p>
+            <a:pPr algn="l"/>
+            <a:endParaRPr lang="pt-PT"/>
+          </a:p>
+        </p:txBody>
+      </p:sp>
+      <p:sp>
+        <p:nvSpPr>
+          <p:cNvPr id="18" name="CaixaDeTexto 17">
+            <a:extLst>
+              <a:ext uri="{FF2B5EF4-FFF2-40B4-BE49-F238E27FC236}">
+                <a16:creationId xmlns:a16="http://schemas.microsoft.com/office/drawing/2014/main" id="{4460F763-94A9-C640-AD72-8B7D81739510}"/>
+              </a:ext>
+            </a:extLst>
+          </p:cNvPr>
+          <p:cNvSpPr txBox="1"/>
+          <p:nvPr/>
+        </p:nvSpPr>
+        <p:spPr>
+          <a:xfrm>
+            <a:off x="6350000" y="2489200"/>
+            <a:ext cx="5029200" cy="254000"/>
+          </a:xfrm>
+          <a:prstGeom prst="rect">
+            <a:avLst/>
+          </a:prstGeom>
+          <a:noFill/>
+        </p:spPr>
+        <p:txBody>
+          <a:bodyPr vertOverflow="overflow" vert="horz" wrap="square" rtlCol="0" anchor="t">
+            <a:spAutoFit/>
+          </a:bodyPr>
+          <a:lstStyle/>
+          <a:p>
+            <a:pPr algn="l"/>
+            <a:r>
+              <a:rPr lang="pt-PT" sz="1400" b="1">
+                <a:solidFill>
+                  <a:srgbClr val="1A2332"/>
+                </a:solidFill>
+                <a:latin typeface="Calibri"/>
+                <a:cs typeface="Calibri"/>
+              </a:rPr>
+              <a:t>TEEs (SGX, TrustZone, SEV)</a:t>
+            </a:r>
+          </a:p>
+        </p:txBody>
+      </p:sp>
+      <p:sp>
+        <p:nvSpPr>
+          <p:cNvPr id="19" name="CaixaDeTexto 18">
+            <a:extLst>
+              <a:ext uri="{FF2B5EF4-FFF2-40B4-BE49-F238E27FC236}">
+                <a16:creationId xmlns:a16="http://schemas.microsoft.com/office/drawing/2014/main" id="{7B712AE0-AB66-2F41-9682-D4DA6813FA03}"/>
+              </a:ext>
+            </a:extLst>
+          </p:cNvPr>
+          <p:cNvSpPr txBox="1"/>
+          <p:nvPr/>
+        </p:nvSpPr>
+        <p:spPr>
+          <a:xfrm>
+            <a:off x="6350000" y="2768600"/>
+            <a:ext cx="5029200" cy="406400"/>
+          </a:xfrm>
+          <a:prstGeom prst="rect">
+            <a:avLst/>
+          </a:prstGeom>
+          <a:noFill/>
+        </p:spPr>
+        <p:txBody>
+          <a:bodyPr vertOverflow="overflow" vert="horz" wrap="square" rtlCol="0" anchor="t">
+            <a:spAutoFit/>
+          </a:bodyPr>
+          <a:lstStyle/>
+          <a:p>
+            <a:pPr algn="l"/>
+            <a:r>
+              <a:rPr lang="pt-PT" sz="1300">
+                <a:solidFill>
+                  <a:srgbClr val="2E3B4E"/>
+                </a:solidFill>
+                <a:latin typeface="Calibri"/>
+                <a:cs typeface="Calibri"/>
+              </a:rPr>
+              <a:t>Executar unlearning em enclave → atestação criptográfica</a:t>
+            </a:r>
+          </a:p>
+        </p:txBody>
+      </p:sp>
+      <p:sp>
+        <p:nvSpPr>
+          <p:cNvPr id="20" name="Oval 19">
+            <a:extLst>
+              <a:ext uri="{FF2B5EF4-FFF2-40B4-BE49-F238E27FC236}">
+                <a16:creationId xmlns:a16="http://schemas.microsoft.com/office/drawing/2014/main" id="{89780F56-6DB4-3644-9525-1E80A52B239A}"/>
+              </a:ext>
+            </a:extLst>
+          </p:cNvPr>
+          <p:cNvSpPr/>
+          <p:nvPr/>
+        </p:nvSpPr>
+        <p:spPr>
+          <a:xfrm>
+            <a:off x="6146800" y="3403600"/>
+            <a:ext cx="101600" cy="101600"/>
+          </a:xfrm>
+          <a:prstGeom prst="ellipse">
+            <a:avLst/>
+          </a:prstGeom>
+          <a:solidFill>
+            <a:srgbClr val="B5511A"/>
+          </a:solidFill>
+          <a:ln w="19050" cap="flat" cmpd="sng" algn="ctr">
+            <a:noFill/>
+            <a:prstDash val="solid"/>
+            <a:miter lim="800000"/>
+          </a:ln>
+        </p:spPr>
+        <p:style>
+          <a:lnRef idx="2">
+            <a:schemeClr val="accent1">
+              <a:shade val="15000"/>
+            </a:schemeClr>
+          </a:lnRef>
+          <a:fillRef idx="1">
+            <a:schemeClr val="accent1"/>
+          </a:fillRef>
+          <a:effectRef idx="0">
+            <a:schemeClr val="accent1"/>
+          </a:effectRef>
+          <a:fontRef idx="minor">
+            <a:schemeClr val="lt1"/>
+          </a:fontRef>
+        </p:style>
+        <p:txBody>
+          <a:bodyPr vertOverflow="clip" horzOverflow="clip" rtlCol="0" anchor="t"/>
+          <a:lstStyle/>
+          <a:p>
+            <a:pPr algn="l"/>
+            <a:endParaRPr lang="pt-PT"/>
+          </a:p>
+        </p:txBody>
+      </p:sp>
+      <p:sp>
+        <p:nvSpPr>
+          <p:cNvPr id="21" name="CaixaDeTexto 20">
+            <a:extLst>
+              <a:ext uri="{FF2B5EF4-FFF2-40B4-BE49-F238E27FC236}">
+                <a16:creationId xmlns:a16="http://schemas.microsoft.com/office/drawing/2014/main" id="{89FE33ED-72D8-E64B-825A-C229569C3503}"/>
+              </a:ext>
+            </a:extLst>
+          </p:cNvPr>
+          <p:cNvSpPr txBox="1"/>
+          <p:nvPr/>
+        </p:nvSpPr>
+        <p:spPr>
+          <a:xfrm>
+            <a:off x="6350000" y="3327400"/>
+            <a:ext cx="5029200" cy="254000"/>
+          </a:xfrm>
+          <a:prstGeom prst="rect">
+            <a:avLst/>
+          </a:prstGeom>
+          <a:noFill/>
+        </p:spPr>
+        <p:txBody>
+          <a:bodyPr vertOverflow="overflow" vert="horz" wrap="square" rtlCol="0" anchor="t">
+            <a:spAutoFit/>
+          </a:bodyPr>
+          <a:lstStyle/>
+          <a:p>
+            <a:pPr algn="l"/>
+            <a:r>
+              <a:rPr lang="pt-PT" sz="1400" b="1">
+                <a:solidFill>
+                  <a:srgbClr val="1A2332"/>
+                </a:solidFill>
+                <a:latin typeface="Calibri"/>
+                <a:cs typeface="Calibri"/>
+              </a:rPr>
+              <a:t>Zero-knowledge proofs</a:t>
+            </a:r>
+          </a:p>
+        </p:txBody>
+      </p:sp>
+      <p:sp>
+        <p:nvSpPr>
+          <p:cNvPr id="22" name="CaixaDeTexto 21">
+            <a:extLst>
+              <a:ext uri="{FF2B5EF4-FFF2-40B4-BE49-F238E27FC236}">
+                <a16:creationId xmlns:a16="http://schemas.microsoft.com/office/drawing/2014/main" id="{C2D647A6-EE07-C245-B24D-7DB07C228C1F}"/>
+              </a:ext>
+            </a:extLst>
+          </p:cNvPr>
+          <p:cNvSpPr txBox="1"/>
+          <p:nvPr/>
+        </p:nvSpPr>
+        <p:spPr>
+          <a:xfrm>
+            <a:off x="6350000" y="3606800"/>
+            <a:ext cx="5029200" cy="406400"/>
+          </a:xfrm>
+          <a:prstGeom prst="rect">
+            <a:avLst/>
+          </a:prstGeom>
+          <a:noFill/>
+        </p:spPr>
+        <p:txBody>
+          <a:bodyPr vertOverflow="overflow" vert="horz" wrap="square" rtlCol="0" anchor="t">
+            <a:spAutoFit/>
+          </a:bodyPr>
+          <a:lstStyle/>
+          <a:p>
+            <a:pPr algn="l"/>
+            <a:r>
+              <a:rPr lang="pt-PT" sz="1300">
+                <a:solidFill>
+                  <a:srgbClr val="2E3B4E"/>
+                </a:solidFill>
+                <a:latin typeface="Calibri"/>
+                <a:cs typeface="Calibri"/>
+              </a:rPr>
+              <a:t>Provar que pesos resultam da função declarada, sem revelar modelo</a:t>
+            </a:r>
+          </a:p>
+        </p:txBody>
+      </p:sp>
+      <p:sp>
+        <p:nvSpPr>
+          <p:cNvPr id="23" name="Oval 22">
+            <a:extLst>
+              <a:ext uri="{FF2B5EF4-FFF2-40B4-BE49-F238E27FC236}">
+                <a16:creationId xmlns:a16="http://schemas.microsoft.com/office/drawing/2014/main" id="{BDAF54C8-C787-2340-8D3C-AA6942ECF560}"/>
+              </a:ext>
+            </a:extLst>
+          </p:cNvPr>
+          <p:cNvSpPr/>
+          <p:nvPr/>
+        </p:nvSpPr>
+        <p:spPr>
+          <a:xfrm>
+            <a:off x="6146800" y="4114800"/>
+            <a:ext cx="101600" cy="101600"/>
+          </a:xfrm>
+          <a:prstGeom prst="ellipse">
+            <a:avLst/>
+          </a:prstGeom>
+          <a:solidFill>
+            <a:srgbClr val="B5511A"/>
+          </a:solidFill>
+          <a:ln w="19050" cap="flat" cmpd="sng" algn="ctr">
+            <a:noFill/>
+            <a:prstDash val="solid"/>
+            <a:miter lim="800000"/>
+          </a:ln>
+        </p:spPr>
+        <p:style>
+          <a:lnRef idx="2">
+            <a:schemeClr val="accent1">
+              <a:shade val="15000"/>
+            </a:schemeClr>
+          </a:lnRef>
+          <a:fillRef idx="1">
+            <a:schemeClr val="accent1"/>
+          </a:fillRef>
+          <a:effectRef idx="0">
+            <a:schemeClr val="accent1"/>
+          </a:effectRef>
+          <a:fontRef idx="minor">
+            <a:schemeClr val="lt1"/>
+          </a:fontRef>
+        </p:style>
+        <p:txBody>
+          <a:bodyPr vertOverflow="clip" horzOverflow="clip" rtlCol="0" anchor="t"/>
+          <a:lstStyle/>
+          <a:p>
+            <a:pPr algn="l"/>
+            <a:endParaRPr lang="pt-PT"/>
+          </a:p>
+        </p:txBody>
+      </p:sp>
+      <p:sp>
+        <p:nvSpPr>
+          <p:cNvPr id="24" name="CaixaDeTexto 23">
+            <a:extLst>
+              <a:ext uri="{FF2B5EF4-FFF2-40B4-BE49-F238E27FC236}">
+                <a16:creationId xmlns:a16="http://schemas.microsoft.com/office/drawing/2014/main" id="{242D99DD-F348-D44F-AD3E-4378D0E3F0AF}"/>
+              </a:ext>
+            </a:extLst>
+          </p:cNvPr>
+          <p:cNvSpPr txBox="1"/>
+          <p:nvPr/>
+        </p:nvSpPr>
+        <p:spPr>
+          <a:xfrm>
+            <a:off x="6350000" y="4038600"/>
+            <a:ext cx="5029200" cy="254000"/>
+          </a:xfrm>
+          <a:prstGeom prst="rect">
+            <a:avLst/>
+          </a:prstGeom>
+          <a:noFill/>
+        </p:spPr>
+        <p:txBody>
+          <a:bodyPr vertOverflow="overflow" vert="horz" wrap="square" rtlCol="0" anchor="t">
+            <a:spAutoFit/>
+          </a:bodyPr>
+          <a:lstStyle/>
+          <a:p>
+            <a:pPr algn="l"/>
+            <a:r>
+              <a:rPr lang="pt-PT" sz="1400" b="1">
+                <a:solidFill>
+                  <a:srgbClr val="1A2332"/>
+                </a:solidFill>
+                <a:latin typeface="Calibri"/>
+                <a:cs typeface="Calibri"/>
+              </a:rPr>
+              <a:t>DP budget tracking</a:t>
+            </a:r>
+          </a:p>
+        </p:txBody>
+      </p:sp>
+      <p:sp>
+        <p:nvSpPr>
+          <p:cNvPr id="25" name="CaixaDeTexto 24">
+            <a:extLst>
+              <a:ext uri="{FF2B5EF4-FFF2-40B4-BE49-F238E27FC236}">
+                <a16:creationId xmlns:a16="http://schemas.microsoft.com/office/drawing/2014/main" id="{5564B44C-F642-E549-8EA9-4A4011F88FD3}"/>
+              </a:ext>
+            </a:extLst>
+          </p:cNvPr>
+          <p:cNvSpPr txBox="1"/>
+          <p:nvPr/>
+        </p:nvSpPr>
+        <p:spPr>
+          <a:xfrm>
+            <a:off x="6350000" y="4318000"/>
+            <a:ext cx="5029200" cy="406400"/>
+          </a:xfrm>
+          <a:prstGeom prst="rect">
+            <a:avLst/>
+          </a:prstGeom>
+          <a:noFill/>
+        </p:spPr>
+        <p:txBody>
+          <a:bodyPr vertOverflow="overflow" vert="horz" wrap="square" rtlCol="0" anchor="t">
+            <a:spAutoFit/>
+          </a:bodyPr>
+          <a:lstStyle/>
+          <a:p>
+            <a:pPr algn="l"/>
+            <a:r>
+              <a:rPr lang="pt-PT" sz="1300">
+                <a:solidFill>
+                  <a:srgbClr val="2E3B4E"/>
+                </a:solidFill>
+                <a:latin typeface="Calibri"/>
+                <a:cs typeface="Calibri"/>
+              </a:rPr>
+              <a:t>Cada evento de erasure consome orçamento de privacidade auditável</a:t>
+            </a:r>
+          </a:p>
+        </p:txBody>
+      </p:sp>
+      <p:sp>
+        <p:nvSpPr>
+          <p:cNvPr id="26" name="Oval 25">
+            <a:extLst>
+              <a:ext uri="{FF2B5EF4-FFF2-40B4-BE49-F238E27FC236}">
+                <a16:creationId xmlns:a16="http://schemas.microsoft.com/office/drawing/2014/main" id="{C45A6D58-6CE1-1146-806B-6E8C3878CF7A}"/>
+              </a:ext>
+            </a:extLst>
+          </p:cNvPr>
+          <p:cNvSpPr/>
+          <p:nvPr/>
+        </p:nvSpPr>
+        <p:spPr>
+          <a:xfrm>
+            <a:off x="6146800" y="4826000"/>
+            <a:ext cx="101600" cy="101600"/>
+          </a:xfrm>
+          <a:prstGeom prst="ellipse">
+            <a:avLst/>
+          </a:prstGeom>
+          <a:solidFill>
+            <a:srgbClr val="B5511A"/>
+          </a:solidFill>
+          <a:ln w="19050" cap="flat" cmpd="sng" algn="ctr">
+            <a:noFill/>
+            <a:prstDash val="solid"/>
+            <a:miter lim="800000"/>
+          </a:ln>
+        </p:spPr>
+        <p:style>
+          <a:lnRef idx="2">
+            <a:schemeClr val="accent1">
+              <a:shade val="15000"/>
+            </a:schemeClr>
+          </a:lnRef>
+          <a:fillRef idx="1">
+            <a:schemeClr val="accent1"/>
+          </a:fillRef>
+          <a:effectRef idx="0">
+            <a:schemeClr val="accent1"/>
+          </a:effectRef>
+          <a:fontRef idx="minor">
+            <a:schemeClr val="lt1"/>
+          </a:fontRef>
+        </p:style>
+        <p:txBody>
+          <a:bodyPr vertOverflow="clip" horzOverflow="clip" rtlCol="0" anchor="t"/>
+          <a:lstStyle/>
+          <a:p>
+            <a:pPr algn="l"/>
+            <a:endParaRPr lang="pt-PT"/>
+          </a:p>
+        </p:txBody>
+      </p:sp>
+      <p:sp>
+        <p:nvSpPr>
+          <p:cNvPr id="27" name="CaixaDeTexto 26">
+            <a:extLst>
+              <a:ext uri="{FF2B5EF4-FFF2-40B4-BE49-F238E27FC236}">
+                <a16:creationId xmlns:a16="http://schemas.microsoft.com/office/drawing/2014/main" id="{29165D0D-A27D-FD47-8D9E-EF7D09BEB984}"/>
+              </a:ext>
+            </a:extLst>
+          </p:cNvPr>
+          <p:cNvSpPr txBox="1"/>
+          <p:nvPr/>
+        </p:nvSpPr>
+        <p:spPr>
+          <a:xfrm>
+            <a:off x="6350000" y="4749800"/>
+            <a:ext cx="5029200" cy="254000"/>
+          </a:xfrm>
+          <a:prstGeom prst="rect">
+            <a:avLst/>
+          </a:prstGeom>
+          <a:noFill/>
+        </p:spPr>
+        <p:txBody>
+          <a:bodyPr vertOverflow="overflow" vert="horz" wrap="square" rtlCol="0" anchor="t">
+            <a:spAutoFit/>
+          </a:bodyPr>
+          <a:lstStyle/>
+          <a:p>
+            <a:pPr algn="l"/>
+            <a:r>
+              <a:rPr lang="pt-PT" sz="1400" b="1">
+                <a:solidFill>
+                  <a:srgbClr val="1A2332"/>
+                </a:solidFill>
+                <a:latin typeface="Calibri"/>
+                <a:cs typeface="Calibri"/>
+              </a:rPr>
+              <a:t>Abordagem híbrida</a:t>
+            </a:r>
+          </a:p>
+        </p:txBody>
+      </p:sp>
+      <p:sp>
+        <p:nvSpPr>
+          <p:cNvPr id="28" name="CaixaDeTexto 27">
+            <a:extLst>
+              <a:ext uri="{FF2B5EF4-FFF2-40B4-BE49-F238E27FC236}">
+                <a16:creationId xmlns:a16="http://schemas.microsoft.com/office/drawing/2014/main" id="{A5963ADC-BD6D-5C47-8417-9D5C7B143767}"/>
+              </a:ext>
+            </a:extLst>
+          </p:cNvPr>
+          <p:cNvSpPr txBox="1"/>
+          <p:nvPr/>
+        </p:nvSpPr>
+        <p:spPr>
+          <a:xfrm>
+            <a:off x="6350000" y="5029200"/>
+            <a:ext cx="5029200" cy="406400"/>
+          </a:xfrm>
+          <a:prstGeom prst="rect">
+            <a:avLst/>
+          </a:prstGeom>
+          <a:noFill/>
+        </p:spPr>
+        <p:txBody>
+          <a:bodyPr vertOverflow="overflow" vert="horz" wrap="square" rtlCol="0" anchor="t">
+            <a:spAutoFit/>
+          </a:bodyPr>
+          <a:lstStyle/>
+          <a:p>
+            <a:pPr algn="l"/>
+            <a:r>
+              <a:rPr lang="pt-PT" sz="1300">
+                <a:solidFill>
+                  <a:srgbClr val="2E3B4E"/>
+                </a:solidFill>
+                <a:latin typeface="Calibri"/>
+                <a:cs typeface="Calibri"/>
+              </a:rPr>
+              <a:t>TEE (runtime) + ZKP (pós-hoc) + DP (cumulativo) em camadas</a:t>
+            </a:r>
+          </a:p>
+        </p:txBody>
+      </p:sp>
+      <p:sp>
+        <p:nvSpPr>
+          <p:cNvPr id="29" name="Retângulo 28">
+            <a:extLst>
+              <a:ext uri="{FF2B5EF4-FFF2-40B4-BE49-F238E27FC236}">
+                <a16:creationId xmlns:a16="http://schemas.microsoft.com/office/drawing/2014/main" id="{3AF5AE9F-4083-AA47-83D7-316C7DC19454}"/>
+              </a:ext>
+            </a:extLst>
+          </p:cNvPr>
+          <p:cNvSpPr/>
+          <p:nvPr/>
+        </p:nvSpPr>
+        <p:spPr>
+          <a:xfrm>
+            <a:off x="457200" y="5562600"/>
+            <a:ext cx="11277600" cy="711200"/>
+          </a:xfrm>
+          <a:prstGeom prst="rect">
+            <a:avLst/>
+          </a:prstGeom>
+          <a:solidFill>
+            <a:srgbClr val="F0EBE3"/>
+          </a:solidFill>
+          <a:ln w="19050" cap="flat" cmpd="sng" algn="ctr">
+            <a:noFill/>
+            <a:prstDash val="solid"/>
+            <a:miter lim="800000"/>
+          </a:ln>
+        </p:spPr>
+        <p:style>
+          <a:lnRef idx="2">
+            <a:schemeClr val="accent1">
+              <a:shade val="15000"/>
+            </a:schemeClr>
+          </a:lnRef>
+          <a:fillRef idx="1">
+            <a:schemeClr val="accent1"/>
+          </a:fillRef>
+          <a:effectRef idx="0">
+            <a:schemeClr val="accent1"/>
+          </a:effectRef>
+          <a:fontRef idx="minor">
+            <a:schemeClr val="lt1"/>
+          </a:fontRef>
+        </p:style>
+        <p:txBody>
+          <a:bodyPr vertOverflow="clip" horzOverflow="clip" rtlCol="0" anchor="t"/>
+          <a:lstStyle/>
+          <a:p>
+            <a:pPr algn="l"/>
+            <a:endParaRPr lang="pt-PT"/>
+          </a:p>
+        </p:txBody>
+      </p:sp>
+      <p:sp>
+        <p:nvSpPr>
+          <p:cNvPr id="30" name="CaixaDeTexto 29">
+            <a:extLst>
+              <a:ext uri="{FF2B5EF4-FFF2-40B4-BE49-F238E27FC236}">
+                <a16:creationId xmlns:a16="http://schemas.microsoft.com/office/drawing/2014/main" id="{427BEB23-DF31-AD44-8C62-B93FBA6D43C8}"/>
+              </a:ext>
+            </a:extLst>
+          </p:cNvPr>
+          <p:cNvSpPr txBox="1"/>
+          <p:nvPr/>
+        </p:nvSpPr>
+        <p:spPr>
+          <a:xfrm>
+            <a:off x="711200" y="5689600"/>
+            <a:ext cx="10769600" cy="457200"/>
+          </a:xfrm>
+          <a:prstGeom prst="rect">
+            <a:avLst/>
+          </a:prstGeom>
+          <a:noFill/>
+        </p:spPr>
+        <p:txBody>
+          <a:bodyPr vertOverflow="overflow" vert="horz" wrap="square" rtlCol="0" anchor="ctr" anchorCtr="0">
+            <a:noAutofit/>
+          </a:bodyPr>
+          <a:lstStyle/>
+          <a:p>
+            <a:pPr algn="l"/>
+            <a:r>
+              <a:rPr lang="pt-PT" sz="1400" i="1">
+                <a:solidFill>
+                  <a:srgbClr val="8B1A1A"/>
+                </a:solidFill>
+                <a:latin typeface="Calibri"/>
+                <a:cs typeface="Calibri"/>
+              </a:rPr>
+              <a:t>⚠  Sem benchmarks para MCU, sem limites formais de erro residual, sem mapeamento jurídico TEE/ZKP → RGPD Art. 17</a:t>
+            </a:r>
+          </a:p>
+        </p:txBody>
+      </p:sp>
+    </p:spTree>
+    <p:extLst>
+      <p:ext uri="{BB962C8B-B14F-4D97-AF65-F5344CB8AC3E}">
+        <p14:creationId xmlns:p14="http://schemas.microsoft.com/office/powerpoint/2010/main" val="1814811947"/>
+      </p:ext>
+    </p:extLst>
+  </p:cSld>
+  <p:clrMapOvr>
+    <a:masterClrMapping/>
+  </p:clrMapOvr>
+</p:sld>
+</file>
+
+<file path=ppt/slides/slide9.xml><?xml version="1.0" encoding="utf-8"?>
+<p:sld xmlns:a="http://schemas.openxmlformats.org/drawingml/2006/main" xmlns:r="http://schemas.openxmlformats.org/officeDocument/2006/relationships" xmlns:p="http://schemas.openxmlformats.org/presentationml/2006/main">
+  <p:cSld>
+    <p:spTree>
+      <p:nvGrpSpPr>
+        <p:cNvPr id="1" name=""/>
+        <p:cNvGrpSpPr/>
+        <p:nvPr/>
+      </p:nvGrpSpPr>
+      <p:grpSpPr>
+        <a:xfrm>
+          <a:off x="0" y="0"/>
+          <a:ext cx="0" cy="0"/>
+          <a:chOff x="0" y="0"/>
+          <a:chExt cx="0" cy="0"/>
+        </a:xfrm>
+      </p:grpSpPr>
+      <p:sp>
+        <p:nvSpPr>
+          <p:cNvPr id="2" name="Título 1">
+            <a:extLst>
+              <a:ext uri="{FF2B5EF4-FFF2-40B4-BE49-F238E27FC236}">
+                <a16:creationId xmlns:a16="http://schemas.microsoft.com/office/drawing/2014/main" id="{EBD52685-EEDA-3D69-3E46-D4D43E2FE8DF}"/>
+              </a:ext>
+            </a:extLst>
+          </p:cNvPr>
+          <p:cNvSpPr>
+            <a:spLocks noGrp="1"/>
+          </p:cNvSpPr>
+          <p:nvPr>
+            <p:ph type="title"/>
+          </p:nvPr>
+        </p:nvSpPr>
+        <p:spPr/>
+        <p:txBody>
+          <a:bodyPr/>
+          <a:lstStyle/>
+          <a:p>
+            <a:pPr algn="l">
+              <a:buNone/>
+            </a:pPr>
+            <a:r>
+              <a:rPr lang="pt-PT" sz="3200" b="1" dirty="0">
+                <a:solidFill>
+                  <a:srgbClr val="1A2332"/>
+                </a:solidFill>
+                <a:latin typeface="Georgia"/>
+              </a:rPr>
+              <a:t>Conclusão</a:t>
+            </a:r>
+          </a:p>
+        </p:txBody>
+      </p:sp>
+      <p:sp>
+        <p:nvSpPr>
+          <p:cNvPr id="3" name="Retângulo Arredondado 2">
+            <a:extLst>
+              <a:ext uri="{FF2B5EF4-FFF2-40B4-BE49-F238E27FC236}">
+                <a16:creationId xmlns:a16="http://schemas.microsoft.com/office/drawing/2014/main" id="{B81E05F5-3FF2-CC4A-8BA5-2622CA841F19}"/>
+              </a:ext>
+            </a:extLst>
+          </p:cNvPr>
+          <p:cNvSpPr/>
+          <p:nvPr/>
+        </p:nvSpPr>
+        <p:spPr>
+          <a:xfrm>
+            <a:off x="457200" y="1905000"/>
+            <a:ext cx="11277600" cy="889000"/>
+          </a:xfrm>
+          <a:prstGeom prst="roundRect">
+            <a:avLst/>
+          </a:prstGeom>
+          <a:solidFill>
+            <a:srgbClr val="156082"/>
+          </a:solidFill>
+          <a:ln w="19050" cap="flat" cmpd="sng" algn="ctr">
+            <a:noFill/>
+            <a:prstDash val="solid"/>
+            <a:miter lim="800000"/>
+          </a:ln>
+        </p:spPr>
+        <p:style>
+          <a:lnRef idx="2">
+            <a:schemeClr val="accent1">
+              <a:shade val="15000"/>
+            </a:schemeClr>
+          </a:lnRef>
+          <a:fillRef idx="1">
+            <a:schemeClr val="accent1"/>
+          </a:fillRef>
+          <a:effectRef idx="0">
+            <a:schemeClr val="accent1"/>
+          </a:effectRef>
+          <a:fontRef idx="minor">
+            <a:schemeClr val="lt1"/>
+          </a:fontRef>
+        </p:style>
+        <p:txBody>
+          <a:bodyPr vertOverflow="clip" horzOverflow="clip" wrap="square" rtlCol="0" anchor="ctr" anchorCtr="0">
+            <a:noAutofit/>
+          </a:bodyPr>
+          <a:lstStyle/>
+          <a:p>
+            <a:pPr algn="l"/>
+            <a:r>
+              <a:rPr lang="pt-PT" dirty="0">
+                <a:solidFill>
+                  <a:srgbClr val="FFFFFF"/>
+                </a:solidFill>
+                <a:latin typeface="Georgia"/>
+              </a:rPr>
+              <a:t>Três eixos interdependentes devem avançar em conjunto para alcançar </a:t>
+            </a:r>
+            <a:r>
+              <a:rPr lang="pt-PT" dirty="0" err="1">
+                <a:solidFill>
+                  <a:srgbClr val="FFFFFF"/>
+                </a:solidFill>
+                <a:latin typeface="Georgia"/>
+              </a:rPr>
+              <a:t>unlearning</a:t>
+            </a:r>
+            <a:r>
+              <a:rPr lang="pt-PT" dirty="0">
+                <a:solidFill>
+                  <a:srgbClr val="FFFFFF"/>
+                </a:solidFill>
+                <a:latin typeface="Georgia"/>
+              </a:rPr>
+              <a:t> responsável em edifícios inteligentes.</a:t>
+            </a:r>
+          </a:p>
+        </p:txBody>
+      </p:sp>
+      <p:sp>
+        <p:nvSpPr>
+          <p:cNvPr id="4" name="Oval 3">
+            <a:extLst>
+              <a:ext uri="{FF2B5EF4-FFF2-40B4-BE49-F238E27FC236}">
+                <a16:creationId xmlns:a16="http://schemas.microsoft.com/office/drawing/2014/main" id="{9E9680A7-A798-EB4F-9A16-720894964DB0}"/>
+              </a:ext>
+            </a:extLst>
+          </p:cNvPr>
+          <p:cNvSpPr/>
+          <p:nvPr/>
+        </p:nvSpPr>
+        <p:spPr>
+          <a:xfrm>
+            <a:off x="1905000" y="3149600"/>
+            <a:ext cx="660400" cy="660400"/>
+          </a:xfrm>
+          <a:prstGeom prst="ellipse">
+            <a:avLst/>
+          </a:prstGeom>
+          <a:solidFill>
+            <a:srgbClr val="156082"/>
+          </a:solidFill>
+          <a:ln w="19050" cap="flat" cmpd="sng" algn="ctr">
+            <a:noFill/>
+            <a:prstDash val="solid"/>
+            <a:miter lim="800000"/>
+          </a:ln>
+        </p:spPr>
+        <p:style>
+          <a:lnRef idx="2">
+            <a:schemeClr val="accent1">
+              <a:shade val="15000"/>
+            </a:schemeClr>
+          </a:lnRef>
+          <a:fillRef idx="1">
+            <a:schemeClr val="accent1"/>
+          </a:fillRef>
+          <a:effectRef idx="0">
+            <a:schemeClr val="accent1"/>
+          </a:effectRef>
+          <a:fontRef idx="minor">
+            <a:schemeClr val="lt1"/>
+          </a:fontRef>
+        </p:style>
+        <p:txBody>
+          <a:bodyPr vertOverflow="clip" horzOverflow="clip" wrap="none" rtlCol="0" anchor="ctr" anchorCtr="0">
+            <a:noAutofit/>
+          </a:bodyPr>
+          <a:lstStyle/>
+          <a:p>
+            <a:pPr algn="l"/>
+            <a:r>
+              <a:rPr lang="pt-PT" sz="2400" b="1">
+                <a:solidFill>
+                  <a:srgbClr val="FFFFFF"/>
+                </a:solidFill>
+                <a:latin typeface="Georgia"/>
+              </a:rPr>
+              <a:t>1</a:t>
+            </a:r>
+          </a:p>
+        </p:txBody>
+      </p:sp>
+      <p:sp>
+        <p:nvSpPr>
+          <p:cNvPr id="5" name="CaixaDeTexto 4">
+            <a:extLst>
+              <a:ext uri="{FF2B5EF4-FFF2-40B4-BE49-F238E27FC236}">
+                <a16:creationId xmlns:a16="http://schemas.microsoft.com/office/drawing/2014/main" id="{3ACB55E4-8882-B34D-AA4C-D5C13B32944F}"/>
+              </a:ext>
+            </a:extLst>
+          </p:cNvPr>
+          <p:cNvSpPr txBox="1"/>
+          <p:nvPr/>
+        </p:nvSpPr>
+        <p:spPr>
+          <a:xfrm>
+            <a:off x="457200" y="3911600"/>
+            <a:ext cx="3556000" cy="355600"/>
+          </a:xfrm>
+          <a:prstGeom prst="rect">
+            <a:avLst/>
+          </a:prstGeom>
+          <a:noFill/>
+        </p:spPr>
+        <p:txBody>
+          <a:bodyPr vertOverflow="overflow" vert="horz" wrap="square" rtlCol="0" anchor="t">
+            <a:spAutoFit/>
+          </a:bodyPr>
+          <a:lstStyle/>
+          <a:p>
+            <a:pPr algn="l"/>
+            <a:r>
+              <a:rPr lang="pt-PT" b="1">
+                <a:solidFill>
+                  <a:srgbClr val="156082"/>
+                </a:solidFill>
+                <a:latin typeface="Georgia"/>
+              </a:rPr>
+              <a:t>Escalabilidade</a:t>
+            </a:r>
+          </a:p>
+        </p:txBody>
+      </p:sp>
+      <p:sp>
+        <p:nvSpPr>
+          <p:cNvPr id="6" name="CaixaDeTexto 5">
+            <a:extLst>
+              <a:ext uri="{FF2B5EF4-FFF2-40B4-BE49-F238E27FC236}">
+                <a16:creationId xmlns:a16="http://schemas.microsoft.com/office/drawing/2014/main" id="{F1B271A0-DCA7-144A-B43F-8F2AFE211EEE}"/>
+              </a:ext>
+            </a:extLst>
+          </p:cNvPr>
+          <p:cNvSpPr txBox="1"/>
+          <p:nvPr/>
+        </p:nvSpPr>
+        <p:spPr>
+          <a:xfrm>
+            <a:off x="457200" y="4318000"/>
+            <a:ext cx="3556000" cy="889000"/>
+          </a:xfrm>
+          <a:prstGeom prst="rect">
+            <a:avLst/>
+          </a:prstGeom>
+          <a:noFill/>
+        </p:spPr>
+        <p:txBody>
+          <a:bodyPr vertOverflow="overflow" vert="horz" wrap="square" rtlCol="0" anchor="t">
+            <a:spAutoFit/>
+          </a:bodyPr>
+          <a:lstStyle/>
+          <a:p>
+            <a:pPr algn="l"/>
+            <a:r>
+              <a:rPr lang="pt-PT" sz="1400" dirty="0">
+                <a:solidFill>
+                  <a:srgbClr val="1A2332"/>
+                </a:solidFill>
+                <a:latin typeface="Calibri"/>
+                <a:cs typeface="Calibri"/>
+              </a:rPr>
+              <a:t>Primitivas de </a:t>
+            </a:r>
+            <a:r>
+              <a:rPr lang="pt-PT" sz="1400" dirty="0" err="1">
+                <a:solidFill>
+                  <a:srgbClr val="1A2332"/>
+                </a:solidFill>
+                <a:latin typeface="Calibri"/>
+                <a:cs typeface="Calibri"/>
+              </a:rPr>
+              <a:t>erasure</a:t>
+            </a:r>
+            <a:r>
+              <a:rPr lang="pt-PT" sz="1400" dirty="0">
+                <a:solidFill>
+                  <a:srgbClr val="1A2332"/>
+                </a:solidFill>
+                <a:latin typeface="Calibri"/>
+                <a:cs typeface="Calibri"/>
+              </a:rPr>
+              <a:t> </a:t>
+            </a:r>
+            <a:r>
+              <a:rPr lang="pt-PT" sz="1400" dirty="0" err="1">
+                <a:solidFill>
+                  <a:srgbClr val="1A2332"/>
+                </a:solidFill>
+                <a:latin typeface="Calibri"/>
+                <a:cs typeface="Calibri"/>
+              </a:rPr>
+              <a:t>on-device</a:t>
+            </a:r>
+            <a:r>
+              <a:rPr lang="pt-PT" sz="1400" dirty="0">
+                <a:solidFill>
+                  <a:srgbClr val="1A2332"/>
+                </a:solidFill>
+                <a:latin typeface="Calibri"/>
+                <a:cs typeface="Calibri"/>
+              </a:rPr>
+              <a:t> (</a:t>
+            </a:r>
+            <a:r>
+              <a:rPr lang="pt-PT" sz="1400" dirty="0" err="1">
+                <a:solidFill>
+                  <a:srgbClr val="1A2332"/>
+                </a:solidFill>
+                <a:latin typeface="Calibri"/>
+                <a:cs typeface="Calibri"/>
+              </a:rPr>
+              <a:t>TinyML</a:t>
+            </a:r>
+            <a:r>
+              <a:rPr lang="pt-PT" sz="1400" dirty="0">
+                <a:solidFill>
+                  <a:srgbClr val="1A2332"/>
+                </a:solidFill>
+                <a:latin typeface="Calibri"/>
+                <a:cs typeface="Calibri"/>
+              </a:rPr>
+              <a:t>, </a:t>
+            </a:r>
+            <a:r>
+              <a:rPr lang="pt-PT" sz="1400" dirty="0" err="1">
+                <a:solidFill>
+                  <a:srgbClr val="1A2332"/>
+                </a:solidFill>
+                <a:latin typeface="Calibri"/>
+                <a:cs typeface="Calibri"/>
+              </a:rPr>
+              <a:t>sparse</a:t>
+            </a:r>
+            <a:r>
+              <a:rPr lang="pt-PT" sz="1400" dirty="0">
+                <a:solidFill>
+                  <a:srgbClr val="1A2332"/>
+                </a:solidFill>
+                <a:latin typeface="Calibri"/>
+                <a:cs typeface="Calibri"/>
+              </a:rPr>
+              <a:t> </a:t>
+            </a:r>
+            <a:r>
+              <a:rPr lang="pt-PT" sz="1400" dirty="0" err="1">
+                <a:solidFill>
+                  <a:srgbClr val="1A2332"/>
+                </a:solidFill>
+                <a:latin typeface="Calibri"/>
+                <a:cs typeface="Calibri"/>
+              </a:rPr>
+              <a:t>updates</a:t>
+            </a:r>
+            <a:r>
+              <a:rPr lang="pt-PT" sz="1400" dirty="0">
+                <a:solidFill>
+                  <a:srgbClr val="1A2332"/>
+                </a:solidFill>
+                <a:latin typeface="Calibri"/>
+                <a:cs typeface="Calibri"/>
+              </a:rPr>
+              <a:t>) que caibam em </a:t>
+            </a:r>
+            <a:r>
+              <a:rPr lang="pt-PT" sz="1400" dirty="0" err="1">
+                <a:solidFill>
+                  <a:srgbClr val="1A2332"/>
+                </a:solidFill>
+                <a:latin typeface="Calibri"/>
+                <a:cs typeface="Calibri"/>
+              </a:rPr>
+              <a:t>MCUs</a:t>
+            </a:r>
+            <a:endParaRPr lang="pt-PT" sz="1400" dirty="0">
+              <a:solidFill>
+                <a:srgbClr val="1A2332"/>
+              </a:solidFill>
+              <a:latin typeface="Calibri"/>
+              <a:cs typeface="Calibri"/>
+            </a:endParaRPr>
+          </a:p>
+        </p:txBody>
+      </p:sp>
+      <p:sp>
+        <p:nvSpPr>
+          <p:cNvPr id="7" name="Oval 6">
+            <a:extLst>
+              <a:ext uri="{FF2B5EF4-FFF2-40B4-BE49-F238E27FC236}">
+                <a16:creationId xmlns:a16="http://schemas.microsoft.com/office/drawing/2014/main" id="{E515DE8B-DDC7-1C45-BB89-29C411889968}"/>
+              </a:ext>
+            </a:extLst>
+          </p:cNvPr>
+          <p:cNvSpPr/>
+          <p:nvPr/>
+        </p:nvSpPr>
+        <p:spPr>
+          <a:xfrm>
+            <a:off x="5765800" y="3149600"/>
+            <a:ext cx="660400" cy="660400"/>
+          </a:xfrm>
+          <a:prstGeom prst="ellipse">
+            <a:avLst/>
+          </a:prstGeom>
+          <a:solidFill>
+            <a:srgbClr val="B5511A"/>
+          </a:solidFill>
+          <a:ln w="19050" cap="flat" cmpd="sng" algn="ctr">
+            <a:noFill/>
+            <a:prstDash val="solid"/>
+            <a:miter lim="800000"/>
+          </a:ln>
+        </p:spPr>
+        <p:style>
+          <a:lnRef idx="2">
+            <a:schemeClr val="accent1">
+              <a:shade val="15000"/>
+            </a:schemeClr>
+          </a:lnRef>
+          <a:fillRef idx="1">
+            <a:schemeClr val="accent1"/>
+          </a:fillRef>
+          <a:effectRef idx="0">
+            <a:schemeClr val="accent1"/>
+          </a:effectRef>
+          <a:fontRef idx="minor">
+            <a:schemeClr val="lt1"/>
+          </a:fontRef>
+        </p:style>
+        <p:txBody>
+          <a:bodyPr vertOverflow="clip" horzOverflow="clip" wrap="none" rtlCol="0" anchor="ctr" anchorCtr="0">
+            <a:noAutofit/>
+          </a:bodyPr>
+          <a:lstStyle/>
+          <a:p>
+            <a:pPr algn="l"/>
+            <a:r>
+              <a:rPr lang="pt-PT" sz="2400" b="1">
+                <a:solidFill>
+                  <a:srgbClr val="FFFFFF"/>
+                </a:solidFill>
+                <a:latin typeface="Georgia"/>
+              </a:rPr>
+              <a:t>2</a:t>
+            </a:r>
+          </a:p>
+        </p:txBody>
+      </p:sp>
+      <p:sp>
+        <p:nvSpPr>
+          <p:cNvPr id="8" name="CaixaDeTexto 7">
+            <a:extLst>
+              <a:ext uri="{FF2B5EF4-FFF2-40B4-BE49-F238E27FC236}">
+                <a16:creationId xmlns:a16="http://schemas.microsoft.com/office/drawing/2014/main" id="{F5D6C62E-2312-B342-A6C3-075830E885C8}"/>
+              </a:ext>
+            </a:extLst>
+          </p:cNvPr>
+          <p:cNvSpPr txBox="1"/>
+          <p:nvPr/>
+        </p:nvSpPr>
+        <p:spPr>
+          <a:xfrm>
+            <a:off x="4318000" y="3911600"/>
+            <a:ext cx="3556000" cy="355600"/>
+          </a:xfrm>
+          <a:prstGeom prst="rect">
+            <a:avLst/>
+          </a:prstGeom>
+          <a:noFill/>
+        </p:spPr>
+        <p:txBody>
+          <a:bodyPr vertOverflow="overflow" vert="horz" wrap="square" rtlCol="0" anchor="t">
+            <a:spAutoFit/>
+          </a:bodyPr>
+          <a:lstStyle/>
+          <a:p>
+            <a:pPr algn="l"/>
+            <a:r>
+              <a:rPr lang="pt-PT" b="1">
+                <a:solidFill>
+                  <a:srgbClr val="E97132"/>
+                </a:solidFill>
+                <a:latin typeface="Georgia"/>
+              </a:rPr>
+              <a:t>Verificação</a:t>
+            </a:r>
+          </a:p>
+        </p:txBody>
+      </p:sp>
+      <p:sp>
+        <p:nvSpPr>
+          <p:cNvPr id="9" name="CaixaDeTexto 8">
+            <a:extLst>
+              <a:ext uri="{FF2B5EF4-FFF2-40B4-BE49-F238E27FC236}">
+                <a16:creationId xmlns:a16="http://schemas.microsoft.com/office/drawing/2014/main" id="{F6523AA0-022C-154C-8804-9E925EF75963}"/>
+              </a:ext>
+            </a:extLst>
+          </p:cNvPr>
+          <p:cNvSpPr txBox="1"/>
+          <p:nvPr/>
+        </p:nvSpPr>
+        <p:spPr>
+          <a:xfrm>
+            <a:off x="4318000" y="4318000"/>
+            <a:ext cx="3556000" cy="889000"/>
+          </a:xfrm>
+          <a:prstGeom prst="rect">
+            <a:avLst/>
+          </a:prstGeom>
+          <a:noFill/>
+        </p:spPr>
+        <p:txBody>
+          <a:bodyPr vertOverflow="overflow" vert="horz" wrap="square" rtlCol="0" anchor="t">
+            <a:spAutoFit/>
+          </a:bodyPr>
+          <a:lstStyle/>
+          <a:p>
+            <a:pPr algn="l"/>
+            <a:r>
+              <a:rPr lang="pt-PT" sz="1400" dirty="0">
+                <a:solidFill>
+                  <a:srgbClr val="1A2332"/>
+                </a:solidFill>
+                <a:latin typeface="Calibri"/>
+                <a:cs typeface="Calibri"/>
+              </a:rPr>
+              <a:t>Provas auditáveis via TEE + ZKP + contabilização de privacidade diferencial</a:t>
+            </a:r>
+          </a:p>
+        </p:txBody>
+      </p:sp>
+      <p:sp>
+        <p:nvSpPr>
+          <p:cNvPr id="10" name="Oval 9">
+            <a:extLst>
+              <a:ext uri="{FF2B5EF4-FFF2-40B4-BE49-F238E27FC236}">
+                <a16:creationId xmlns:a16="http://schemas.microsoft.com/office/drawing/2014/main" id="{AA8477AF-7D99-C44C-B184-6DE4F3C85E0B}"/>
+              </a:ext>
+            </a:extLst>
+          </p:cNvPr>
+          <p:cNvSpPr/>
+          <p:nvPr/>
+        </p:nvSpPr>
+        <p:spPr>
+          <a:xfrm>
+            <a:off x="9626600" y="3149600"/>
+            <a:ext cx="660400" cy="660400"/>
+          </a:xfrm>
+          <a:prstGeom prst="ellipse">
+            <a:avLst/>
+          </a:prstGeom>
+          <a:solidFill>
+            <a:srgbClr val="196B24"/>
+          </a:solidFill>
+          <a:ln w="19050" cap="flat" cmpd="sng" algn="ctr">
+            <a:noFill/>
+            <a:prstDash val="solid"/>
+            <a:miter lim="800000"/>
+          </a:ln>
+        </p:spPr>
+        <p:style>
+          <a:lnRef idx="2">
+            <a:schemeClr val="accent1">
+              <a:shade val="15000"/>
+            </a:schemeClr>
+          </a:lnRef>
+          <a:fillRef idx="1">
+            <a:schemeClr val="accent1"/>
+          </a:fillRef>
+          <a:effectRef idx="0">
+            <a:schemeClr val="accent1"/>
+          </a:effectRef>
+          <a:fontRef idx="minor">
+            <a:schemeClr val="lt1"/>
+          </a:fontRef>
+        </p:style>
+        <p:txBody>
+          <a:bodyPr vertOverflow="clip" horzOverflow="clip" wrap="none" rtlCol="0" anchor="ctr" anchorCtr="0">
+            <a:noAutofit/>
+          </a:bodyPr>
+          <a:lstStyle/>
+          <a:p>
+            <a:pPr algn="l"/>
+            <a:r>
+              <a:rPr lang="pt-PT" sz="2400" b="1">
+                <a:solidFill>
+                  <a:srgbClr val="FFFFFF"/>
+                </a:solidFill>
+                <a:latin typeface="Georgia"/>
+              </a:rPr>
+              <a:t>3</a:t>
+            </a:r>
+          </a:p>
+        </p:txBody>
+      </p:sp>
+      <p:sp>
+        <p:nvSpPr>
+          <p:cNvPr id="11" name="CaixaDeTexto 10">
+            <a:extLst>
+              <a:ext uri="{FF2B5EF4-FFF2-40B4-BE49-F238E27FC236}">
+                <a16:creationId xmlns:a16="http://schemas.microsoft.com/office/drawing/2014/main" id="{D2B5A08D-2BC6-294D-8D85-7A577EFF5507}"/>
+              </a:ext>
+            </a:extLst>
+          </p:cNvPr>
+          <p:cNvSpPr txBox="1"/>
+          <p:nvPr/>
+        </p:nvSpPr>
+        <p:spPr>
+          <a:xfrm>
+            <a:off x="8178800" y="3911600"/>
+            <a:ext cx="3556000" cy="355600"/>
+          </a:xfrm>
+          <a:prstGeom prst="rect">
+            <a:avLst/>
+          </a:prstGeom>
+          <a:noFill/>
+        </p:spPr>
+        <p:txBody>
+          <a:bodyPr vertOverflow="overflow" vert="horz" wrap="square" rtlCol="0" anchor="t">
+            <a:spAutoFit/>
+          </a:bodyPr>
+          <a:lstStyle/>
+          <a:p>
+            <a:pPr algn="l"/>
+            <a:r>
+              <a:rPr lang="pt-PT" b="1">
+                <a:solidFill>
+                  <a:srgbClr val="196B24"/>
+                </a:solidFill>
+                <a:latin typeface="Georgia"/>
+              </a:rPr>
+              <a:t>Regulação</a:t>
+            </a:r>
+          </a:p>
+        </p:txBody>
+      </p:sp>
+      <p:sp>
+        <p:nvSpPr>
+          <p:cNvPr id="12" name="CaixaDeTexto 11">
+            <a:extLst>
+              <a:ext uri="{FF2B5EF4-FFF2-40B4-BE49-F238E27FC236}">
+                <a16:creationId xmlns:a16="http://schemas.microsoft.com/office/drawing/2014/main" id="{5934ED8C-06A1-2348-B7E1-FE5CFEE7AEA2}"/>
+              </a:ext>
+            </a:extLst>
+          </p:cNvPr>
+          <p:cNvSpPr txBox="1"/>
+          <p:nvPr/>
+        </p:nvSpPr>
+        <p:spPr>
+          <a:xfrm>
+            <a:off x="8178800" y="4318000"/>
+            <a:ext cx="3556000" cy="889000"/>
+          </a:xfrm>
+          <a:prstGeom prst="rect">
+            <a:avLst/>
+          </a:prstGeom>
+          <a:noFill/>
+        </p:spPr>
+        <p:txBody>
+          <a:bodyPr vertOverflow="overflow" vert="horz" wrap="square" rtlCol="0" anchor="t">
+            <a:spAutoFit/>
+          </a:bodyPr>
+          <a:lstStyle/>
+          <a:p>
+            <a:pPr algn="l"/>
+            <a:r>
+              <a:rPr lang="pt-PT" sz="1400" dirty="0">
+                <a:solidFill>
+                  <a:srgbClr val="1A2332"/>
+                </a:solidFill>
+                <a:latin typeface="Calibri"/>
+                <a:cs typeface="Calibri"/>
+              </a:rPr>
+              <a:t>Alinhamento entre mecanismos técnicos e requisitos legais (RGPD </a:t>
+            </a:r>
+            <a:r>
+              <a:rPr lang="pt-PT" sz="1400" dirty="0" err="1">
+                <a:solidFill>
+                  <a:srgbClr val="1A2332"/>
+                </a:solidFill>
+                <a:latin typeface="Calibri"/>
+                <a:cs typeface="Calibri"/>
+              </a:rPr>
+              <a:t>Art</a:t>
+            </a:r>
+            <a:r>
+              <a:rPr lang="pt-PT" sz="1400" dirty="0">
+                <a:solidFill>
+                  <a:srgbClr val="1A2332"/>
+                </a:solidFill>
+                <a:latin typeface="Calibri"/>
+                <a:cs typeface="Calibri"/>
+              </a:rPr>
+              <a:t>. 17)</a:t>
+            </a:r>
+          </a:p>
+        </p:txBody>
+      </p:sp>
+      <p:sp>
+        <p:nvSpPr>
+          <p:cNvPr id="13" name="Retângulo 12">
+            <a:extLst>
+              <a:ext uri="{FF2B5EF4-FFF2-40B4-BE49-F238E27FC236}">
+                <a16:creationId xmlns:a16="http://schemas.microsoft.com/office/drawing/2014/main" id="{C4774E2B-6863-4649-94A2-F0F2BB120D50}"/>
+              </a:ext>
+            </a:extLst>
+          </p:cNvPr>
+          <p:cNvSpPr/>
+          <p:nvPr/>
+        </p:nvSpPr>
+        <p:spPr>
+          <a:xfrm>
+            <a:off x="4064000" y="5334000"/>
+            <a:ext cx="4064000" cy="25400"/>
+          </a:xfrm>
+          <a:prstGeom prst="rect">
+            <a:avLst/>
+          </a:prstGeom>
+          <a:solidFill>
+            <a:srgbClr val="D0C9C0"/>
+          </a:solidFill>
+          <a:ln w="19050" cap="flat" cmpd="sng" algn="ctr">
+            <a:noFill/>
+            <a:prstDash val="solid"/>
+            <a:miter lim="800000"/>
+          </a:ln>
+        </p:spPr>
+        <p:style>
+          <a:lnRef idx="2">
+            <a:schemeClr val="accent1">
+              <a:shade val="15000"/>
+            </a:schemeClr>
+          </a:lnRef>
+          <a:fillRef idx="1">
+            <a:schemeClr val="accent1"/>
+          </a:fillRef>
+          <a:effectRef idx="0">
+            <a:schemeClr val="accent1"/>
+          </a:effectRef>
+          <a:fontRef idx="minor">
+            <a:schemeClr val="lt1"/>
+          </a:fontRef>
+        </p:style>
+        <p:txBody>
+          <a:bodyPr vertOverflow="clip" horzOverflow="clip" rtlCol="0" anchor="t"/>
+          <a:lstStyle/>
+          <a:p>
+            <a:pPr algn="l"/>
+            <a:endParaRPr lang="pt-PT"/>
+          </a:p>
+        </p:txBody>
+      </p:sp>
+    </p:spTree>
+    <p:extLst>
+      <p:ext uri="{BB962C8B-B14F-4D97-AF65-F5344CB8AC3E}">
+        <p14:creationId xmlns:p14="http://schemas.microsoft.com/office/powerpoint/2010/main" val="3757545887"/>
       </p:ext>
     </p:extLst>
   </p:cSld>

</xml_diff>

<commit_message>
Commit from thinkpad on 29/05/2026, 17:28:28
</commit_message>
<xml_diff>
--- a/Entregas PhD/machine-unlearning.pptx
+++ b/Entregas PhD/machine-unlearning.pptx
@@ -208,7 +208,7 @@
           <a:p>
             <a:fld id="{0D531979-3C4C-B04F-AD49-A1AD3E566F89}" type="datetimeFigureOut">
               <a:rPr lang="pt-PT" smtClean="0"/>
-              <a:t>25/05/26</a:t>
+              <a:t>29/05/26</a:t>
             </a:fld>
             <a:endParaRPr lang="pt-PT"/>
           </a:p>
@@ -519,6 +519,135 @@
           <a:bodyPr/>
           <a:lstStyle/>
           <a:p>
+            <a:r>
+              <a:rPr lang="pt-PT" dirty="0"/>
+              <a:t>Boa tarde a todos. Vou apresentar o meu trabalho sobre "</a:t>
+            </a:r>
+            <a:r>
+              <a:rPr lang="pt-PT" i="1" dirty="0" err="1"/>
+              <a:t>Machine</a:t>
+            </a:r>
+            <a:r>
+              <a:rPr lang="pt-PT" i="1" dirty="0"/>
+              <a:t> </a:t>
+            </a:r>
+            <a:r>
+              <a:rPr lang="pt-PT" i="1" dirty="0" err="1"/>
+              <a:t>Unlearning</a:t>
+            </a:r>
+            <a:r>
+              <a:rPr lang="pt-PT" dirty="0"/>
+              <a:t> para </a:t>
+            </a:r>
+            <a:r>
+              <a:rPr lang="pt-PT" dirty="0" err="1"/>
+              <a:t>IoT</a:t>
+            </a:r>
+            <a:r>
+              <a:rPr lang="pt-PT" dirty="0"/>
+              <a:t> em Edifícios Inteligentes em Comunidades". À medida que integramos a IA mais profundamente nos nossos espaços, enfrentamos um desafio crítico: como garantir a privacidade quando os modelos se recusam a esquecer?</a:t>
+            </a:r>
+          </a:p>
+        </p:txBody>
+      </p:sp>
+      <p:sp>
+        <p:nvSpPr>
+          <p:cNvPr id="4" name="Marcador de Posição do Número do Diapositivo 3"/>
+          <p:cNvSpPr>
+            <a:spLocks noGrp="1"/>
+          </p:cNvSpPr>
+          <p:nvPr>
+            <p:ph type="sldNum" sz="quarter" idx="5"/>
+          </p:nvPr>
+        </p:nvSpPr>
+        <p:spPr/>
+        <p:txBody>
+          <a:bodyPr/>
+          <a:lstStyle/>
+          <a:p>
+            <a:fld id="{4BEEEA3F-08CE-6043-AB76-D392B1207876}" type="slidenum">
+              <a:rPr lang="pt-PT" smtClean="0"/>
+              <a:t>1</a:t>
+            </a:fld>
+            <a:endParaRPr lang="pt-PT"/>
+          </a:p>
+        </p:txBody>
+      </p:sp>
+    </p:spTree>
+    <p:extLst>
+      <p:ext uri="{BB962C8B-B14F-4D97-AF65-F5344CB8AC3E}">
+        <p14:creationId xmlns:p14="http://schemas.microsoft.com/office/powerpoint/2010/main" val="2582094984"/>
+      </p:ext>
+    </p:extLst>
+  </p:cSld>
+  <p:clrMapOvr>
+    <a:masterClrMapping/>
+  </p:clrMapOvr>
+</p:notes>
+</file>
+
+<file path=ppt/notesSlides/notesSlide10.xml><?xml version="1.0" encoding="utf-8"?>
+<p:notes xmlns:a="http://schemas.openxmlformats.org/drawingml/2006/main" xmlns:r="http://schemas.openxmlformats.org/officeDocument/2006/relationships" xmlns:p="http://schemas.openxmlformats.org/presentationml/2006/main">
+  <p:cSld>
+    <p:spTree>
+      <p:nvGrpSpPr>
+        <p:cNvPr id="1" name="">
+          <a:extLst>
+            <a:ext uri="{FF2B5EF4-FFF2-40B4-BE49-F238E27FC236}">
+              <a16:creationId xmlns:a16="http://schemas.microsoft.com/office/drawing/2014/main" id="{1F8B1AD9-2478-B77F-D2D6-4338A5314A25}"/>
+            </a:ext>
+          </a:extLst>
+        </p:cNvPr>
+        <p:cNvGrpSpPr/>
+        <p:nvPr/>
+      </p:nvGrpSpPr>
+      <p:grpSpPr>
+        <a:xfrm>
+          <a:off x="0" y="0"/>
+          <a:ext cx="0" cy="0"/>
+          <a:chOff x="0" y="0"/>
+          <a:chExt cx="0" cy="0"/>
+        </a:xfrm>
+      </p:grpSpPr>
+      <p:sp>
+        <p:nvSpPr>
+          <p:cNvPr id="2" name="Marcador de Posição da Imagem do Diapositivo 1">
+            <a:extLst>
+              <a:ext uri="{FF2B5EF4-FFF2-40B4-BE49-F238E27FC236}">
+                <a16:creationId xmlns:a16="http://schemas.microsoft.com/office/drawing/2014/main" id="{16F87413-56CC-DEE7-3553-988D37435D19}"/>
+              </a:ext>
+            </a:extLst>
+          </p:cNvPr>
+          <p:cNvSpPr>
+            <a:spLocks noGrp="1" noRot="1" noChangeAspect="1"/>
+          </p:cNvSpPr>
+          <p:nvPr>
+            <p:ph type="sldImg"/>
+          </p:nvPr>
+        </p:nvSpPr>
+        <p:spPr/>
+      </p:sp>
+      <p:sp>
+        <p:nvSpPr>
+          <p:cNvPr id="3" name="Marcador de Posição de Notas 2">
+            <a:extLst>
+              <a:ext uri="{FF2B5EF4-FFF2-40B4-BE49-F238E27FC236}">
+                <a16:creationId xmlns:a16="http://schemas.microsoft.com/office/drawing/2014/main" id="{F8B268EE-26D4-B3A7-8374-D6C283F192F2}"/>
+              </a:ext>
+            </a:extLst>
+          </p:cNvPr>
+          <p:cNvSpPr>
+            <a:spLocks noGrp="1"/>
+          </p:cNvSpPr>
+          <p:nvPr>
+            <p:ph type="body" idx="1"/>
+          </p:nvPr>
+        </p:nvSpPr>
+        <p:spPr/>
+        <p:txBody>
+          <a:bodyPr/>
+          <a:lstStyle/>
+          <a:p>
             <a:pPr marL="0" marR="0" lvl="0" indent="0" algn="l" defTabSz="914400" rtl="0" eaLnBrk="1" fontAlgn="auto" latinLnBrk="0" hangingPunct="1">
               <a:lnSpc>
                 <a:spcPct val="100000"/>
@@ -537,38 +666,25 @@
               <a:defRPr/>
             </a:pPr>
             <a:r>
-              <a:rPr lang="pt-PT" sz="1200" dirty="0">
-                <a:solidFill>
-                  <a:srgbClr val="1A2332"/>
-                </a:solidFill>
-                <a:latin typeface="Calibri"/>
-                <a:cs typeface="Calibri"/>
-              </a:rPr>
-              <a:t>Dispositivos </a:t>
-            </a:r>
-            <a:r>
-              <a:rPr lang="pt-PT" sz="1200" dirty="0" err="1">
-                <a:solidFill>
-                  <a:srgbClr val="1A2332"/>
-                </a:solidFill>
-                <a:latin typeface="Calibri"/>
-                <a:cs typeface="Calibri"/>
-              </a:rPr>
-              <a:t>IoT</a:t>
-            </a:r>
-            <a:r>
-              <a:rPr lang="pt-PT" sz="1200" dirty="0">
-                <a:solidFill>
-                  <a:srgbClr val="1A2332"/>
-                </a:solidFill>
-                <a:latin typeface="Calibri"/>
-                <a:cs typeface="Calibri"/>
-              </a:rPr>
-              <a:t> recolhem padrões de ocupação, consumo energético, sinais biométricos e movimento, criando um histórico longitudinal detalhado dos ocupantes.</a:t>
-            </a:r>
-          </a:p>
-          <a:p>
-            <a:endParaRPr lang="pt-PT" dirty="0"/>
+              <a:rPr lang="pt-PT" dirty="0"/>
+              <a:t>A lacuna é significativa. A maior parte da investigação sobre </a:t>
+            </a:r>
+            <a:r>
+              <a:rPr lang="pt-PT" i="1" dirty="0" err="1"/>
+              <a:t>unlearning</a:t>
+            </a:r>
+            <a:r>
+              <a:rPr lang="pt-PT" dirty="0"/>
+              <a:t> é desenvolvida em silos. Descobrimos que apenas uma pequena fração dos métodos considera os limites de recursos da </a:t>
+            </a:r>
+            <a:r>
+              <a:rPr lang="pt-PT" i="1" dirty="0" err="1"/>
+              <a:t>edge</a:t>
+            </a:r>
+            <a:r>
+              <a:rPr lang="pt-PT" dirty="0"/>
+              <a:t>, e ainda menos fornecem o tipo de verificação que um regulador aceitaria como um verdadeiro esquecimento.</a:t>
+            </a:r>
           </a:p>
           <a:p>
             <a:pPr marL="0" marR="0" lvl="0" indent="0" algn="l" defTabSz="914400" rtl="0" eaLnBrk="1" fontAlgn="auto" latinLnBrk="0" hangingPunct="1">
@@ -588,16 +704,13 @@
               <a:tabLst/>
               <a:defRPr/>
             </a:pPr>
-            <a:r>
-              <a:rPr lang="pt-PT" sz="1200" dirty="0">
-                <a:solidFill>
-                  <a:srgbClr val="1A2332"/>
-                </a:solidFill>
-                <a:latin typeface="Calibri"/>
-                <a:cs typeface="Calibri"/>
-              </a:rPr>
-              <a:t>Modelos treinados retêm traços estatísticos exploráveis por ataques de inferência de pertença e inversão de modelo, mesmo após eliminar os dados originais.</a:t>
-            </a:r>
+            <a:endParaRPr lang="pt-PT" sz="1200" i="1" dirty="0">
+              <a:solidFill>
+                <a:srgbClr val="1A2332"/>
+              </a:solidFill>
+              <a:latin typeface="Calibri"/>
+              <a:cs typeface="Calibri"/>
+            </a:endParaRPr>
           </a:p>
           <a:p>
             <a:pPr marL="0" marR="0" lvl="0" indent="0" algn="l" defTabSz="914400" rtl="0" eaLnBrk="1" fontAlgn="auto" latinLnBrk="0" hangingPunct="1">
@@ -617,7 +730,7 @@
               <a:tabLst/>
               <a:defRPr/>
             </a:pPr>
-            <a:endParaRPr lang="pt-PT" sz="1200" dirty="0">
+            <a:endParaRPr lang="pt-PT" sz="1200" i="1" dirty="0">
               <a:solidFill>
                 <a:srgbClr val="1A2332"/>
               </a:solidFill>
@@ -644,100 +757,279 @@
               <a:defRPr/>
             </a:pPr>
             <a:r>
-              <a:rPr lang="pt-PT" sz="1200" dirty="0">
-                <a:solidFill>
-                  <a:srgbClr val="1A2332"/>
-                </a:solidFill>
-                <a:latin typeface="Calibri"/>
-                <a:cs typeface="Calibri"/>
-              </a:rPr>
-              <a:t>RGPD </a:t>
-            </a:r>
-            <a:r>
-              <a:rPr lang="pt-PT" sz="1200" dirty="0" err="1">
-                <a:solidFill>
-                  <a:srgbClr val="1A2332"/>
-                </a:solidFill>
-                <a:latin typeface="Calibri"/>
-                <a:cs typeface="Calibri"/>
-              </a:rPr>
-              <a:t>Art</a:t>
-            </a:r>
-            <a:r>
-              <a:rPr lang="pt-PT" sz="1200" dirty="0">
-                <a:solidFill>
-                  <a:srgbClr val="1A2332"/>
-                </a:solidFill>
-                <a:latin typeface="Calibri"/>
-                <a:cs typeface="Calibri"/>
-              </a:rPr>
-              <a:t>. 17 (direito ao esquecimento) exige eliminar não só os dados, mas a sua influência nos modelos derivados — não basta apagar a fonte.</a:t>
+              <a:rPr lang="pt-PT" sz="1200" i="1" dirty="0">
+                <a:solidFill>
+                  <a:srgbClr val="1A2332"/>
+                </a:solidFill>
+                <a:latin typeface="Calibri"/>
+                <a:cs typeface="Calibri"/>
+              </a:rPr>
+              <a:t>Sem </a:t>
+            </a:r>
+            <a:r>
+              <a:rPr lang="pt-PT" sz="1200" i="1" dirty="0" err="1">
+                <a:solidFill>
+                  <a:srgbClr val="1A2332"/>
+                </a:solidFill>
+                <a:latin typeface="Calibri"/>
+                <a:cs typeface="Calibri"/>
+              </a:rPr>
+              <a:t>benchmark</a:t>
+            </a:r>
+            <a:r>
+              <a:rPr lang="pt-PT" sz="1200" i="1" dirty="0">
+                <a:solidFill>
+                  <a:srgbClr val="1A2332"/>
+                </a:solidFill>
+                <a:latin typeface="Calibri"/>
+                <a:cs typeface="Calibri"/>
+              </a:rPr>
+              <a:t> partilhado: cada estudo usa as suas próprias métricas, </a:t>
+            </a:r>
+            <a:r>
+              <a:rPr lang="pt-PT" sz="1200" i="1" dirty="0" err="1">
+                <a:solidFill>
+                  <a:srgbClr val="1A2332"/>
+                </a:solidFill>
+                <a:latin typeface="Calibri"/>
+                <a:cs typeface="Calibri"/>
+              </a:rPr>
+              <a:t>datasets</a:t>
+            </a:r>
+            <a:r>
+              <a:rPr lang="pt-PT" sz="1200" i="1" dirty="0">
+                <a:solidFill>
+                  <a:srgbClr val="1A2332"/>
+                </a:solidFill>
+                <a:latin typeface="Calibri"/>
+                <a:cs typeface="Calibri"/>
+              </a:rPr>
+              <a:t> e modelos de ameaça — impossível comparar soluções parciais.</a:t>
             </a:r>
           </a:p>
           <a:p>
             <a:endParaRPr lang="pt-PT" dirty="0"/>
           </a:p>
-          <a:p>
-            <a:pPr marL="0" marR="0" lvl="0" indent="0" algn="l" defTabSz="914400" rtl="0" eaLnBrk="1" fontAlgn="auto" latinLnBrk="0" hangingPunct="1">
-              <a:lnSpc>
-                <a:spcPct val="100000"/>
-              </a:lnSpc>
-              <a:spcBef>
-                <a:spcPts val="0"/>
-              </a:spcBef>
-              <a:spcAft>
-                <a:spcPts val="0"/>
-              </a:spcAft>
-              <a:buClrTx/>
-              <a:buSzTx/>
-              <a:buFontTx/>
-              <a:buNone/>
-              <a:tabLst/>
-              <a:defRPr/>
-            </a:pPr>
-            <a:r>
-              <a:rPr lang="pt-PT" i="1" dirty="0" err="1">
-                <a:solidFill>
-                  <a:srgbClr val="1A2332"/>
-                </a:solidFill>
-                <a:latin typeface="Calibri"/>
-                <a:cs typeface="Calibri"/>
-              </a:rPr>
-              <a:t>Machine</a:t>
-            </a:r>
-            <a:r>
-              <a:rPr lang="pt-PT" i="1" dirty="0">
-                <a:solidFill>
-                  <a:srgbClr val="1A2332"/>
-                </a:solidFill>
-                <a:latin typeface="Calibri"/>
-                <a:cs typeface="Calibri"/>
-              </a:rPr>
+        </p:txBody>
+      </p:sp>
+      <p:sp>
+        <p:nvSpPr>
+          <p:cNvPr id="4" name="Marcador de Posição do Número do Diapositivo 3">
+            <a:extLst>
+              <a:ext uri="{FF2B5EF4-FFF2-40B4-BE49-F238E27FC236}">
+                <a16:creationId xmlns:a16="http://schemas.microsoft.com/office/drawing/2014/main" id="{1F1BE4FF-EEA4-2EC9-BDAC-87370AA99461}"/>
+              </a:ext>
+            </a:extLst>
+          </p:cNvPr>
+          <p:cNvSpPr>
+            <a:spLocks noGrp="1"/>
+          </p:cNvSpPr>
+          <p:nvPr>
+            <p:ph type="sldNum" sz="quarter" idx="5"/>
+          </p:nvPr>
+        </p:nvSpPr>
+        <p:spPr/>
+        <p:txBody>
+          <a:bodyPr/>
+          <a:lstStyle/>
+          <a:p>
+            <a:fld id="{4BEEEA3F-08CE-6043-AB76-D392B1207876}" type="slidenum">
+              <a:rPr lang="pt-PT" smtClean="0"/>
+              <a:t>10</a:t>
+            </a:fld>
+            <a:endParaRPr lang="pt-PT"/>
+          </a:p>
+        </p:txBody>
+      </p:sp>
+    </p:spTree>
+    <p:extLst>
+      <p:ext uri="{BB962C8B-B14F-4D97-AF65-F5344CB8AC3E}">
+        <p14:creationId xmlns:p14="http://schemas.microsoft.com/office/powerpoint/2010/main" val="3361521210"/>
+      </p:ext>
+    </p:extLst>
+  </p:cSld>
+  <p:clrMapOvr>
+    <a:masterClrMapping/>
+  </p:clrMapOvr>
+</p:notes>
+</file>
+
+<file path=ppt/notesSlides/notesSlide11.xml><?xml version="1.0" encoding="utf-8"?>
+<p:notes xmlns:a="http://schemas.openxmlformats.org/drawingml/2006/main" xmlns:r="http://schemas.openxmlformats.org/officeDocument/2006/relationships" xmlns:p="http://schemas.openxmlformats.org/presentationml/2006/main">
+  <p:cSld>
+    <p:spTree>
+      <p:nvGrpSpPr>
+        <p:cNvPr id="1" name=""/>
+        <p:cNvGrpSpPr/>
+        <p:nvPr/>
+      </p:nvGrpSpPr>
+      <p:grpSpPr>
+        <a:xfrm>
+          <a:off x="0" y="0"/>
+          <a:ext cx="0" cy="0"/>
+          <a:chOff x="0" y="0"/>
+          <a:chExt cx="0" cy="0"/>
+        </a:xfrm>
+      </p:grpSpPr>
+      <p:sp>
+        <p:nvSpPr>
+          <p:cNvPr id="2" name="Marcador de Posição da Imagem do Diapositivo 1"/>
+          <p:cNvSpPr>
+            <a:spLocks noGrp="1" noRot="1" noChangeAspect="1"/>
+          </p:cNvSpPr>
+          <p:nvPr>
+            <p:ph type="sldImg"/>
+          </p:nvPr>
+        </p:nvSpPr>
+        <p:spPr/>
+      </p:sp>
+      <p:sp>
+        <p:nvSpPr>
+          <p:cNvPr id="3" name="Marcador de Posição de Notas 2"/>
+          <p:cNvSpPr>
+            <a:spLocks noGrp="1"/>
+          </p:cNvSpPr>
+          <p:nvPr>
+            <p:ph type="body" idx="1"/>
+          </p:nvPr>
+        </p:nvSpPr>
+        <p:spPr/>
+        <p:txBody>
+          <a:bodyPr/>
+          <a:lstStyle/>
+          <a:p>
+            <a:r>
+              <a:rPr lang="pt-PT" dirty="0"/>
+              <a:t>Como é que resolvemos isto?</a:t>
+            </a:r>
+          </a:p>
+          <a:p>
+            <a:r>
+              <a:rPr lang="pt-PT" b="1" dirty="0"/>
+              <a:t>Primeiro: Escalabilidade.</a:t>
+            </a:r>
+            <a:r>
+              <a:rPr lang="pt-PT" dirty="0"/>
+              <a:t> Precisamos de "</a:t>
+            </a:r>
+            <a:r>
+              <a:rPr lang="pt-PT" i="1" dirty="0" err="1"/>
+              <a:t>Tiny</a:t>
+            </a:r>
+            <a:r>
+              <a:rPr lang="pt-PT" i="1" dirty="0"/>
               <a:t> </a:t>
             </a:r>
             <a:r>
-              <a:rPr lang="pt-PT" i="1" dirty="0" err="1">
-                <a:solidFill>
-                  <a:srgbClr val="1A2332"/>
-                </a:solidFill>
-                <a:latin typeface="Calibri"/>
-                <a:cs typeface="Calibri"/>
-              </a:rPr>
+              <a:rPr lang="pt-PT" i="1" dirty="0" err="1"/>
+              <a:t>Unlearning</a:t>
+            </a:r>
+            <a:r>
+              <a:rPr lang="pt-PT" dirty="0"/>
+              <a:t>". Em vez de um </a:t>
+            </a:r>
+            <a:r>
+              <a:rPr lang="pt-PT" dirty="0" err="1"/>
+              <a:t>retreino</a:t>
+            </a:r>
+            <a:r>
+              <a:rPr lang="pt-PT" dirty="0"/>
+              <a:t> completo, utilizamos atualizações e aceleração por </a:t>
+            </a:r>
+            <a:r>
+              <a:rPr lang="pt-PT" i="1" dirty="0"/>
+              <a:t>hardware</a:t>
+            </a:r>
+            <a:r>
+              <a:rPr lang="pt-PT" dirty="0"/>
+              <a:t> para realizar o apagamento diretamente no </a:t>
+            </a:r>
+            <a:r>
+              <a:rPr lang="pt-PT" i="1" dirty="0"/>
+              <a:t>hardware</a:t>
+            </a:r>
+            <a:r>
+              <a:rPr lang="pt-PT" dirty="0"/>
+              <a:t> da </a:t>
+            </a:r>
+            <a:r>
+              <a:rPr lang="pt-PT" i="1" dirty="0" err="1"/>
+              <a:t>edge</a:t>
+            </a:r>
+            <a:r>
+              <a:rPr lang="pt-PT" dirty="0"/>
+              <a:t>, sem sobrecarregar o sistema.</a:t>
+            </a:r>
+          </a:p>
+          <a:p>
+            <a:r>
+              <a:rPr lang="pt-PT" b="1" dirty="0"/>
+              <a:t>Segundo: Verificação.</a:t>
+            </a:r>
+            <a:r>
+              <a:rPr lang="pt-PT" dirty="0"/>
+              <a:t> Precisamos de mais do que apenas um "confie em mim" de um fornecedor. Precisamos de certificados e de </a:t>
+            </a:r>
+            <a:r>
+              <a:rPr lang="pt-PT" i="1" dirty="0"/>
+              <a:t>Zero-</a:t>
+            </a:r>
+            <a:r>
+              <a:rPr lang="pt-PT" i="1" dirty="0" err="1"/>
+              <a:t>Knowledge</a:t>
+            </a:r>
+            <a:r>
+              <a:rPr lang="pt-PT" i="1" dirty="0"/>
+              <a:t> </a:t>
+            </a:r>
+            <a:r>
+              <a:rPr lang="pt-PT" i="1" dirty="0" err="1"/>
+              <a:t>Proofs</a:t>
+            </a:r>
+            <a:r>
+              <a:rPr lang="pt-PT" i="1" dirty="0"/>
+              <a:t> </a:t>
+            </a:r>
+            <a:r>
+              <a:rPr lang="pt-PT" dirty="0"/>
+              <a:t>para certificar aos residentes e reguladores que a influência dos seus dados desapareceu verdadeiramente.</a:t>
+            </a:r>
+          </a:p>
+          <a:p>
+            <a:r>
+              <a:rPr lang="pt-PT" dirty="0"/>
+              <a:t>Para concluir, o </a:t>
+            </a:r>
+            <a:r>
+              <a:rPr lang="pt-PT" i="1" dirty="0" err="1"/>
+              <a:t>machine</a:t>
+            </a:r>
+            <a:r>
+              <a:rPr lang="pt-PT" i="1" dirty="0"/>
+              <a:t> </a:t>
+            </a:r>
+            <a:r>
+              <a:rPr lang="pt-PT" i="1" dirty="0" err="1"/>
               <a:t>unlearning</a:t>
             </a:r>
             <a:r>
-              <a:rPr lang="pt-PT" i="1" dirty="0">
-                <a:solidFill>
-                  <a:srgbClr val="1A2332"/>
-                </a:solidFill>
-                <a:latin typeface="Calibri"/>
-                <a:cs typeface="Calibri"/>
-              </a:rPr>
-              <a:t> surge como resposta técnica mas foi concebido para cenários centralizados e estáticos, não para o contexto distribuído dos edifícios inteligentes.</a:t>
-            </a:r>
-          </a:p>
-          <a:p>
-            <a:endParaRPr lang="pt-PT" dirty="0"/>
+              <a:rPr lang="pt-PT" dirty="0"/>
+              <a:t> em edifícios inteligentes não é apenas um problema académico — é uma necessidade regulatória. Precisamos de passar de métodos centrados na </a:t>
+            </a:r>
+            <a:r>
+              <a:rPr lang="pt-PT" i="1" dirty="0" err="1"/>
+              <a:t>cloud</a:t>
+            </a:r>
+            <a:r>
+              <a:rPr lang="pt-PT" dirty="0"/>
+              <a:t> para sistemas distribuídos e verificáveis. </a:t>
+            </a:r>
+          </a:p>
+          <a:p>
+            <a:r>
+              <a:rPr lang="pt-PT" dirty="0"/>
+              <a:t>Obrigado pela vossa atenção, estou agora disponível para qualquer questão.</a:t>
+            </a:r>
           </a:p>
         </p:txBody>
       </p:sp>
@@ -758,7 +1050,7 @@
           <a:p>
             <a:fld id="{4BEEEA3F-08CE-6043-AB76-D392B1207876}" type="slidenum">
               <a:rPr lang="pt-PT" smtClean="0"/>
-              <a:t>2</a:t>
+              <a:t>11</a:t>
             </a:fld>
             <a:endParaRPr lang="pt-PT"/>
           </a:p>
@@ -767,7 +1059,7 @@
     </p:spTree>
     <p:extLst>
       <p:ext uri="{BB962C8B-B14F-4D97-AF65-F5344CB8AC3E}">
-        <p14:creationId xmlns:p14="http://schemas.microsoft.com/office/powerpoint/2010/main" val="840767661"/>
+        <p14:creationId xmlns:p14="http://schemas.microsoft.com/office/powerpoint/2010/main" val="1854154032"/>
       </p:ext>
     </p:extLst>
   </p:cSld>
@@ -840,101 +1132,8 @@
             </a:pPr>
             <a:r>
               <a:rPr lang="pt-PT" dirty="0"/>
-              <a:t>EXACT: </a:t>
-            </a:r>
-            <a:r>
-              <a:rPr lang="pt-PT" sz="1200" dirty="0">
-                <a:solidFill>
-                  <a:srgbClr val="1A2332"/>
-                </a:solidFill>
-                <a:latin typeface="Calibri"/>
-                <a:cs typeface="Calibri"/>
-              </a:rPr>
-              <a:t>Reestrutura o treino para que cada eliminação seja resolvida por </a:t>
-            </a:r>
-            <a:r>
-              <a:rPr lang="pt-PT" sz="1200" dirty="0" err="1">
-                <a:solidFill>
-                  <a:srgbClr val="1A2332"/>
-                </a:solidFill>
-                <a:latin typeface="Calibri"/>
-                <a:cs typeface="Calibri"/>
-              </a:rPr>
-              <a:t>retreino</a:t>
-            </a:r>
-            <a:r>
-              <a:rPr lang="pt-PT" sz="1200" dirty="0">
-                <a:solidFill>
-                  <a:srgbClr val="1A2332"/>
-                </a:solidFill>
-                <a:latin typeface="Calibri"/>
-                <a:cs typeface="Calibri"/>
-              </a:rPr>
-              <a:t> parcial. SISA divide o </a:t>
-            </a:r>
-            <a:r>
-              <a:rPr lang="pt-PT" sz="1200" dirty="0" err="1">
-                <a:solidFill>
-                  <a:srgbClr val="1A2332"/>
-                </a:solidFill>
-                <a:latin typeface="Calibri"/>
-                <a:cs typeface="Calibri"/>
-              </a:rPr>
-              <a:t>dataset</a:t>
-            </a:r>
-            <a:r>
-              <a:rPr lang="pt-PT" sz="1200" dirty="0">
-                <a:solidFill>
-                  <a:srgbClr val="1A2332"/>
-                </a:solidFill>
-                <a:latin typeface="Calibri"/>
-                <a:cs typeface="Calibri"/>
-              </a:rPr>
-              <a:t> em </a:t>
-            </a:r>
-            <a:r>
-              <a:rPr lang="pt-PT" sz="1200" dirty="0" err="1">
-                <a:solidFill>
-                  <a:srgbClr val="1A2332"/>
-                </a:solidFill>
-                <a:latin typeface="Calibri"/>
-                <a:cs typeface="Calibri"/>
-              </a:rPr>
-              <a:t>shards</a:t>
-            </a:r>
-            <a:r>
-              <a:rPr lang="pt-PT" sz="1200" dirty="0">
-                <a:solidFill>
-                  <a:srgbClr val="1A2332"/>
-                </a:solidFill>
-                <a:latin typeface="Calibri"/>
-                <a:cs typeface="Calibri"/>
-              </a:rPr>
-              <a:t> isolados — só o </a:t>
-            </a:r>
-            <a:r>
-              <a:rPr lang="pt-PT" sz="1200" dirty="0" err="1">
-                <a:solidFill>
-                  <a:srgbClr val="1A2332"/>
-                </a:solidFill>
-                <a:latin typeface="Calibri"/>
-                <a:cs typeface="Calibri"/>
-              </a:rPr>
-              <a:t>shard</a:t>
-            </a:r>
-            <a:r>
-              <a:rPr lang="pt-PT" sz="1200" dirty="0">
-                <a:solidFill>
-                  <a:srgbClr val="1A2332"/>
-                </a:solidFill>
-                <a:latin typeface="Calibri"/>
-                <a:cs typeface="Calibri"/>
-              </a:rPr>
-              <a:t> afetado precisa de reestruturação.</a:t>
-            </a:r>
-          </a:p>
-          <a:p>
-            <a:endParaRPr lang="pt-PT" dirty="0"/>
+              <a:t>Os edifícios inteligentes são, essencialmente, ecossistemas de sensores. Estes dispositivos geram pegadas do nosso comportamento. Embora isto otimize o conforto e a energia, cria uma pegada digital massiva. Mesmo que eliminemos os dados em bruto, os modelos treinados com eles retêm vestígios que podem ser explorados.</a:t>
+            </a:r>
           </a:p>
           <a:p>
             <a:pPr marL="0" marR="0" lvl="0" indent="0" algn="l" defTabSz="914400" rtl="0" eaLnBrk="1" fontAlgn="auto" latinLnBrk="0" hangingPunct="1">
@@ -954,22 +1153,6 @@
               <a:tabLst/>
               <a:defRPr/>
             </a:pPr>
-            <a:r>
-              <a:rPr lang="pt-PT" dirty="0"/>
-              <a:t>APPROXIMATE: </a:t>
-            </a:r>
-            <a:r>
-              <a:rPr lang="pt-PT" sz="1200" dirty="0">
-                <a:solidFill>
-                  <a:srgbClr val="1A2332"/>
-                </a:solidFill>
-                <a:latin typeface="Calibri"/>
-                <a:cs typeface="Calibri"/>
-              </a:rPr>
-              <a:t>Atualiza pesos para minimizar o impacto dos dados-alvo, sem garantia de eliminação total. Inclui métodos baseados em gradiente, funções de influência, destilação e refinamento.</a:t>
-            </a:r>
-          </a:p>
-          <a:p>
             <a:endParaRPr lang="pt-PT" dirty="0"/>
           </a:p>
           <a:p>
@@ -991,24 +1174,395 @@
               <a:defRPr/>
             </a:pPr>
             <a:r>
-              <a:rPr lang="pt-PT" sz="1200" i="1" dirty="0" err="1">
-                <a:solidFill>
-                  <a:srgbClr val="1A2332"/>
-                </a:solidFill>
-                <a:latin typeface="Calibri"/>
-                <a:cs typeface="Calibri"/>
-              </a:rPr>
-              <a:t>Trade-off</a:t>
-            </a:r>
-            <a:r>
-              <a:rPr lang="pt-PT" sz="1200" i="1" dirty="0">
-                <a:solidFill>
-                  <a:srgbClr val="1A2332"/>
-                </a:solidFill>
-                <a:latin typeface="Calibri"/>
-                <a:cs typeface="Calibri"/>
-              </a:rPr>
-              <a:t> entre garantia, custo computacional e flexibilidade de implementação — crítico em hardware com recursos limitados.</a:t>
+              <a:rPr lang="pt-PT" dirty="0"/>
+              <a:t>O Artigo 17.º do RGPD, o "Direito ao Esquecimento", exige que as organizações não só eliminem os registos em bruto, mas também qualquer influência derivada.</a:t>
+            </a:r>
+          </a:p>
+          <a:p>
+            <a:pPr marL="0" marR="0" lvl="0" indent="0" algn="l" defTabSz="914400" rtl="0" eaLnBrk="1" fontAlgn="auto" latinLnBrk="0" hangingPunct="1">
+              <a:lnSpc>
+                <a:spcPct val="100000"/>
+              </a:lnSpc>
+              <a:spcBef>
+                <a:spcPts val="0"/>
+              </a:spcBef>
+              <a:spcAft>
+                <a:spcPts val="0"/>
+              </a:spcAft>
+              <a:buClrTx/>
+              <a:buSzTx/>
+              <a:buFontTx/>
+              <a:buNone/>
+              <a:tabLst/>
+              <a:defRPr/>
+            </a:pPr>
+            <a:endParaRPr lang="pt-PT" dirty="0"/>
+          </a:p>
+          <a:p>
+            <a:pPr marL="0" marR="0" lvl="0" indent="0" algn="l" defTabSz="914400" rtl="0" eaLnBrk="1" fontAlgn="auto" latinLnBrk="0" hangingPunct="1">
+              <a:lnSpc>
+                <a:spcPct val="100000"/>
+              </a:lnSpc>
+              <a:spcBef>
+                <a:spcPts val="0"/>
+              </a:spcBef>
+              <a:spcAft>
+                <a:spcPts val="0"/>
+              </a:spcAft>
+              <a:buClrTx/>
+              <a:buSzTx/>
+              <a:buFontTx/>
+              <a:buNone/>
+              <a:tabLst/>
+              <a:defRPr/>
+            </a:pPr>
+            <a:r>
+              <a:rPr lang="pt-PT" dirty="0"/>
+              <a:t>No entanto, a pura remoção de dados em bruto já não é suficiente. Os modelos de </a:t>
+            </a:r>
+            <a:r>
+              <a:rPr lang="pt-PT" i="1" dirty="0" err="1"/>
+              <a:t>machine</a:t>
+            </a:r>
+            <a:r>
+              <a:rPr lang="pt-PT" i="1" dirty="0"/>
+              <a:t> </a:t>
+            </a:r>
+            <a:r>
+              <a:rPr lang="pt-PT" i="1" dirty="0" err="1"/>
+              <a:t>learning</a:t>
+            </a:r>
+            <a:r>
+              <a:rPr lang="pt-PT" dirty="0"/>
+              <a:t> "memorizam" os seus conjuntos de treino. Através de ataques de </a:t>
+            </a:r>
+            <a:r>
+              <a:rPr lang="pt-PT" i="1" dirty="0" err="1"/>
+              <a:t>Membership</a:t>
+            </a:r>
+            <a:r>
+              <a:rPr lang="pt-PT" i="1" dirty="0"/>
+              <a:t> </a:t>
+            </a:r>
+            <a:r>
+              <a:rPr lang="pt-PT" i="1" dirty="0" err="1"/>
+              <a:t>Inference</a:t>
+            </a:r>
+            <a:r>
+              <a:rPr lang="pt-PT" i="1" dirty="0"/>
+              <a:t> ou</a:t>
+            </a:r>
+            <a:r>
+              <a:rPr lang="pt-PT" dirty="0"/>
+              <a:t> </a:t>
+            </a:r>
+            <a:r>
+              <a:rPr lang="pt-PT" i="1" dirty="0" err="1"/>
+              <a:t>Model</a:t>
+            </a:r>
+            <a:r>
+              <a:rPr lang="pt-PT" i="1" dirty="0"/>
+              <a:t> </a:t>
+            </a:r>
+            <a:r>
+              <a:rPr lang="pt-PT" i="1" dirty="0" err="1"/>
+              <a:t>Inversion</a:t>
+            </a:r>
+            <a:r>
+              <a:rPr lang="pt-PT" i="1" dirty="0"/>
+              <a:t>,</a:t>
+            </a:r>
+            <a:r>
+              <a:rPr lang="pt-PT" dirty="0"/>
+              <a:t> um adversário pode reconstruir informações privadas dos residentes. </a:t>
+            </a:r>
+            <a:r>
+              <a:rPr lang="pt-PT" i="1" dirty="0" err="1"/>
+              <a:t>Machine</a:t>
+            </a:r>
+            <a:r>
+              <a:rPr lang="pt-PT" i="1" dirty="0"/>
+              <a:t> </a:t>
+            </a:r>
+            <a:r>
+              <a:rPr lang="pt-PT" i="1" dirty="0" err="1"/>
+              <a:t>Unlearning</a:t>
+            </a:r>
+            <a:r>
+              <a:rPr lang="pt-PT" dirty="0"/>
+              <a:t> </a:t>
+            </a:r>
+            <a:r>
+              <a:rPr lang="pt-PT" dirty="0" err="1"/>
+              <a:t>surje</a:t>
+            </a:r>
+            <a:r>
+              <a:rPr lang="pt-PT" dirty="0"/>
+              <a:t> como a resposta isto — é o processo de remover seletivamente a influência dos dados.</a:t>
+            </a:r>
+          </a:p>
+          <a:p>
+            <a:pPr marL="0" marR="0" lvl="0" indent="0" algn="l" defTabSz="914400" rtl="0" eaLnBrk="1" fontAlgn="auto" latinLnBrk="0" hangingPunct="1">
+              <a:lnSpc>
+                <a:spcPct val="100000"/>
+              </a:lnSpc>
+              <a:spcBef>
+                <a:spcPts val="0"/>
+              </a:spcBef>
+              <a:spcAft>
+                <a:spcPts val="0"/>
+              </a:spcAft>
+              <a:buClrTx/>
+              <a:buSzTx/>
+              <a:buFontTx/>
+              <a:buNone/>
+              <a:tabLst/>
+              <a:defRPr/>
+            </a:pPr>
+            <a:endParaRPr lang="pt-PT" dirty="0"/>
+          </a:p>
+          <a:p>
+            <a:pPr marL="0" marR="0" lvl="0" indent="0" algn="l" defTabSz="914400" rtl="0" eaLnBrk="1" fontAlgn="auto" latinLnBrk="0" hangingPunct="1">
+              <a:lnSpc>
+                <a:spcPct val="100000"/>
+              </a:lnSpc>
+              <a:spcBef>
+                <a:spcPts val="0"/>
+              </a:spcBef>
+              <a:spcAft>
+                <a:spcPts val="0"/>
+              </a:spcAft>
+              <a:buClrTx/>
+              <a:buSzTx/>
+              <a:buFontTx/>
+              <a:buNone/>
+              <a:tabLst/>
+              <a:defRPr/>
+            </a:pPr>
+            <a:endParaRPr lang="pt-PT" sz="1200" dirty="0">
+              <a:solidFill>
+                <a:srgbClr val="1A2332"/>
+              </a:solidFill>
+              <a:latin typeface="Calibri"/>
+              <a:cs typeface="Calibri"/>
+            </a:endParaRPr>
+          </a:p>
+          <a:p>
+            <a:pPr marL="0" marR="0" lvl="0" indent="0" algn="l" defTabSz="914400" rtl="0" eaLnBrk="1" fontAlgn="auto" latinLnBrk="0" hangingPunct="1">
+              <a:lnSpc>
+                <a:spcPct val="100000"/>
+              </a:lnSpc>
+              <a:spcBef>
+                <a:spcPts val="0"/>
+              </a:spcBef>
+              <a:spcAft>
+                <a:spcPts val="0"/>
+              </a:spcAft>
+              <a:buClrTx/>
+              <a:buSzTx/>
+              <a:buFontTx/>
+              <a:buNone/>
+              <a:tabLst/>
+              <a:defRPr/>
+            </a:pPr>
+            <a:r>
+              <a:rPr lang="pt-PT" sz="1200" dirty="0">
+                <a:solidFill>
+                  <a:srgbClr val="1A2332"/>
+                </a:solidFill>
+                <a:latin typeface="Calibri"/>
+                <a:cs typeface="Calibri"/>
+              </a:rPr>
+              <a:t>Dispositivos </a:t>
+            </a:r>
+            <a:r>
+              <a:rPr lang="pt-PT" sz="1200" dirty="0" err="1">
+                <a:solidFill>
+                  <a:srgbClr val="1A2332"/>
+                </a:solidFill>
+                <a:latin typeface="Calibri"/>
+                <a:cs typeface="Calibri"/>
+              </a:rPr>
+              <a:t>IoT</a:t>
+            </a:r>
+            <a:r>
+              <a:rPr lang="pt-PT" sz="1200" dirty="0">
+                <a:solidFill>
+                  <a:srgbClr val="1A2332"/>
+                </a:solidFill>
+                <a:latin typeface="Calibri"/>
+                <a:cs typeface="Calibri"/>
+              </a:rPr>
+              <a:t> recolhem padrões de ocupação, consumo energético, sinais biométricos e movimento, criando um histórico longitudinal detalhado dos ocupantes.</a:t>
+            </a:r>
+          </a:p>
+          <a:p>
+            <a:endParaRPr lang="pt-PT" dirty="0"/>
+          </a:p>
+          <a:p>
+            <a:pPr marL="0" marR="0" lvl="0" indent="0" algn="l" defTabSz="914400" rtl="0" eaLnBrk="1" fontAlgn="auto" latinLnBrk="0" hangingPunct="1">
+              <a:lnSpc>
+                <a:spcPct val="100000"/>
+              </a:lnSpc>
+              <a:spcBef>
+                <a:spcPts val="0"/>
+              </a:spcBef>
+              <a:spcAft>
+                <a:spcPts val="0"/>
+              </a:spcAft>
+              <a:buClrTx/>
+              <a:buSzTx/>
+              <a:buFontTx/>
+              <a:buNone/>
+              <a:tabLst/>
+              <a:defRPr/>
+            </a:pPr>
+            <a:r>
+              <a:rPr lang="pt-PT" sz="1200" dirty="0">
+                <a:solidFill>
+                  <a:srgbClr val="1A2332"/>
+                </a:solidFill>
+                <a:latin typeface="Calibri"/>
+                <a:cs typeface="Calibri"/>
+              </a:rPr>
+              <a:t>Modelos treinados retêm traços estatísticos exploráveis por ataques de inferência de pertença e inversão de modelo, mesmo após eliminar os dados originais.</a:t>
+            </a:r>
+          </a:p>
+          <a:p>
+            <a:pPr marL="0" marR="0" lvl="0" indent="0" algn="l" defTabSz="914400" rtl="0" eaLnBrk="1" fontAlgn="auto" latinLnBrk="0" hangingPunct="1">
+              <a:lnSpc>
+                <a:spcPct val="100000"/>
+              </a:lnSpc>
+              <a:spcBef>
+                <a:spcPts val="0"/>
+              </a:spcBef>
+              <a:spcAft>
+                <a:spcPts val="0"/>
+              </a:spcAft>
+              <a:buClrTx/>
+              <a:buSzTx/>
+              <a:buFontTx/>
+              <a:buNone/>
+              <a:tabLst/>
+              <a:defRPr/>
+            </a:pPr>
+            <a:endParaRPr lang="pt-PT" sz="1200" dirty="0">
+              <a:solidFill>
+                <a:srgbClr val="1A2332"/>
+              </a:solidFill>
+              <a:latin typeface="Calibri"/>
+              <a:cs typeface="Calibri"/>
+            </a:endParaRPr>
+          </a:p>
+          <a:p>
+            <a:pPr marL="0" marR="0" lvl="0" indent="0" algn="l" defTabSz="914400" rtl="0" eaLnBrk="1" fontAlgn="auto" latinLnBrk="0" hangingPunct="1">
+              <a:lnSpc>
+                <a:spcPct val="100000"/>
+              </a:lnSpc>
+              <a:spcBef>
+                <a:spcPts val="0"/>
+              </a:spcBef>
+              <a:spcAft>
+                <a:spcPts val="0"/>
+              </a:spcAft>
+              <a:buClrTx/>
+              <a:buSzTx/>
+              <a:buFontTx/>
+              <a:buNone/>
+              <a:tabLst/>
+              <a:defRPr/>
+            </a:pPr>
+            <a:r>
+              <a:rPr lang="pt-PT" sz="1200" dirty="0">
+                <a:solidFill>
+                  <a:srgbClr val="1A2332"/>
+                </a:solidFill>
+                <a:latin typeface="Calibri"/>
+                <a:cs typeface="Calibri"/>
+              </a:rPr>
+              <a:t>RGPD </a:t>
+            </a:r>
+            <a:r>
+              <a:rPr lang="pt-PT" sz="1200" dirty="0" err="1">
+                <a:solidFill>
+                  <a:srgbClr val="1A2332"/>
+                </a:solidFill>
+                <a:latin typeface="Calibri"/>
+                <a:cs typeface="Calibri"/>
+              </a:rPr>
+              <a:t>Art</a:t>
+            </a:r>
+            <a:r>
+              <a:rPr lang="pt-PT" sz="1200" dirty="0">
+                <a:solidFill>
+                  <a:srgbClr val="1A2332"/>
+                </a:solidFill>
+                <a:latin typeface="Calibri"/>
+                <a:cs typeface="Calibri"/>
+              </a:rPr>
+              <a:t>. 17 (direito ao esquecimento) exige eliminar não só os dados, mas a sua influência nos modelos derivados — não basta apagar a fonte.</a:t>
+            </a:r>
+          </a:p>
+          <a:p>
+            <a:endParaRPr lang="pt-PT" dirty="0"/>
+          </a:p>
+          <a:p>
+            <a:pPr marL="0" marR="0" lvl="0" indent="0" algn="l" defTabSz="914400" rtl="0" eaLnBrk="1" fontAlgn="auto" latinLnBrk="0" hangingPunct="1">
+              <a:lnSpc>
+                <a:spcPct val="100000"/>
+              </a:lnSpc>
+              <a:spcBef>
+                <a:spcPts val="0"/>
+              </a:spcBef>
+              <a:spcAft>
+                <a:spcPts val="0"/>
+              </a:spcAft>
+              <a:buClrTx/>
+              <a:buSzTx/>
+              <a:buFontTx/>
+              <a:buNone/>
+              <a:tabLst/>
+              <a:defRPr/>
+            </a:pPr>
+            <a:r>
+              <a:rPr lang="pt-PT" i="1" dirty="0" err="1">
+                <a:solidFill>
+                  <a:srgbClr val="1A2332"/>
+                </a:solidFill>
+                <a:latin typeface="Calibri"/>
+                <a:cs typeface="Calibri"/>
+              </a:rPr>
+              <a:t>Machine</a:t>
+            </a:r>
+            <a:r>
+              <a:rPr lang="pt-PT" i="1" dirty="0">
+                <a:solidFill>
+                  <a:srgbClr val="1A2332"/>
+                </a:solidFill>
+                <a:latin typeface="Calibri"/>
+                <a:cs typeface="Calibri"/>
+              </a:rPr>
+              <a:t> </a:t>
+            </a:r>
+            <a:r>
+              <a:rPr lang="pt-PT" i="1" dirty="0" err="1">
+                <a:solidFill>
+                  <a:srgbClr val="1A2332"/>
+                </a:solidFill>
+                <a:latin typeface="Calibri"/>
+                <a:cs typeface="Calibri"/>
+              </a:rPr>
+              <a:t>unlearning</a:t>
+            </a:r>
+            <a:r>
+              <a:rPr lang="pt-PT" i="1" dirty="0">
+                <a:solidFill>
+                  <a:srgbClr val="1A2332"/>
+                </a:solidFill>
+                <a:latin typeface="Calibri"/>
+                <a:cs typeface="Calibri"/>
+              </a:rPr>
+              <a:t> surge como resposta técnica mas foi concebido para cenários centralizados e estáticos, não para o contexto distribuído dos edifícios inteligentes.</a:t>
             </a:r>
           </a:p>
           <a:p>
@@ -1033,7 +1587,7 @@
           <a:p>
             <a:fld id="{4BEEEA3F-08CE-6043-AB76-D392B1207876}" type="slidenum">
               <a:rPr lang="pt-PT" smtClean="0"/>
-              <a:t>3</a:t>
+              <a:t>2</a:t>
             </a:fld>
             <a:endParaRPr lang="pt-PT"/>
           </a:p>
@@ -1042,7 +1596,7 @@
     </p:spTree>
     <p:extLst>
       <p:ext uri="{BB962C8B-B14F-4D97-AF65-F5344CB8AC3E}">
-        <p14:creationId xmlns:p14="http://schemas.microsoft.com/office/powerpoint/2010/main" val="863320645"/>
+        <p14:creationId xmlns:p14="http://schemas.microsoft.com/office/powerpoint/2010/main" val="840767661"/>
       </p:ext>
     </p:extLst>
   </p:cSld>
@@ -1114,22 +1668,24 @@
               <a:defRPr/>
             </a:pPr>
             <a:r>
-              <a:rPr lang="pt-PT" sz="1200" dirty="0" err="1">
-                <a:solidFill>
-                  <a:srgbClr val="1A2332"/>
-                </a:solidFill>
-                <a:latin typeface="Calibri"/>
-              </a:rPr>
-              <a:t>Cloud</a:t>
-            </a:r>
-            <a:r>
-              <a:rPr lang="pt-PT" sz="1200" dirty="0">
-                <a:solidFill>
-                  <a:srgbClr val="1A2332"/>
-                </a:solidFill>
-                <a:latin typeface="Calibri"/>
-              </a:rPr>
-              <a:t>: Treino de modelos globais · armazenamento histórico · análise entre edifícios</a:t>
+              <a:rPr lang="pt-PT" dirty="0"/>
+              <a:t>Existem dois paradigmas principais: Exato e Aproximado. A </a:t>
+            </a:r>
+            <a:r>
+              <a:rPr lang="pt-PT" dirty="0" err="1"/>
+              <a:t>desaprendizagem</a:t>
+            </a:r>
+            <a:r>
+              <a:rPr lang="pt-PT" dirty="0"/>
+              <a:t> exata como o método SISA, garante a remoção voltando a treinar partes do modelo, mas é computacionalmente pesada. A </a:t>
+            </a:r>
+            <a:r>
+              <a:rPr lang="pt-PT" dirty="0" err="1"/>
+              <a:t>desaprendizagem</a:t>
+            </a:r>
+            <a:r>
+              <a:rPr lang="pt-PT" dirty="0"/>
+              <a:t> aproximada é mais rápida, mas apenas minimiza a influência até a um limite tolerável — o que a torna mais difícil de garantir esta remoção.</a:t>
             </a:r>
           </a:p>
           <a:p>
@@ -1150,23 +1706,7 @@
               <a:tabLst/>
               <a:defRPr/>
             </a:pPr>
-            <a:r>
-              <a:rPr lang="pt-PT" dirty="0" err="1"/>
-              <a:t>Edge</a:t>
-            </a:r>
-            <a:r>
-              <a:rPr lang="pt-PT" dirty="0"/>
-              <a:t>: </a:t>
-            </a:r>
-            <a:r>
-              <a:rPr lang="pt-PT" sz="1200" dirty="0">
-                <a:solidFill>
-                  <a:srgbClr val="1A2332"/>
-                </a:solidFill>
-                <a:latin typeface="Calibri"/>
-              </a:rPr>
-              <a:t>Agregação · pré-processamento · execução de modelos leves</a:t>
-            </a:r>
+            <a:endParaRPr lang="pt-PT" dirty="0"/>
           </a:p>
           <a:p>
             <a:pPr marL="0" marR="0" lvl="0" indent="0" algn="l" defTabSz="914400" rtl="0" eaLnBrk="1" fontAlgn="auto" latinLnBrk="0" hangingPunct="1">
@@ -1187,12 +1727,8 @@
               <a:defRPr/>
             </a:pPr>
             <a:r>
-              <a:rPr lang="pt-PT" dirty="0" err="1"/>
-              <a:t>Perception</a:t>
-            </a:r>
-            <a:r>
               <a:rPr lang="pt-PT" dirty="0"/>
-              <a:t>: </a:t>
+              <a:t>EXACT: </a:t>
             </a:r>
             <a:r>
               <a:rPr lang="pt-PT" sz="1200" dirty="0">
@@ -1200,8 +1736,9 @@
                   <a:srgbClr val="1A2332"/>
                 </a:solidFill>
                 <a:latin typeface="Calibri"/>
-              </a:rPr>
-              <a:t>Sensores e atuadores no terreno: ocupação, ambiente, contadores, </a:t>
+                <a:cs typeface="Calibri"/>
+              </a:rPr>
+              <a:t>Reestrutura o treino para que cada eliminação seja resolvida por </a:t>
             </a:r>
             <a:r>
               <a:rPr lang="pt-PT" sz="1200" dirty="0" err="1">
@@ -1209,15 +1746,80 @@
                   <a:srgbClr val="1A2332"/>
                 </a:solidFill>
                 <a:latin typeface="Calibri"/>
-              </a:rPr>
-              <a:t>wearables</a:t>
-            </a:r>
-            <a:endParaRPr lang="pt-PT" sz="1200" dirty="0">
-              <a:solidFill>
-                <a:srgbClr val="1A2332"/>
-              </a:solidFill>
-              <a:latin typeface="Calibri"/>
-            </a:endParaRPr>
+                <a:cs typeface="Calibri"/>
+              </a:rPr>
+              <a:t>retreino</a:t>
+            </a:r>
+            <a:r>
+              <a:rPr lang="pt-PT" sz="1200" dirty="0">
+                <a:solidFill>
+                  <a:srgbClr val="1A2332"/>
+                </a:solidFill>
+                <a:latin typeface="Calibri"/>
+                <a:cs typeface="Calibri"/>
+              </a:rPr>
+              <a:t> parcial. SISA divide o </a:t>
+            </a:r>
+            <a:r>
+              <a:rPr lang="pt-PT" sz="1200" dirty="0" err="1">
+                <a:solidFill>
+                  <a:srgbClr val="1A2332"/>
+                </a:solidFill>
+                <a:latin typeface="Calibri"/>
+                <a:cs typeface="Calibri"/>
+              </a:rPr>
+              <a:t>dataset</a:t>
+            </a:r>
+            <a:r>
+              <a:rPr lang="pt-PT" sz="1200" dirty="0">
+                <a:solidFill>
+                  <a:srgbClr val="1A2332"/>
+                </a:solidFill>
+                <a:latin typeface="Calibri"/>
+                <a:cs typeface="Calibri"/>
+              </a:rPr>
+              <a:t> em </a:t>
+            </a:r>
+            <a:r>
+              <a:rPr lang="pt-PT" sz="1200" dirty="0" err="1">
+                <a:solidFill>
+                  <a:srgbClr val="1A2332"/>
+                </a:solidFill>
+                <a:latin typeface="Calibri"/>
+                <a:cs typeface="Calibri"/>
+              </a:rPr>
+              <a:t>shards</a:t>
+            </a:r>
+            <a:r>
+              <a:rPr lang="pt-PT" sz="1200" dirty="0">
+                <a:solidFill>
+                  <a:srgbClr val="1A2332"/>
+                </a:solidFill>
+                <a:latin typeface="Calibri"/>
+                <a:cs typeface="Calibri"/>
+              </a:rPr>
+              <a:t> isolados — só o </a:t>
+            </a:r>
+            <a:r>
+              <a:rPr lang="pt-PT" sz="1200" dirty="0" err="1">
+                <a:solidFill>
+                  <a:srgbClr val="1A2332"/>
+                </a:solidFill>
+                <a:latin typeface="Calibri"/>
+                <a:cs typeface="Calibri"/>
+              </a:rPr>
+              <a:t>shard</a:t>
+            </a:r>
+            <a:r>
+              <a:rPr lang="pt-PT" sz="1200" dirty="0">
+                <a:solidFill>
+                  <a:srgbClr val="1A2332"/>
+                </a:solidFill>
+                <a:latin typeface="Calibri"/>
+                <a:cs typeface="Calibri"/>
+              </a:rPr>
+              <a:t> afetado precisa de reestruturação.</a:t>
+            </a:r>
           </a:p>
           <a:p>
             <a:endParaRPr lang="pt-PT" dirty="0"/>
@@ -1241,26 +1843,63 @@
               <a:defRPr/>
             </a:pPr>
             <a:r>
+              <a:rPr lang="pt-PT" dirty="0"/>
+              <a:t>APPROXIMATE: </a:t>
+            </a:r>
+            <a:r>
               <a:rPr lang="pt-PT" sz="1200" dirty="0">
                 <a:solidFill>
                   <a:srgbClr val="1A2332"/>
                 </a:solidFill>
                 <a:latin typeface="Calibri"/>
-              </a:rPr>
-              <a:t>Um pedido de eliminação tem de propagar-se pelas três camadas. </a:t>
-            </a:r>
+                <a:cs typeface="Calibri"/>
+              </a:rPr>
+              <a:t>Atualiza pesos para minimizar o impacto dos dados-alvo, sem garantia de eliminação total. Inclui métodos baseados em gradiente, funções de influência, destilação e refinamento.</a:t>
+            </a:r>
+          </a:p>
+          <a:p>
             <a:endParaRPr lang="pt-PT" dirty="0"/>
           </a:p>
           <a:p>
-            <a:r>
-              <a:rPr lang="pt-PT" sz="1200" dirty="0">
-                <a:solidFill>
-                  <a:srgbClr val="1A2332"/>
-                </a:solidFill>
-                <a:latin typeface="Calibri"/>
-              </a:rPr>
-              <a:t>Estados parciais — em que apenas uma camada “esquece” — violam o direito ao esquecimento e deixam superfícies para ataques de inferência.</a:t>
-            </a:r>
+            <a:pPr marL="0" marR="0" lvl="0" indent="0" algn="l" defTabSz="914400" rtl="0" eaLnBrk="1" fontAlgn="auto" latinLnBrk="0" hangingPunct="1">
+              <a:lnSpc>
+                <a:spcPct val="100000"/>
+              </a:lnSpc>
+              <a:spcBef>
+                <a:spcPts val="0"/>
+              </a:spcBef>
+              <a:spcAft>
+                <a:spcPts val="0"/>
+              </a:spcAft>
+              <a:buClrTx/>
+              <a:buSzTx/>
+              <a:buFontTx/>
+              <a:buNone/>
+              <a:tabLst/>
+              <a:defRPr/>
+            </a:pPr>
+            <a:r>
+              <a:rPr lang="pt-PT" sz="1200" i="1" dirty="0" err="1">
+                <a:solidFill>
+                  <a:srgbClr val="1A2332"/>
+                </a:solidFill>
+                <a:latin typeface="Calibri"/>
+                <a:cs typeface="Calibri"/>
+              </a:rPr>
+              <a:t>Trade-off</a:t>
+            </a:r>
+            <a:r>
+              <a:rPr lang="pt-PT" sz="1200" i="1" dirty="0">
+                <a:solidFill>
+                  <a:srgbClr val="1A2332"/>
+                </a:solidFill>
+                <a:latin typeface="Calibri"/>
+                <a:cs typeface="Calibri"/>
+              </a:rPr>
+              <a:t> entre garantia, custo computacional e flexibilidade de implementação — crítico em hardware com recursos limitados.</a:t>
+            </a:r>
+          </a:p>
+          <a:p>
             <a:endParaRPr lang="pt-PT" dirty="0"/>
           </a:p>
         </p:txBody>
@@ -1282,7 +1921,7 @@
           <a:p>
             <a:fld id="{4BEEEA3F-08CE-6043-AB76-D392B1207876}" type="slidenum">
               <a:rPr lang="pt-PT" smtClean="0"/>
-              <a:t>4</a:t>
+              <a:t>3</a:t>
             </a:fld>
             <a:endParaRPr lang="pt-PT"/>
           </a:p>
@@ -1291,7 +1930,7 @@
     </p:spTree>
     <p:extLst>
       <p:ext uri="{BB962C8B-B14F-4D97-AF65-F5344CB8AC3E}">
-        <p14:creationId xmlns:p14="http://schemas.microsoft.com/office/powerpoint/2010/main" val="582045854"/>
+        <p14:creationId xmlns:p14="http://schemas.microsoft.com/office/powerpoint/2010/main" val="863320645"/>
       </p:ext>
     </p:extLst>
   </p:cSld>
@@ -1363,61 +2002,65 @@
               <a:defRPr/>
             </a:pPr>
             <a:r>
-              <a:rPr lang="pt-PT" sz="1200" dirty="0">
-                <a:solidFill>
-                  <a:srgbClr val="1A2332"/>
-                </a:solidFill>
-                <a:latin typeface="Calibri"/>
-                <a:cs typeface="Calibri"/>
-              </a:rPr>
-              <a:t>Em edifícios </a:t>
-            </a:r>
-            <a:r>
-              <a:rPr lang="pt-PT" sz="1200" dirty="0" err="1">
-                <a:solidFill>
-                  <a:srgbClr val="1A2332"/>
-                </a:solidFill>
-                <a:latin typeface="Calibri"/>
-                <a:cs typeface="Calibri"/>
-              </a:rPr>
-              <a:t>multi-inquilino</a:t>
-            </a:r>
-            <a:r>
-              <a:rPr lang="pt-PT" sz="1200" dirty="0">
-                <a:solidFill>
-                  <a:srgbClr val="1A2332"/>
-                </a:solidFill>
-                <a:latin typeface="Calibri"/>
-                <a:cs typeface="Calibri"/>
-              </a:rPr>
-              <a:t>, cada ocupante concede consentimento separadamente. Um único pedido de eliminação não pode ser aplicado de forma global ao </a:t>
-            </a:r>
-            <a:r>
-              <a:rPr lang="pt-PT" sz="1200" dirty="0" err="1">
-                <a:solidFill>
-                  <a:srgbClr val="1A2332"/>
-                </a:solidFill>
-                <a:latin typeface="Calibri"/>
-                <a:cs typeface="Calibri"/>
-              </a:rPr>
-              <a:t>dataset</a:t>
-            </a:r>
-            <a:r>
-              <a:rPr lang="pt-PT" sz="1200" dirty="0">
-                <a:solidFill>
-                  <a:srgbClr val="1A2332"/>
-                </a:solidFill>
-                <a:latin typeface="Calibri"/>
-                <a:cs typeface="Calibri"/>
-              </a:rPr>
-              <a:t>.</a:t>
-            </a:r>
-          </a:p>
-          <a:p>
-            <a:endParaRPr lang="pt-PT" dirty="0"/>
-          </a:p>
-          <a:p>
-            <a:endParaRPr lang="pt-PT" dirty="0"/>
+              <a:rPr lang="pt-PT" dirty="0"/>
+              <a:t>Os edifícios inteligentes seguem uma hierarquia em camadas. Perceção para deteção, </a:t>
+            </a:r>
+            <a:r>
+              <a:rPr lang="pt-PT" i="1" dirty="0" err="1"/>
+              <a:t>Edge</a:t>
+            </a:r>
+            <a:r>
+              <a:rPr lang="pt-PT" dirty="0"/>
+              <a:t> para controlo local e </a:t>
+            </a:r>
+            <a:r>
+              <a:rPr lang="pt-PT" i="1" dirty="0" err="1"/>
+              <a:t>Cloud</a:t>
+            </a:r>
+            <a:r>
+              <a:rPr lang="pt-PT" dirty="0"/>
+              <a:t> para otimização global. O </a:t>
+            </a:r>
+            <a:r>
+              <a:rPr lang="pt-PT" i="1" dirty="0" err="1"/>
+              <a:t>machine</a:t>
+            </a:r>
+            <a:r>
+              <a:rPr lang="pt-PT" i="1" dirty="0"/>
+              <a:t> </a:t>
+            </a:r>
+            <a:r>
+              <a:rPr lang="pt-PT" i="1" dirty="0" err="1"/>
+              <a:t>unlearning</a:t>
+            </a:r>
+            <a:r>
+              <a:rPr lang="pt-PT" dirty="0"/>
+              <a:t> deve ocorrer em todas as camadas. Se a </a:t>
+            </a:r>
+            <a:r>
+              <a:rPr lang="pt-PT" i="1" dirty="0" err="1"/>
+              <a:t>cloud</a:t>
+            </a:r>
+            <a:r>
+              <a:rPr lang="pt-PT" dirty="0"/>
+              <a:t> esquecer, mas o </a:t>
+            </a:r>
+            <a:r>
+              <a:rPr lang="pt-PT" i="1" dirty="0" err="1"/>
+              <a:t>gateway</a:t>
+            </a:r>
+            <a:r>
+              <a:rPr lang="pt-PT" dirty="0"/>
+              <a:t> na </a:t>
+            </a:r>
+            <a:r>
+              <a:rPr lang="pt-PT" i="1" dirty="0" err="1"/>
+              <a:t>edge</a:t>
+            </a:r>
+            <a:r>
+              <a:rPr lang="pt-PT" dirty="0"/>
+              <a:t> retiver os pesos do utilizador, significa que o sistema não está em conformidade legal.</a:t>
+            </a:r>
           </a:p>
           <a:p>
             <a:pPr marL="0" marR="0" lvl="0" indent="0" algn="l" defTabSz="914400" rtl="0" eaLnBrk="1" fontAlgn="auto" latinLnBrk="0" hangingPunct="1">
@@ -1437,22 +2080,12 @@
               <a:tabLst/>
               <a:defRPr/>
             </a:pPr>
-            <a:r>
-              <a:rPr lang="pt-PT" sz="1200" dirty="0">
-                <a:solidFill>
-                  <a:srgbClr val="1A2332"/>
-                </a:solidFill>
-                <a:latin typeface="Calibri"/>
-                <a:cs typeface="Calibri"/>
-              </a:rPr>
-              <a:t>Sensores partilhados (corredores, AVAC, contadores comuns) recolhem dados que pertencem simultaneamente a vários inquilinos — o mesmo registo serve treino de múltiplos perfis.</a:t>
-            </a:r>
-          </a:p>
-          <a:p>
-            <a:endParaRPr lang="pt-PT" dirty="0"/>
-          </a:p>
-          <a:p>
-            <a:endParaRPr lang="pt-PT" dirty="0"/>
+            <a:endParaRPr lang="pt-PT" sz="1200" dirty="0">
+              <a:solidFill>
+                <a:srgbClr val="1A2332"/>
+              </a:solidFill>
+              <a:latin typeface="Calibri"/>
+            </a:endParaRPr>
           </a:p>
           <a:p>
             <a:pPr marL="0" marR="0" lvl="0" indent="0" algn="l" defTabSz="914400" rtl="0" eaLnBrk="1" fontAlgn="auto" latinLnBrk="0" hangingPunct="1">
@@ -1473,21 +2106,23 @@
               <a:defRPr/>
             </a:pPr>
             <a:r>
+              <a:rPr lang="pt-PT" sz="1200" dirty="0" err="1">
+                <a:solidFill>
+                  <a:srgbClr val="1A2332"/>
+                </a:solidFill>
+                <a:latin typeface="Calibri"/>
+              </a:rPr>
+              <a:t>Cloud</a:t>
+            </a:r>
+            <a:r>
               <a:rPr lang="pt-PT" sz="1200" dirty="0">
                 <a:solidFill>
                   <a:srgbClr val="1A2332"/>
                 </a:solidFill>
                 <a:latin typeface="Calibri"/>
-                <a:cs typeface="Calibri"/>
-              </a:rPr>
-              <a:t>Eliminar limpamente os dados de um utilizador sem afetar os restantes torna-se quase impossível — restrição operacional fundamental destacada na literatura.</a:t>
-            </a:r>
-          </a:p>
-          <a:p>
-            <a:endParaRPr lang="pt-PT" dirty="0"/>
-          </a:p>
-          <a:p>
-            <a:endParaRPr lang="pt-PT" dirty="0"/>
+              </a:rPr>
+              <a:t>: Treino de modelos globais · armazenamento histórico · análise entre edifícios</a:t>
+            </a:r>
           </a:p>
           <a:p>
             <a:pPr marL="0" marR="0" lvl="0" indent="0" algn="l" defTabSz="914400" rtl="0" eaLnBrk="1" fontAlgn="auto" latinLnBrk="0" hangingPunct="1">
@@ -1508,34 +2143,115 @@
               <a:defRPr/>
             </a:pPr>
             <a:r>
-              <a:rPr lang="pt-PT" sz="1200" i="1" dirty="0">
-                <a:solidFill>
-                  <a:srgbClr val="1A2332"/>
-                </a:solidFill>
-                <a:latin typeface="Calibri"/>
-                <a:cs typeface="Calibri"/>
-              </a:rPr>
-              <a:t>Restrição operacional fundamental: o consentimento não é uniforme nem isolável — define o limite prático de qualquer mecanismo de </a:t>
-            </a:r>
-            <a:r>
-              <a:rPr lang="pt-PT" sz="1200" i="1" dirty="0" err="1">
-                <a:solidFill>
-                  <a:srgbClr val="1A2332"/>
-                </a:solidFill>
-                <a:latin typeface="Calibri"/>
-                <a:cs typeface="Calibri"/>
-              </a:rPr>
-              <a:t>unlearning</a:t>
-            </a:r>
-            <a:r>
-              <a:rPr lang="pt-PT" sz="1200" i="1" dirty="0">
-                <a:solidFill>
-                  <a:srgbClr val="1A2332"/>
-                </a:solidFill>
-                <a:latin typeface="Calibri"/>
-                <a:cs typeface="Calibri"/>
-              </a:rPr>
-              <a:t> em edifícios partilhados.</a:t>
+              <a:rPr lang="pt-PT" dirty="0" err="1"/>
+              <a:t>Edge</a:t>
+            </a:r>
+            <a:r>
+              <a:rPr lang="pt-PT" dirty="0"/>
+              <a:t>: </a:t>
+            </a:r>
+            <a:r>
+              <a:rPr lang="pt-PT" sz="1200" dirty="0">
+                <a:solidFill>
+                  <a:srgbClr val="1A2332"/>
+                </a:solidFill>
+                <a:latin typeface="Calibri"/>
+              </a:rPr>
+              <a:t>Agregação · pré-processamento · execução de modelos leves</a:t>
+            </a:r>
+          </a:p>
+          <a:p>
+            <a:pPr marL="0" marR="0" lvl="0" indent="0" algn="l" defTabSz="914400" rtl="0" eaLnBrk="1" fontAlgn="auto" latinLnBrk="0" hangingPunct="1">
+              <a:lnSpc>
+                <a:spcPct val="100000"/>
+              </a:lnSpc>
+              <a:spcBef>
+                <a:spcPts val="0"/>
+              </a:spcBef>
+              <a:spcAft>
+                <a:spcPts val="0"/>
+              </a:spcAft>
+              <a:buClrTx/>
+              <a:buSzTx/>
+              <a:buFontTx/>
+              <a:buNone/>
+              <a:tabLst/>
+              <a:defRPr/>
+            </a:pPr>
+            <a:r>
+              <a:rPr lang="pt-PT" dirty="0" err="1"/>
+              <a:t>Perception</a:t>
+            </a:r>
+            <a:r>
+              <a:rPr lang="pt-PT" dirty="0"/>
+              <a:t>: </a:t>
+            </a:r>
+            <a:r>
+              <a:rPr lang="pt-PT" sz="1200" dirty="0">
+                <a:solidFill>
+                  <a:srgbClr val="1A2332"/>
+                </a:solidFill>
+                <a:latin typeface="Calibri"/>
+              </a:rPr>
+              <a:t>Sensores e atuadores no terreno: ocupação, ambiente, contadores, </a:t>
+            </a:r>
+            <a:r>
+              <a:rPr lang="pt-PT" sz="1200" dirty="0" err="1">
+                <a:solidFill>
+                  <a:srgbClr val="1A2332"/>
+                </a:solidFill>
+                <a:latin typeface="Calibri"/>
+              </a:rPr>
+              <a:t>wearables</a:t>
+            </a:r>
+            <a:endParaRPr lang="pt-PT" sz="1200" dirty="0">
+              <a:solidFill>
+                <a:srgbClr val="1A2332"/>
+              </a:solidFill>
+              <a:latin typeface="Calibri"/>
+            </a:endParaRPr>
+          </a:p>
+          <a:p>
+            <a:endParaRPr lang="pt-PT" dirty="0"/>
+          </a:p>
+          <a:p>
+            <a:pPr marL="0" marR="0" lvl="0" indent="0" algn="l" defTabSz="914400" rtl="0" eaLnBrk="1" fontAlgn="auto" latinLnBrk="0" hangingPunct="1">
+              <a:lnSpc>
+                <a:spcPct val="100000"/>
+              </a:lnSpc>
+              <a:spcBef>
+                <a:spcPts val="0"/>
+              </a:spcBef>
+              <a:spcAft>
+                <a:spcPts val="0"/>
+              </a:spcAft>
+              <a:buClrTx/>
+              <a:buSzTx/>
+              <a:buFontTx/>
+              <a:buNone/>
+              <a:tabLst/>
+              <a:defRPr/>
+            </a:pPr>
+            <a:r>
+              <a:rPr lang="pt-PT" sz="1200" dirty="0">
+                <a:solidFill>
+                  <a:srgbClr val="1A2332"/>
+                </a:solidFill>
+                <a:latin typeface="Calibri"/>
+              </a:rPr>
+              <a:t>Um pedido de eliminação tem de propagar-se pelas três camadas. </a:t>
+            </a:r>
+            <a:endParaRPr lang="pt-PT" dirty="0"/>
+          </a:p>
+          <a:p>
+            <a:r>
+              <a:rPr lang="pt-PT" sz="1200" dirty="0">
+                <a:solidFill>
+                  <a:srgbClr val="1A2332"/>
+                </a:solidFill>
+                <a:latin typeface="Calibri"/>
+              </a:rPr>
+              <a:t>Estados parciais — em que apenas uma camada “esquece” — violam o direito ao esquecimento e deixam superfícies para ataques de inferência.</a:t>
             </a:r>
             <a:endParaRPr lang="pt-PT" dirty="0"/>
           </a:p>
@@ -1558,7 +2274,7 @@
           <a:p>
             <a:fld id="{4BEEEA3F-08CE-6043-AB76-D392B1207876}" type="slidenum">
               <a:rPr lang="pt-PT" smtClean="0"/>
-              <a:t>5</a:t>
+              <a:t>4</a:t>
             </a:fld>
             <a:endParaRPr lang="pt-PT"/>
           </a:p>
@@ -1567,7 +2283,7 @@
     </p:spTree>
     <p:extLst>
       <p:ext uri="{BB962C8B-B14F-4D97-AF65-F5344CB8AC3E}">
-        <p14:creationId xmlns:p14="http://schemas.microsoft.com/office/powerpoint/2010/main" val="3370395725"/>
+        <p14:creationId xmlns:p14="http://schemas.microsoft.com/office/powerpoint/2010/main" val="582045854"/>
       </p:ext>
     </p:extLst>
   </p:cSld>
@@ -1639,6 +2355,410 @@
               <a:defRPr/>
             </a:pPr>
             <a:r>
+              <a:rPr lang="pt-PT" dirty="0"/>
+              <a:t>Ao contrário de, por exemplo, um telemóvel pessoal, os dados dos edifícios estão entrelaçados. Se um inquilino num escritório partilhado retirar o consentimento, os seus dados que estão misturados com os dos seus colegas nos mesmos sensores ambientais. Remover a influência de um utilizador sem degradar o desempenho do modelo para todos os outros é um grande obstáculo.</a:t>
+            </a:r>
+          </a:p>
+          <a:p>
+            <a:pPr marL="0" marR="0" lvl="0" indent="0" algn="l" defTabSz="914400" rtl="0" eaLnBrk="1" fontAlgn="auto" latinLnBrk="0" hangingPunct="1">
+              <a:lnSpc>
+                <a:spcPct val="100000"/>
+              </a:lnSpc>
+              <a:spcBef>
+                <a:spcPts val="0"/>
+              </a:spcBef>
+              <a:spcAft>
+                <a:spcPts val="0"/>
+              </a:spcAft>
+              <a:buClrTx/>
+              <a:buSzTx/>
+              <a:buFontTx/>
+              <a:buNone/>
+              <a:tabLst/>
+              <a:defRPr/>
+            </a:pPr>
+            <a:endParaRPr lang="pt-PT" sz="1200" dirty="0">
+              <a:solidFill>
+                <a:srgbClr val="1A2332"/>
+              </a:solidFill>
+              <a:latin typeface="Calibri"/>
+              <a:cs typeface="Calibri"/>
+            </a:endParaRPr>
+          </a:p>
+          <a:p>
+            <a:pPr marL="0" marR="0" lvl="0" indent="0" algn="l" defTabSz="914400" rtl="0" eaLnBrk="1" fontAlgn="auto" latinLnBrk="0" hangingPunct="1">
+              <a:lnSpc>
+                <a:spcPct val="100000"/>
+              </a:lnSpc>
+              <a:spcBef>
+                <a:spcPts val="0"/>
+              </a:spcBef>
+              <a:spcAft>
+                <a:spcPts val="0"/>
+              </a:spcAft>
+              <a:buClrTx/>
+              <a:buSzTx/>
+              <a:buFontTx/>
+              <a:buNone/>
+              <a:tabLst/>
+              <a:defRPr/>
+            </a:pPr>
+            <a:r>
+              <a:rPr lang="pt-PT" sz="1200" dirty="0">
+                <a:solidFill>
+                  <a:srgbClr val="1A2332"/>
+                </a:solidFill>
+                <a:latin typeface="Calibri"/>
+                <a:cs typeface="Calibri"/>
+              </a:rPr>
+              <a:t>Em edifícios </a:t>
+            </a:r>
+            <a:r>
+              <a:rPr lang="pt-PT" sz="1200" dirty="0" err="1">
+                <a:solidFill>
+                  <a:srgbClr val="1A2332"/>
+                </a:solidFill>
+                <a:latin typeface="Calibri"/>
+                <a:cs typeface="Calibri"/>
+              </a:rPr>
+              <a:t>multi-inquilino</a:t>
+            </a:r>
+            <a:r>
+              <a:rPr lang="pt-PT" sz="1200" dirty="0">
+                <a:solidFill>
+                  <a:srgbClr val="1A2332"/>
+                </a:solidFill>
+                <a:latin typeface="Calibri"/>
+                <a:cs typeface="Calibri"/>
+              </a:rPr>
+              <a:t>, cada ocupante concede consentimento separadamente. Um único pedido de eliminação não pode ser aplicado de forma global ao </a:t>
+            </a:r>
+            <a:r>
+              <a:rPr lang="pt-PT" sz="1200" dirty="0" err="1">
+                <a:solidFill>
+                  <a:srgbClr val="1A2332"/>
+                </a:solidFill>
+                <a:latin typeface="Calibri"/>
+                <a:cs typeface="Calibri"/>
+              </a:rPr>
+              <a:t>dataset</a:t>
+            </a:r>
+            <a:r>
+              <a:rPr lang="pt-PT" sz="1200" dirty="0">
+                <a:solidFill>
+                  <a:srgbClr val="1A2332"/>
+                </a:solidFill>
+                <a:latin typeface="Calibri"/>
+                <a:cs typeface="Calibri"/>
+              </a:rPr>
+              <a:t>.</a:t>
+            </a:r>
+          </a:p>
+          <a:p>
+            <a:endParaRPr lang="pt-PT" dirty="0"/>
+          </a:p>
+          <a:p>
+            <a:endParaRPr lang="pt-PT" dirty="0"/>
+          </a:p>
+          <a:p>
+            <a:pPr marL="0" marR="0" lvl="0" indent="0" algn="l" defTabSz="914400" rtl="0" eaLnBrk="1" fontAlgn="auto" latinLnBrk="0" hangingPunct="1">
+              <a:lnSpc>
+                <a:spcPct val="100000"/>
+              </a:lnSpc>
+              <a:spcBef>
+                <a:spcPts val="0"/>
+              </a:spcBef>
+              <a:spcAft>
+                <a:spcPts val="0"/>
+              </a:spcAft>
+              <a:buClrTx/>
+              <a:buSzTx/>
+              <a:buFontTx/>
+              <a:buNone/>
+              <a:tabLst/>
+              <a:defRPr/>
+            </a:pPr>
+            <a:r>
+              <a:rPr lang="pt-PT" sz="1200" dirty="0">
+                <a:solidFill>
+                  <a:srgbClr val="1A2332"/>
+                </a:solidFill>
+                <a:latin typeface="Calibri"/>
+                <a:cs typeface="Calibri"/>
+              </a:rPr>
+              <a:t>Sensores partilhados (corredores, AVAC, contadores comuns) recolhem dados que pertencem simultaneamente a vários inquilinos — o mesmo registo serve treino de múltiplos perfis.</a:t>
+            </a:r>
+          </a:p>
+          <a:p>
+            <a:endParaRPr lang="pt-PT" dirty="0"/>
+          </a:p>
+          <a:p>
+            <a:endParaRPr lang="pt-PT" dirty="0"/>
+          </a:p>
+          <a:p>
+            <a:pPr marL="0" marR="0" lvl="0" indent="0" algn="l" defTabSz="914400" rtl="0" eaLnBrk="1" fontAlgn="auto" latinLnBrk="0" hangingPunct="1">
+              <a:lnSpc>
+                <a:spcPct val="100000"/>
+              </a:lnSpc>
+              <a:spcBef>
+                <a:spcPts val="0"/>
+              </a:spcBef>
+              <a:spcAft>
+                <a:spcPts val="0"/>
+              </a:spcAft>
+              <a:buClrTx/>
+              <a:buSzTx/>
+              <a:buFontTx/>
+              <a:buNone/>
+              <a:tabLst/>
+              <a:defRPr/>
+            </a:pPr>
+            <a:r>
+              <a:rPr lang="pt-PT" sz="1200" dirty="0">
+                <a:solidFill>
+                  <a:srgbClr val="1A2332"/>
+                </a:solidFill>
+                <a:latin typeface="Calibri"/>
+                <a:cs typeface="Calibri"/>
+              </a:rPr>
+              <a:t>Eliminar limpamente os dados de um utilizador sem afetar os restantes torna-se quase impossível — restrição operacional fundamental destacada na literatura.</a:t>
+            </a:r>
+          </a:p>
+          <a:p>
+            <a:endParaRPr lang="pt-PT" dirty="0"/>
+          </a:p>
+          <a:p>
+            <a:endParaRPr lang="pt-PT" dirty="0"/>
+          </a:p>
+          <a:p>
+            <a:pPr marL="0" marR="0" lvl="0" indent="0" algn="l" defTabSz="914400" rtl="0" eaLnBrk="1" fontAlgn="auto" latinLnBrk="0" hangingPunct="1">
+              <a:lnSpc>
+                <a:spcPct val="100000"/>
+              </a:lnSpc>
+              <a:spcBef>
+                <a:spcPts val="0"/>
+              </a:spcBef>
+              <a:spcAft>
+                <a:spcPts val="0"/>
+              </a:spcAft>
+              <a:buClrTx/>
+              <a:buSzTx/>
+              <a:buFontTx/>
+              <a:buNone/>
+              <a:tabLst/>
+              <a:defRPr/>
+            </a:pPr>
+            <a:r>
+              <a:rPr lang="pt-PT" sz="1200" i="1" dirty="0">
+                <a:solidFill>
+                  <a:srgbClr val="1A2332"/>
+                </a:solidFill>
+                <a:latin typeface="Calibri"/>
+                <a:cs typeface="Calibri"/>
+              </a:rPr>
+              <a:t>Restrição operacional fundamental: o consentimento não é uniforme nem isolável — define o limite prático de qualquer mecanismo de </a:t>
+            </a:r>
+            <a:r>
+              <a:rPr lang="pt-PT" sz="1200" i="1" dirty="0" err="1">
+                <a:solidFill>
+                  <a:srgbClr val="1A2332"/>
+                </a:solidFill>
+                <a:latin typeface="Calibri"/>
+                <a:cs typeface="Calibri"/>
+              </a:rPr>
+              <a:t>unlearning</a:t>
+            </a:r>
+            <a:r>
+              <a:rPr lang="pt-PT" sz="1200" i="1" dirty="0">
+                <a:solidFill>
+                  <a:srgbClr val="1A2332"/>
+                </a:solidFill>
+                <a:latin typeface="Calibri"/>
+                <a:cs typeface="Calibri"/>
+              </a:rPr>
+              <a:t> em edifícios partilhados.</a:t>
+            </a:r>
+            <a:endParaRPr lang="pt-PT" dirty="0"/>
+          </a:p>
+        </p:txBody>
+      </p:sp>
+      <p:sp>
+        <p:nvSpPr>
+          <p:cNvPr id="4" name="Marcador de Posição do Número do Diapositivo 3"/>
+          <p:cNvSpPr>
+            <a:spLocks noGrp="1"/>
+          </p:cNvSpPr>
+          <p:nvPr>
+            <p:ph type="sldNum" sz="quarter" idx="5"/>
+          </p:nvPr>
+        </p:nvSpPr>
+        <p:spPr/>
+        <p:txBody>
+          <a:bodyPr/>
+          <a:lstStyle/>
+          <a:p>
+            <a:fld id="{4BEEEA3F-08CE-6043-AB76-D392B1207876}" type="slidenum">
+              <a:rPr lang="pt-PT" smtClean="0"/>
+              <a:t>5</a:t>
+            </a:fld>
+            <a:endParaRPr lang="pt-PT"/>
+          </a:p>
+        </p:txBody>
+      </p:sp>
+    </p:spTree>
+    <p:extLst>
+      <p:ext uri="{BB962C8B-B14F-4D97-AF65-F5344CB8AC3E}">
+        <p14:creationId xmlns:p14="http://schemas.microsoft.com/office/powerpoint/2010/main" val="3370395725"/>
+      </p:ext>
+    </p:extLst>
+  </p:cSld>
+  <p:clrMapOvr>
+    <a:masterClrMapping/>
+  </p:clrMapOvr>
+</p:notes>
+</file>
+
+<file path=ppt/notesSlides/notesSlide6.xml><?xml version="1.0" encoding="utf-8"?>
+<p:notes xmlns:a="http://schemas.openxmlformats.org/drawingml/2006/main" xmlns:r="http://schemas.openxmlformats.org/officeDocument/2006/relationships" xmlns:p="http://schemas.openxmlformats.org/presentationml/2006/main">
+  <p:cSld>
+    <p:spTree>
+      <p:nvGrpSpPr>
+        <p:cNvPr id="1" name=""/>
+        <p:cNvGrpSpPr/>
+        <p:nvPr/>
+      </p:nvGrpSpPr>
+      <p:grpSpPr>
+        <a:xfrm>
+          <a:off x="0" y="0"/>
+          <a:ext cx="0" cy="0"/>
+          <a:chOff x="0" y="0"/>
+          <a:chExt cx="0" cy="0"/>
+        </a:xfrm>
+      </p:grpSpPr>
+      <p:sp>
+        <p:nvSpPr>
+          <p:cNvPr id="2" name="Marcador de Posição da Imagem do Diapositivo 1"/>
+          <p:cNvSpPr>
+            <a:spLocks noGrp="1" noRot="1" noChangeAspect="1"/>
+          </p:cNvSpPr>
+          <p:nvPr>
+            <p:ph type="sldImg"/>
+          </p:nvPr>
+        </p:nvSpPr>
+        <p:spPr/>
+      </p:sp>
+      <p:sp>
+        <p:nvSpPr>
+          <p:cNvPr id="3" name="Marcador de Posição de Notas 2"/>
+          <p:cNvSpPr>
+            <a:spLocks noGrp="1"/>
+          </p:cNvSpPr>
+          <p:nvPr>
+            <p:ph type="body" idx="1"/>
+          </p:nvPr>
+        </p:nvSpPr>
+        <p:spPr/>
+        <p:txBody>
+          <a:bodyPr/>
+          <a:lstStyle/>
+          <a:p>
+            <a:pPr marL="0" marR="0" lvl="0" indent="0" algn="l" defTabSz="914400" rtl="0" eaLnBrk="1" fontAlgn="auto" latinLnBrk="0" hangingPunct="1">
+              <a:lnSpc>
+                <a:spcPct val="100000"/>
+              </a:lnSpc>
+              <a:spcBef>
+                <a:spcPts val="0"/>
+              </a:spcBef>
+              <a:spcAft>
+                <a:spcPts val="0"/>
+              </a:spcAft>
+              <a:buClrTx/>
+              <a:buSzTx/>
+              <a:buFontTx/>
+              <a:buNone/>
+              <a:tabLst/>
+              <a:defRPr/>
+            </a:pPr>
+            <a:r>
+              <a:rPr lang="pt-PT" dirty="0"/>
+              <a:t>Quando olhamos para os métodos atuais, vemos lacunas claras. Os métodos na </a:t>
+            </a:r>
+            <a:r>
+              <a:rPr lang="pt-PT" i="1" dirty="0" err="1"/>
+              <a:t>cloud</a:t>
+            </a:r>
+            <a:r>
+              <a:rPr lang="pt-PT" dirty="0"/>
+              <a:t>, ignoram as limitações da </a:t>
+            </a:r>
+            <a:r>
+              <a:rPr lang="pt-PT" i="1" dirty="0" err="1"/>
+              <a:t>edge</a:t>
+            </a:r>
+            <a:r>
+              <a:rPr lang="pt-PT" i="1" dirty="0"/>
+              <a:t>.</a:t>
+            </a:r>
+            <a:r>
+              <a:rPr lang="pt-PT" dirty="0"/>
+              <a:t> No lado da </a:t>
+            </a:r>
+            <a:r>
+              <a:rPr lang="pt-PT" i="1" dirty="0" err="1"/>
+              <a:t>edge</a:t>
+            </a:r>
+            <a:r>
+              <a:rPr lang="pt-PT" dirty="0"/>
+              <a:t> a solução é rápida, mas ignora a hierarquia de múltiplos inquilinos. A </a:t>
+            </a:r>
+            <a:r>
+              <a:rPr lang="pt-PT" dirty="0" err="1"/>
+              <a:t>desaprendizagem</a:t>
+            </a:r>
+            <a:r>
+              <a:rPr lang="pt-PT" dirty="0"/>
+              <a:t> federada existe, mas enfraquece a própria garantia de "apagamento", baseando-se frequentemente em provas estatísticas em vez de certezas.</a:t>
+            </a:r>
+          </a:p>
+          <a:p>
+            <a:pPr marL="0" marR="0" lvl="0" indent="0" algn="l" defTabSz="914400" rtl="0" eaLnBrk="1" fontAlgn="auto" latinLnBrk="0" hangingPunct="1">
+              <a:lnSpc>
+                <a:spcPct val="100000"/>
+              </a:lnSpc>
+              <a:spcBef>
+                <a:spcPts val="0"/>
+              </a:spcBef>
+              <a:spcAft>
+                <a:spcPts val="0"/>
+              </a:spcAft>
+              <a:buClrTx/>
+              <a:buSzTx/>
+              <a:buFontTx/>
+              <a:buNone/>
+              <a:tabLst/>
+              <a:defRPr/>
+            </a:pPr>
+            <a:endParaRPr lang="pt-PT" dirty="0"/>
+          </a:p>
+          <a:p>
+            <a:pPr marL="0" marR="0" lvl="0" indent="0" algn="l" defTabSz="914400" rtl="0" eaLnBrk="1" fontAlgn="auto" latinLnBrk="0" hangingPunct="1">
+              <a:lnSpc>
+                <a:spcPct val="100000"/>
+              </a:lnSpc>
+              <a:spcBef>
+                <a:spcPts val="0"/>
+              </a:spcBef>
+              <a:spcAft>
+                <a:spcPts val="0"/>
+              </a:spcAft>
+              <a:buClrTx/>
+              <a:buSzTx/>
+              <a:buFontTx/>
+              <a:buNone/>
+              <a:tabLst/>
+              <a:defRPr/>
+            </a:pPr>
+            <a:r>
               <a:rPr lang="pt-PT" sz="1200" i="1" dirty="0">
                 <a:solidFill>
                   <a:srgbClr val="1A2332"/>
@@ -1730,7 +2850,7 @@
 </p:notes>
 </file>
 
-<file path=ppt/notesSlides/notesSlide6.xml><?xml version="1.0" encoding="utf-8"?>
+<file path=ppt/notesSlides/notesSlide7.xml><?xml version="1.0" encoding="utf-8"?>
 <p:notes xmlns:a="http://schemas.openxmlformats.org/drawingml/2006/main" xmlns:r="http://schemas.openxmlformats.org/officeDocument/2006/relationships" xmlns:p="http://schemas.openxmlformats.org/presentationml/2006/main">
   <p:cSld>
     <p:spTree>
@@ -1810,6 +2930,91 @@
               <a:defRPr/>
             </a:pPr>
             <a:r>
+              <a:rPr lang="pt-PT" dirty="0"/>
+              <a:t>Quando olhamos para os métodos atuais, vemos lacunas claras. Os métodos na </a:t>
+            </a:r>
+            <a:r>
+              <a:rPr lang="pt-PT" i="1" dirty="0" err="1"/>
+              <a:t>cloud</a:t>
+            </a:r>
+            <a:r>
+              <a:rPr lang="pt-PT" dirty="0"/>
+              <a:t>, ignoram as limitações da </a:t>
+            </a:r>
+            <a:r>
+              <a:rPr lang="pt-PT" i="1" dirty="0" err="1"/>
+              <a:t>edge</a:t>
+            </a:r>
+            <a:r>
+              <a:rPr lang="pt-PT" i="1" dirty="0"/>
+              <a:t>.</a:t>
+            </a:r>
+            <a:r>
+              <a:rPr lang="pt-PT" dirty="0"/>
+              <a:t> No lado da </a:t>
+            </a:r>
+            <a:r>
+              <a:rPr lang="pt-PT" i="1" dirty="0" err="1"/>
+              <a:t>edge</a:t>
+            </a:r>
+            <a:r>
+              <a:rPr lang="pt-PT" dirty="0"/>
+              <a:t> a solução é rápida, mas ignora a hierarquia de múltiplos inquilinos. A </a:t>
+            </a:r>
+            <a:r>
+              <a:rPr lang="pt-PT" dirty="0" err="1"/>
+              <a:t>desaprendizagem</a:t>
+            </a:r>
+            <a:r>
+              <a:rPr lang="pt-PT" dirty="0"/>
+              <a:t> federada existe, mas enfraquece a própria garantia de remoção, baseando-se frequentemente em provas estatísticas em vez de certezas.</a:t>
+            </a:r>
+          </a:p>
+          <a:p>
+            <a:pPr marL="0" marR="0" lvl="0" indent="0" algn="l" defTabSz="914400" rtl="0" eaLnBrk="1" fontAlgn="auto" latinLnBrk="0" hangingPunct="1">
+              <a:lnSpc>
+                <a:spcPct val="100000"/>
+              </a:lnSpc>
+              <a:spcBef>
+                <a:spcPts val="0"/>
+              </a:spcBef>
+              <a:spcAft>
+                <a:spcPts val="0"/>
+              </a:spcAft>
+              <a:buClrTx/>
+              <a:buSzTx/>
+              <a:buFontTx/>
+              <a:buNone/>
+              <a:tabLst/>
+              <a:defRPr/>
+            </a:pPr>
+            <a:endParaRPr lang="pt-PT" sz="1200" i="1" dirty="0">
+              <a:solidFill>
+                <a:srgbClr val="1A2332"/>
+              </a:solidFill>
+              <a:latin typeface="Calibri"/>
+              <a:cs typeface="Calibri"/>
+            </a:endParaRPr>
+          </a:p>
+          <a:p>
+            <a:pPr marL="0" marR="0" lvl="0" indent="0" algn="l" defTabSz="914400" rtl="0" eaLnBrk="1" fontAlgn="auto" latinLnBrk="0" hangingPunct="1">
+              <a:lnSpc>
+                <a:spcPct val="100000"/>
+              </a:lnSpc>
+              <a:spcBef>
+                <a:spcPts val="0"/>
+              </a:spcBef>
+              <a:spcAft>
+                <a:spcPts val="0"/>
+              </a:spcAft>
+              <a:buClrTx/>
+              <a:buSzTx/>
+              <a:buFontTx/>
+              <a:buNone/>
+              <a:tabLst/>
+              <a:defRPr/>
+            </a:pPr>
+            <a:r>
               <a:rPr lang="pt-PT" sz="1200" i="1" dirty="0">
                 <a:solidFill>
                   <a:srgbClr val="1A2332"/>
@@ -1907,7 +3112,7 @@
 </p:notes>
 </file>
 
-<file path=ppt/notesSlides/notesSlide7.xml><?xml version="1.0" encoding="utf-8"?>
+<file path=ppt/notesSlides/notesSlide8.xml><?xml version="1.0" encoding="utf-8"?>
 <p:notes xmlns:a="http://schemas.openxmlformats.org/drawingml/2006/main" xmlns:r="http://schemas.openxmlformats.org/officeDocument/2006/relationships" xmlns:p="http://schemas.openxmlformats.org/presentationml/2006/main">
   <p:cSld>
     <p:spTree>
@@ -1987,6 +3192,97 @@
               <a:defRPr/>
             </a:pPr>
             <a:r>
+              <a:rPr lang="pt-PT" dirty="0"/>
+              <a:t>A lacuna é significativa. A maior parte da investigação sobre </a:t>
+            </a:r>
+            <a:r>
+              <a:rPr lang="pt-PT" i="1" dirty="0" err="1"/>
+              <a:t>unlearning</a:t>
+            </a:r>
+            <a:r>
+              <a:rPr lang="pt-PT" dirty="0"/>
+              <a:t> é desenvolvida em silos. Descobrimos que apenas uma pequena fração dos métodos considera os limites de recursos da </a:t>
+            </a:r>
+            <a:r>
+              <a:rPr lang="pt-PT" i="1" dirty="0" err="1"/>
+              <a:t>edge</a:t>
+            </a:r>
+            <a:r>
+              <a:rPr lang="pt-PT" dirty="0"/>
+              <a:t>, e ainda menos fornecem o tipo de verificação que um regulador aceitaria como um verdadeiro esquecimento.</a:t>
+            </a:r>
+          </a:p>
+          <a:p>
+            <a:pPr marL="0" marR="0" lvl="0" indent="0" algn="l" defTabSz="914400" rtl="0" eaLnBrk="1" fontAlgn="auto" latinLnBrk="0" hangingPunct="1">
+              <a:lnSpc>
+                <a:spcPct val="100000"/>
+              </a:lnSpc>
+              <a:spcBef>
+                <a:spcPts val="0"/>
+              </a:spcBef>
+              <a:spcAft>
+                <a:spcPts val="0"/>
+              </a:spcAft>
+              <a:buClrTx/>
+              <a:buSzTx/>
+              <a:buFontTx/>
+              <a:buNone/>
+              <a:tabLst/>
+              <a:defRPr/>
+            </a:pPr>
+            <a:endParaRPr lang="pt-PT" sz="1200" i="1" dirty="0">
+              <a:solidFill>
+                <a:srgbClr val="1A2332"/>
+              </a:solidFill>
+              <a:latin typeface="Calibri"/>
+              <a:cs typeface="Calibri"/>
+            </a:endParaRPr>
+          </a:p>
+          <a:p>
+            <a:pPr marL="0" marR="0" lvl="0" indent="0" algn="l" defTabSz="914400" rtl="0" eaLnBrk="1" fontAlgn="auto" latinLnBrk="0" hangingPunct="1">
+              <a:lnSpc>
+                <a:spcPct val="100000"/>
+              </a:lnSpc>
+              <a:spcBef>
+                <a:spcPts val="0"/>
+              </a:spcBef>
+              <a:spcAft>
+                <a:spcPts val="0"/>
+              </a:spcAft>
+              <a:buClrTx/>
+              <a:buSzTx/>
+              <a:buFontTx/>
+              <a:buNone/>
+              <a:tabLst/>
+              <a:defRPr/>
+            </a:pPr>
+            <a:endParaRPr lang="pt-PT" sz="1200" i="1" dirty="0">
+              <a:solidFill>
+                <a:srgbClr val="1A2332"/>
+              </a:solidFill>
+              <a:latin typeface="Calibri"/>
+              <a:cs typeface="Calibri"/>
+            </a:endParaRPr>
+          </a:p>
+          <a:p>
+            <a:pPr marL="0" marR="0" lvl="0" indent="0" algn="l" defTabSz="914400" rtl="0" eaLnBrk="1" fontAlgn="auto" latinLnBrk="0" hangingPunct="1">
+              <a:lnSpc>
+                <a:spcPct val="100000"/>
+              </a:lnSpc>
+              <a:spcBef>
+                <a:spcPts val="0"/>
+              </a:spcBef>
+              <a:spcAft>
+                <a:spcPts val="0"/>
+              </a:spcAft>
+              <a:buClrTx/>
+              <a:buSzTx/>
+              <a:buFontTx/>
+              <a:buNone/>
+              <a:tabLst/>
+              <a:defRPr/>
+            </a:pPr>
+            <a:r>
               <a:rPr lang="pt-PT" sz="1200" i="1" dirty="0">
                 <a:solidFill>
                   <a:srgbClr val="1A2332"/>
@@ -2084,7 +3380,7 @@
 </p:notes>
 </file>
 
-<file path=ppt/notesSlides/notesSlide8.xml><?xml version="1.0" encoding="utf-8"?>
+<file path=ppt/notesSlides/notesSlide9.xml><?xml version="1.0" encoding="utf-8"?>
 <p:notes xmlns:a="http://schemas.openxmlformats.org/drawingml/2006/main" xmlns:r="http://schemas.openxmlformats.org/officeDocument/2006/relationships" xmlns:p="http://schemas.openxmlformats.org/presentationml/2006/main">
   <p:cSld>
     <p:spTree>
@@ -2164,164 +3460,26 @@
               <a:defRPr/>
             </a:pPr>
             <a:r>
-              <a:rPr lang="pt-PT" sz="1200" i="1" dirty="0">
-                <a:solidFill>
-                  <a:srgbClr val="1A2332"/>
-                </a:solidFill>
-                <a:latin typeface="Calibri"/>
-                <a:cs typeface="Calibri"/>
-              </a:rPr>
-              <a:t>Sem </a:t>
-            </a:r>
-            <a:r>
-              <a:rPr lang="pt-PT" sz="1200" i="1" dirty="0" err="1">
-                <a:solidFill>
-                  <a:srgbClr val="1A2332"/>
-                </a:solidFill>
-                <a:latin typeface="Calibri"/>
-                <a:cs typeface="Calibri"/>
-              </a:rPr>
-              <a:t>benchmark</a:t>
-            </a:r>
-            <a:r>
-              <a:rPr lang="pt-PT" sz="1200" i="1" dirty="0">
-                <a:solidFill>
-                  <a:srgbClr val="1A2332"/>
-                </a:solidFill>
-                <a:latin typeface="Calibri"/>
-                <a:cs typeface="Calibri"/>
-              </a:rPr>
-              <a:t> partilhado: cada estudo usa as suas próprias métricas, </a:t>
-            </a:r>
-            <a:r>
-              <a:rPr lang="pt-PT" sz="1200" i="1" dirty="0" err="1">
-                <a:solidFill>
-                  <a:srgbClr val="1A2332"/>
-                </a:solidFill>
-                <a:latin typeface="Calibri"/>
-                <a:cs typeface="Calibri"/>
-              </a:rPr>
-              <a:t>datasets</a:t>
-            </a:r>
-            <a:r>
-              <a:rPr lang="pt-PT" sz="1200" i="1" dirty="0">
-                <a:solidFill>
-                  <a:srgbClr val="1A2332"/>
-                </a:solidFill>
-                <a:latin typeface="Calibri"/>
-                <a:cs typeface="Calibri"/>
-              </a:rPr>
-              <a:t> e modelos de ameaça — impossível comparar soluções parciais.</a:t>
-            </a:r>
-          </a:p>
-          <a:p>
-            <a:endParaRPr lang="pt-PT" dirty="0"/>
-          </a:p>
-        </p:txBody>
-      </p:sp>
-      <p:sp>
-        <p:nvSpPr>
-          <p:cNvPr id="4" name="Marcador de Posição do Número do Diapositivo 3">
-            <a:extLst>
-              <a:ext uri="{FF2B5EF4-FFF2-40B4-BE49-F238E27FC236}">
-                <a16:creationId xmlns:a16="http://schemas.microsoft.com/office/drawing/2014/main" id="{68CD6910-FC17-5FCD-3A29-54D5911C2C5F}"/>
-              </a:ext>
-            </a:extLst>
-          </p:cNvPr>
-          <p:cNvSpPr>
-            <a:spLocks noGrp="1"/>
-          </p:cNvSpPr>
-          <p:nvPr>
-            <p:ph type="sldNum" sz="quarter" idx="5"/>
-          </p:nvPr>
-        </p:nvSpPr>
-        <p:spPr/>
-        <p:txBody>
-          <a:bodyPr/>
-          <a:lstStyle/>
-          <a:p>
-            <a:fld id="{4BEEEA3F-08CE-6043-AB76-D392B1207876}" type="slidenum">
-              <a:rPr lang="pt-PT" smtClean="0"/>
-              <a:t>9</a:t>
-            </a:fld>
-            <a:endParaRPr lang="pt-PT"/>
-          </a:p>
-        </p:txBody>
-      </p:sp>
-    </p:spTree>
-    <p:extLst>
-      <p:ext uri="{BB962C8B-B14F-4D97-AF65-F5344CB8AC3E}">
-        <p14:creationId xmlns:p14="http://schemas.microsoft.com/office/powerpoint/2010/main" val="3891899684"/>
-      </p:ext>
-    </p:extLst>
-  </p:cSld>
-  <p:clrMapOvr>
-    <a:masterClrMapping/>
-  </p:clrMapOvr>
-</p:notes>
-</file>
-
-<file path=ppt/notesSlides/notesSlide9.xml><?xml version="1.0" encoding="utf-8"?>
-<p:notes xmlns:a="http://schemas.openxmlformats.org/drawingml/2006/main" xmlns:r="http://schemas.openxmlformats.org/officeDocument/2006/relationships" xmlns:p="http://schemas.openxmlformats.org/presentationml/2006/main">
-  <p:cSld>
-    <p:spTree>
-      <p:nvGrpSpPr>
-        <p:cNvPr id="1" name="">
-          <a:extLst>
-            <a:ext uri="{FF2B5EF4-FFF2-40B4-BE49-F238E27FC236}">
-              <a16:creationId xmlns:a16="http://schemas.microsoft.com/office/drawing/2014/main" id="{1F8B1AD9-2478-B77F-D2D6-4338A5314A25}"/>
-            </a:ext>
-          </a:extLst>
-        </p:cNvPr>
-        <p:cNvGrpSpPr/>
-        <p:nvPr/>
-      </p:nvGrpSpPr>
-      <p:grpSpPr>
-        <a:xfrm>
-          <a:off x="0" y="0"/>
-          <a:ext cx="0" cy="0"/>
-          <a:chOff x="0" y="0"/>
-          <a:chExt cx="0" cy="0"/>
-        </a:xfrm>
-      </p:grpSpPr>
-      <p:sp>
-        <p:nvSpPr>
-          <p:cNvPr id="2" name="Marcador de Posição da Imagem do Diapositivo 1">
-            <a:extLst>
-              <a:ext uri="{FF2B5EF4-FFF2-40B4-BE49-F238E27FC236}">
-                <a16:creationId xmlns:a16="http://schemas.microsoft.com/office/drawing/2014/main" id="{16F87413-56CC-DEE7-3553-988D37435D19}"/>
-              </a:ext>
-            </a:extLst>
-          </p:cNvPr>
-          <p:cNvSpPr>
-            <a:spLocks noGrp="1" noRot="1" noChangeAspect="1"/>
-          </p:cNvSpPr>
-          <p:nvPr>
-            <p:ph type="sldImg"/>
-          </p:nvPr>
-        </p:nvSpPr>
-        <p:spPr/>
-      </p:sp>
-      <p:sp>
-        <p:nvSpPr>
-          <p:cNvPr id="3" name="Marcador de Posição de Notas 2">
-            <a:extLst>
-              <a:ext uri="{FF2B5EF4-FFF2-40B4-BE49-F238E27FC236}">
-                <a16:creationId xmlns:a16="http://schemas.microsoft.com/office/drawing/2014/main" id="{F8B268EE-26D4-B3A7-8374-D6C283F192F2}"/>
-              </a:ext>
-            </a:extLst>
-          </p:cNvPr>
-          <p:cNvSpPr>
-            <a:spLocks noGrp="1"/>
-          </p:cNvSpPr>
-          <p:nvPr>
-            <p:ph type="body" idx="1"/>
-          </p:nvPr>
-        </p:nvSpPr>
-        <p:spPr/>
-        <p:txBody>
-          <a:bodyPr/>
-          <a:lstStyle/>
+              <a:rPr lang="pt-PT" dirty="0"/>
+              <a:t>A lacuna é significativa. A maior parte da investigação sobre </a:t>
+            </a:r>
+            <a:r>
+              <a:rPr lang="pt-PT" i="1" dirty="0" err="1"/>
+              <a:t>unlearning</a:t>
+            </a:r>
+            <a:r>
+              <a:rPr lang="pt-PT" dirty="0"/>
+              <a:t> é desenvolvida em silos. Descobrimos que apenas uma pequena fração dos métodos considera os limites de recursos da </a:t>
+            </a:r>
+            <a:r>
+              <a:rPr lang="pt-PT" i="1" dirty="0" err="1"/>
+              <a:t>edge</a:t>
+            </a:r>
+            <a:r>
+              <a:rPr lang="pt-PT" dirty="0"/>
+              <a:t>, e ainda menos fornecem o tipo de verificação que um regulador aceitaria como um verdadeiro esquecimento.</a:t>
+            </a:r>
+          </a:p>
           <a:p>
             <a:pPr marL="0" marR="0" lvl="0" indent="0" algn="l" defTabSz="914400" rtl="0" eaLnBrk="1" fontAlgn="auto" latinLnBrk="0" hangingPunct="1">
               <a:lnSpc>
@@ -2340,6 +3498,58 @@
               <a:tabLst/>
               <a:defRPr/>
             </a:pPr>
+            <a:endParaRPr lang="pt-PT" sz="1200" i="1" dirty="0">
+              <a:solidFill>
+                <a:srgbClr val="1A2332"/>
+              </a:solidFill>
+              <a:latin typeface="Calibri"/>
+              <a:cs typeface="Calibri"/>
+            </a:endParaRPr>
+          </a:p>
+          <a:p>
+            <a:pPr marL="0" marR="0" lvl="0" indent="0" algn="l" defTabSz="914400" rtl="0" eaLnBrk="1" fontAlgn="auto" latinLnBrk="0" hangingPunct="1">
+              <a:lnSpc>
+                <a:spcPct val="100000"/>
+              </a:lnSpc>
+              <a:spcBef>
+                <a:spcPts val="0"/>
+              </a:spcBef>
+              <a:spcAft>
+                <a:spcPts val="0"/>
+              </a:spcAft>
+              <a:buClrTx/>
+              <a:buSzTx/>
+              <a:buFontTx/>
+              <a:buNone/>
+              <a:tabLst/>
+              <a:defRPr/>
+            </a:pPr>
+            <a:endParaRPr lang="pt-PT" sz="1200" i="1" dirty="0">
+              <a:solidFill>
+                <a:srgbClr val="1A2332"/>
+              </a:solidFill>
+              <a:latin typeface="Calibri"/>
+              <a:cs typeface="Calibri"/>
+            </a:endParaRPr>
+          </a:p>
+          <a:p>
+            <a:pPr marL="0" marR="0" lvl="0" indent="0" algn="l" defTabSz="914400" rtl="0" eaLnBrk="1" fontAlgn="auto" latinLnBrk="0" hangingPunct="1">
+              <a:lnSpc>
+                <a:spcPct val="100000"/>
+              </a:lnSpc>
+              <a:spcBef>
+                <a:spcPts val="0"/>
+              </a:spcBef>
+              <a:spcAft>
+                <a:spcPts val="0"/>
+              </a:spcAft>
+              <a:buClrTx/>
+              <a:buSzTx/>
+              <a:buFontTx/>
+              <a:buNone/>
+              <a:tabLst/>
+              <a:defRPr/>
+            </a:pPr>
             <a:r>
               <a:rPr lang="pt-PT" sz="1200" i="1" dirty="0">
                 <a:solidFill>
@@ -2401,7 +3611,7 @@
           <p:cNvPr id="4" name="Marcador de Posição do Número do Diapositivo 3">
             <a:extLst>
               <a:ext uri="{FF2B5EF4-FFF2-40B4-BE49-F238E27FC236}">
-                <a16:creationId xmlns:a16="http://schemas.microsoft.com/office/drawing/2014/main" id="{1F1BE4FF-EEA4-2EC9-BDAC-87370AA99461}"/>
+                <a16:creationId xmlns:a16="http://schemas.microsoft.com/office/drawing/2014/main" id="{68CD6910-FC17-5FCD-3A29-54D5911C2C5F}"/>
               </a:ext>
             </a:extLst>
           </p:cNvPr>
@@ -2419,7 +3629,7 @@
           <a:p>
             <a:fld id="{4BEEEA3F-08CE-6043-AB76-D392B1207876}" type="slidenum">
               <a:rPr lang="pt-PT" smtClean="0"/>
-              <a:t>10</a:t>
+              <a:t>9</a:t>
             </a:fld>
             <a:endParaRPr lang="pt-PT"/>
           </a:p>
@@ -2428,7 +3638,7 @@
     </p:spTree>
     <p:extLst>
       <p:ext uri="{BB962C8B-B14F-4D97-AF65-F5344CB8AC3E}">
-        <p14:creationId xmlns:p14="http://schemas.microsoft.com/office/powerpoint/2010/main" val="3361521210"/>
+        <p14:creationId xmlns:p14="http://schemas.microsoft.com/office/powerpoint/2010/main" val="3891899684"/>
       </p:ext>
     </p:extLst>
   </p:cSld>
@@ -2585,7 +3795,7 @@
           <a:p>
             <a:fld id="{A8FD5399-E005-4D46-A3BC-4F04C5B9BCCE}" type="datetimeFigureOut">
               <a:rPr lang="pt-PT" smtClean="0"/>
-              <a:t>25/05/26</a:t>
+              <a:t>29/05/26</a:t>
             </a:fld>
             <a:endParaRPr lang="pt-PT"/>
           </a:p>
@@ -2783,7 +3993,7 @@
           <a:p>
             <a:fld id="{A8FD5399-E005-4D46-A3BC-4F04C5B9BCCE}" type="datetimeFigureOut">
               <a:rPr lang="pt-PT" smtClean="0"/>
-              <a:t>25/05/26</a:t>
+              <a:t>29/05/26</a:t>
             </a:fld>
             <a:endParaRPr lang="pt-PT"/>
           </a:p>
@@ -2991,7 +4201,7 @@
           <a:p>
             <a:fld id="{A8FD5399-E005-4D46-A3BC-4F04C5B9BCCE}" type="datetimeFigureOut">
               <a:rPr lang="pt-PT" smtClean="0"/>
-              <a:t>25/05/26</a:t>
+              <a:t>29/05/26</a:t>
             </a:fld>
             <a:endParaRPr lang="pt-PT"/>
           </a:p>
@@ -3189,7 +4399,7 @@
           <a:p>
             <a:fld id="{A8FD5399-E005-4D46-A3BC-4F04C5B9BCCE}" type="datetimeFigureOut">
               <a:rPr lang="pt-PT" smtClean="0"/>
-              <a:t>25/05/26</a:t>
+              <a:t>29/05/26</a:t>
             </a:fld>
             <a:endParaRPr lang="pt-PT"/>
           </a:p>
@@ -3464,7 +4674,7 @@
           <a:p>
             <a:fld id="{A8FD5399-E005-4D46-A3BC-4F04C5B9BCCE}" type="datetimeFigureOut">
               <a:rPr lang="pt-PT" smtClean="0"/>
-              <a:t>25/05/26</a:t>
+              <a:t>29/05/26</a:t>
             </a:fld>
             <a:endParaRPr lang="pt-PT"/>
           </a:p>
@@ -3729,7 +4939,7 @@
           <a:p>
             <a:fld id="{A8FD5399-E005-4D46-A3BC-4F04C5B9BCCE}" type="datetimeFigureOut">
               <a:rPr lang="pt-PT" smtClean="0"/>
-              <a:t>25/05/26</a:t>
+              <a:t>29/05/26</a:t>
             </a:fld>
             <a:endParaRPr lang="pt-PT"/>
           </a:p>
@@ -4141,7 +5351,7 @@
           <a:p>
             <a:fld id="{A8FD5399-E005-4D46-A3BC-4F04C5B9BCCE}" type="datetimeFigureOut">
               <a:rPr lang="pt-PT" smtClean="0"/>
-              <a:t>25/05/26</a:t>
+              <a:t>29/05/26</a:t>
             </a:fld>
             <a:endParaRPr lang="pt-PT"/>
           </a:p>
@@ -4282,7 +5492,7 @@
           <a:p>
             <a:fld id="{A8FD5399-E005-4D46-A3BC-4F04C5B9BCCE}" type="datetimeFigureOut">
               <a:rPr lang="pt-PT" smtClean="0"/>
-              <a:t>25/05/26</a:t>
+              <a:t>29/05/26</a:t>
             </a:fld>
             <a:endParaRPr lang="pt-PT"/>
           </a:p>
@@ -4395,7 +5605,7 @@
           <a:p>
             <a:fld id="{A8FD5399-E005-4D46-A3BC-4F04C5B9BCCE}" type="datetimeFigureOut">
               <a:rPr lang="pt-PT" smtClean="0"/>
-              <a:t>25/05/26</a:t>
+              <a:t>29/05/26</a:t>
             </a:fld>
             <a:endParaRPr lang="pt-PT"/>
           </a:p>
@@ -4706,7 +5916,7 @@
           <a:p>
             <a:fld id="{A8FD5399-E005-4D46-A3BC-4F04C5B9BCCE}" type="datetimeFigureOut">
               <a:rPr lang="pt-PT" smtClean="0"/>
-              <a:t>25/05/26</a:t>
+              <a:t>29/05/26</a:t>
             </a:fld>
             <a:endParaRPr lang="pt-PT"/>
           </a:p>
@@ -4994,7 +6204,7 @@
           <a:p>
             <a:fld id="{A8FD5399-E005-4D46-A3BC-4F04C5B9BCCE}" type="datetimeFigureOut">
               <a:rPr lang="pt-PT" smtClean="0"/>
-              <a:t>25/05/26</a:t>
+              <a:t>29/05/26</a:t>
             </a:fld>
             <a:endParaRPr lang="pt-PT"/>
           </a:p>
@@ -5238,7 +6448,7 @@
           <a:p>
             <a:fld id="{A8FD5399-E005-4D46-A3BC-4F04C5B9BCCE}" type="datetimeFigureOut">
               <a:rPr lang="pt-PT" smtClean="0"/>
-              <a:t>25/05/26</a:t>
+              <a:t>29/05/26</a:t>
             </a:fld>
             <a:endParaRPr lang="pt-PT"/>
           </a:p>
@@ -14306,7 +15516,7 @@
               <a:rPr lang="pt-PT" sz="1600" b="0" dirty="0">
                 <a:latin typeface="+mn-lt"/>
               </a:rPr>
-              <a:t>Nenhum método atual satisfaz o envelope completo de restrições</a:t>
+              <a:t>Nenhum método atual satisfaz o leque completo de restrições</a:t>
             </a:r>
           </a:p>
         </p:txBody>

</xml_diff>

<commit_message>
Commit from thinkpad on 02/06/2026, 16:24:18
</commit_message>
<xml_diff>
--- a/Entregas PhD/machine-unlearning.pptx
+++ b/Entregas PhD/machine-unlearning.pptx
@@ -910,7 +910,7 @@
             </a:r>
             <a:r>
               <a:rPr lang="pt-PT" dirty="0"/>
-              <a:t> Precisamos de "</a:t>
+              <a:t> Tem de ser avançar para "</a:t>
             </a:r>
             <a:r>
               <a:rPr lang="pt-PT" i="1" dirty="0" err="1"/>
@@ -942,15 +942,11 @@
             </a:r>
             <a:r>
               <a:rPr lang="pt-PT" dirty="0"/>
-              <a:t> para realizar o apagamento diretamente no </a:t>
+              <a:t> para realizar o esquecimento diretamente </a:t>
             </a:r>
             <a:r>
               <a:rPr lang="pt-PT" i="1" dirty="0"/>
-              <a:t>hardware</a:t>
-            </a:r>
-            <a:r>
-              <a:rPr lang="pt-PT" dirty="0"/>
-              <a:t> da </a:t>
+              <a:t>na </a:t>
             </a:r>
             <a:r>
               <a:rPr lang="pt-PT" i="1" dirty="0" err="1"/>
@@ -968,15 +964,25 @@
             </a:r>
             <a:r>
               <a:rPr lang="pt-PT" dirty="0"/>
-              <a:t> Precisamos de mais do que apenas um "confie em mim" de um fornecedor. Precisamos de certificados e de </a:t>
+              <a:t> É necessário mais do que apenas um "confie em mim" de um fornecedor. Precisamos de certificados e de </a:t>
             </a:r>
             <a:r>
               <a:rPr lang="pt-PT" i="1" dirty="0"/>
-              <a:t>Zero-</a:t>
+              <a:t>provas de esquecimento </a:t>
+            </a:r>
+            <a:r>
+              <a:rPr lang="pt-PT" dirty="0"/>
+              <a:t>para certificar aos residentes e reguladores que a influência dos seus dados desapareceu verdadeiramente.</a:t>
+            </a:r>
+          </a:p>
+          <a:p>
+            <a:r>
+              <a:rPr lang="pt-PT" dirty="0"/>
+              <a:t>Para concluir, o </a:t>
             </a:r>
             <a:r>
               <a:rPr lang="pt-PT" i="1" dirty="0" err="1"/>
-              <a:t>Knowledge</a:t>
+              <a:t>machine</a:t>
             </a:r>
             <a:r>
               <a:rPr lang="pt-PT" i="1" dirty="0"/>
@@ -984,37 +990,11 @@
             </a:r>
             <a:r>
               <a:rPr lang="pt-PT" i="1" dirty="0" err="1"/>
-              <a:t>Proofs</a:t>
-            </a:r>
-            <a:r>
-              <a:rPr lang="pt-PT" i="1" dirty="0"/>
-              <a:t> </a:t>
+              <a:t>unlearning</a:t>
             </a:r>
             <a:r>
               <a:rPr lang="pt-PT" dirty="0"/>
-              <a:t>para certificar aos residentes e reguladores que a influência dos seus dados desapareceu verdadeiramente.</a:t>
-            </a:r>
-          </a:p>
-          <a:p>
-            <a:r>
-              <a:rPr lang="pt-PT" dirty="0"/>
-              <a:t>Para concluir, o </a:t>
-            </a:r>
-            <a:r>
-              <a:rPr lang="pt-PT" i="1" dirty="0" err="1"/>
-              <a:t>machine</a:t>
-            </a:r>
-            <a:r>
-              <a:rPr lang="pt-PT" i="1" dirty="0"/>
-              <a:t> </a:t>
-            </a:r>
-            <a:r>
-              <a:rPr lang="pt-PT" i="1" dirty="0" err="1"/>
-              <a:t>unlearning</a:t>
-            </a:r>
-            <a:r>
-              <a:rPr lang="pt-PT" dirty="0"/>
-              <a:t> em edifícios inteligentes não é apenas um problema académico — é uma necessidade regulatória. Precisamos de passar de métodos centrados na </a:t>
+              <a:t> em edifícios inteligentes não é apenas um problema académico — é uma necessidade regulatória, ou seja, é necessário que as entidades de ambas as matérias se alinhe. Precisamos de passar de métodos centrados na </a:t>
             </a:r>
             <a:r>
               <a:rPr lang="pt-PT" i="1" dirty="0" err="1"/>
@@ -1023,6 +1003,57 @@
             <a:r>
               <a:rPr lang="pt-PT" dirty="0"/>
               <a:t> para sistemas distribuídos e verificáveis. </a:t>
+            </a:r>
+          </a:p>
+          <a:p>
+            <a:endParaRPr lang="pt-PT" dirty="0"/>
+          </a:p>
+          <a:p>
+            <a:r>
+              <a:rPr lang="pt-PT" dirty="0"/>
+              <a:t>Para a minha tese, tendo em consideração estes problemas, o que planeei foi passar pela minimização da partilha de dados. Os modelos que correm num </a:t>
+            </a:r>
+            <a:r>
+              <a:rPr lang="pt-PT" dirty="0" err="1"/>
+              <a:t>edíficio</a:t>
+            </a:r>
+            <a:r>
+              <a:rPr lang="pt-PT" dirty="0"/>
+              <a:t> são treinados apenas pelos dados dos residentes nesses </a:t>
+            </a:r>
+            <a:r>
+              <a:rPr lang="pt-PT" dirty="0" err="1"/>
+              <a:t>edíficios</a:t>
+            </a:r>
+            <a:r>
+              <a:rPr lang="pt-PT" dirty="0"/>
+              <a:t>. O problema real acontece na partilha dos dados, que como vimos não temos garantias de depois os esquecer, no entanto essa partilha tem de ser explicita.</a:t>
+            </a:r>
+            <a:br>
+              <a:rPr lang="pt-PT" dirty="0"/>
+            </a:br>
+            <a:br>
+              <a:rPr lang="pt-PT" dirty="0"/>
+            </a:br>
+            <a:r>
+              <a:rPr lang="pt-PT" dirty="0"/>
+              <a:t>É importante também referir que a maneira como resolvemos o problema do esquecimento, depende muito de como o </a:t>
+            </a:r>
+            <a:r>
+              <a:rPr lang="pt-PT" dirty="0" err="1"/>
+              <a:t>machine</a:t>
+            </a:r>
+            <a:r>
+              <a:rPr lang="pt-PT" dirty="0"/>
+              <a:t> </a:t>
+            </a:r>
+            <a:r>
+              <a:rPr lang="pt-PT" dirty="0" err="1"/>
+              <a:t>unlearning</a:t>
+            </a:r>
+            <a:r>
+              <a:rPr lang="pt-PT" dirty="0"/>
+              <a:t> evoluir. Este campo não é o mesmo que era há 10 anos e, com grande probabilidade não vai ser o mesmo nos próximos.</a:t>
             </a:r>
           </a:p>
           <a:p>
@@ -1132,7 +1163,7 @@
             </a:pPr>
             <a:r>
               <a:rPr lang="pt-PT" dirty="0"/>
-              <a:t>Os edifícios inteligentes são, essencialmente, ecossistemas de sensores. Estes dispositivos geram pegadas do nosso comportamento. Embora isto otimize o conforto e a energia, cria uma pegada digital massiva. Mesmo que eliminemos os dados em bruto, os modelos treinados com eles retêm vestígios que podem ser explorados.</a:t>
+              <a:t>Os edifícios inteligentes são, essencialmente, ecossistemas de sensores. Estes dispositivos geram pegadas do nosso comportamento. Embora isto otimize o conforto e a energia, cria uma grande pegada digital. Mesmo que eliminemos os dados em bruto, os modelos treinados retêm na mesma vestígios que podem ser explorados.</a:t>
             </a:r>
           </a:p>
           <a:p>
@@ -1175,7 +1206,7 @@
             </a:pPr>
             <a:r>
               <a:rPr lang="pt-PT" dirty="0"/>
-              <a:t>O Artigo 17.º do RGPD, o "Direito ao Esquecimento", exige que as organizações não só eliminem os registos em bruto, mas também qualquer influência derivada.</a:t>
+              <a:t>O Artigo 17.º do RGPD, o "Direito ao Esquecimento", exige que as organizações não só eliminem os registos em bruto, mas também qualquer influência derivada destes dados.</a:t>
             </a:r>
           </a:p>
           <a:p>
@@ -1298,7 +1329,7 @@
             </a:r>
             <a:r>
               <a:rPr lang="pt-PT" dirty="0"/>
-              <a:t> como a resposta isto — é o processo de remover seletivamente a influência dos dados.</a:t>
+              <a:t> como a resposta isto, ou seja o processo de remover seletivamente a influência dos dados.</a:t>
             </a:r>
           </a:p>
           <a:p>
@@ -2043,15 +2074,7 @@
             </a:r>
             <a:r>
               <a:rPr lang="pt-PT" dirty="0"/>
-              <a:t> esquecer, mas o </a:t>
-            </a:r>
-            <a:r>
-              <a:rPr lang="pt-PT" i="1" dirty="0" err="1"/>
-              <a:t>gateway</a:t>
-            </a:r>
-            <a:r>
-              <a:rPr lang="pt-PT" dirty="0"/>
-              <a:t> na </a:t>
+              <a:t> esquecer, mas a </a:t>
             </a:r>
             <a:r>
               <a:rPr lang="pt-PT" i="1" dirty="0" err="1"/>
@@ -2709,7 +2732,7 @@
             </a:r>
             <a:r>
               <a:rPr lang="pt-PT" dirty="0"/>
-              <a:t> a solução é rápida, mas ignora a hierarquia de múltiplos inquilinos. A </a:t>
+              <a:t> a solução é rápida, mas ignora a hierarquia de múltiplos residentes. A </a:t>
             </a:r>
             <a:r>
               <a:rPr lang="pt-PT" dirty="0" err="1"/>
@@ -2717,7 +2740,7 @@
             </a:r>
             <a:r>
               <a:rPr lang="pt-PT" dirty="0"/>
-              <a:t> federada existe, mas enfraquece a própria garantia de "apagamento", baseando-se frequentemente em provas estatísticas em vez de certezas.</a:t>
+              <a:t> federada existe, mas enfraquece a própria garantia de "esquecimento", baseando-se frequentemente em provas estatísticas em vez de certezas.</a:t>
             </a:r>
           </a:p>
           <a:p>
@@ -2911,6 +2934,29 @@
         <p:txBody>
           <a:bodyPr/>
           <a:lstStyle/>
+          <a:p>
+            <a:pPr marL="0" marR="0" lvl="0" indent="0" algn="l" defTabSz="914400" rtl="0" eaLnBrk="1" fontAlgn="auto" latinLnBrk="0" hangingPunct="1">
+              <a:lnSpc>
+                <a:spcPct val="100000"/>
+              </a:lnSpc>
+              <a:spcBef>
+                <a:spcPts val="0"/>
+              </a:spcBef>
+              <a:spcAft>
+                <a:spcPts val="0"/>
+              </a:spcAft>
+              <a:buClrTx/>
+              <a:buSzTx/>
+              <a:buFontTx/>
+              <a:buNone/>
+              <a:tabLst/>
+              <a:defRPr/>
+            </a:pPr>
+            <a:r>
+              <a:rPr lang="pt-PT" dirty="0"/>
+              <a:t>NAO ESQUCER DE PASSAR PARA A FRENTE</a:t>
+            </a:r>
+          </a:p>
           <a:p>
             <a:pPr marL="0" marR="0" lvl="0" indent="0" algn="l" defTabSz="914400" rtl="0" eaLnBrk="1" fontAlgn="auto" latinLnBrk="0" hangingPunct="1">
               <a:lnSpc>
@@ -7112,7 +7158,7 @@
                 <a:latin typeface="Calibri"/>
                 <a:cs typeface="Calibri"/>
               </a:rPr>
-              <a:t>Restrições operacionais, lacunas dos métodos atuais e oportunidades de investigação</a:t>
+              <a:t>Restrições operacionais, lacunas dos métodos atuais e oportunidades/direções de investigação</a:t>
             </a:r>
           </a:p>
         </p:txBody>

</xml_diff>